<commit_message>
docs: update soutenance deck with measured RAGAS results
</commit_message>
<xml_diff>
--- a/outputs/openagenda-rag-soutenance.pptx
+++ b/outputs/openagenda-rag-soutenance.pptx
@@ -2,27 +2,27 @@
 <file path=ppt/presentation.xml><?xml version="1.0" encoding="utf-8"?>
 <p:presentation xmlns:p="http://schemas.openxmlformats.org/presentationml/2006/main">
   <p:sldMasterIdLst>
-    <p:sldMasterId xmlns:r="http://schemas.openxmlformats.org/officeDocument/2006/relationships" id="2147483648" r:id="R4071a02056bf45c8"/>
+    <p:sldMasterId xmlns:r="http://schemas.openxmlformats.org/officeDocument/2006/relationships" id="2147483648" r:id="R3bec24a006d94845"/>
   </p:sldMasterIdLst>
   <p:notesMasterIdLst>
-    <p:notesMasterId xmlns:r="http://schemas.openxmlformats.org/officeDocument/2006/relationships" r:id="R93677ca16e984225"/>
+    <p:notesMasterId xmlns:r="http://schemas.openxmlformats.org/officeDocument/2006/relationships" r:id="R35ceb18aa94241b0"/>
   </p:notesMasterIdLst>
   <p:sldIdLst>
-    <p:sldId xmlns:r="http://schemas.openxmlformats.org/officeDocument/2006/relationships" id="256" r:id="Rd72eb9b6eaf24f50"/>
-    <p:sldId xmlns:r="http://schemas.openxmlformats.org/officeDocument/2006/relationships" id="257" r:id="Rddf63683f0054bc4"/>
-    <p:sldId xmlns:r="http://schemas.openxmlformats.org/officeDocument/2006/relationships" id="258" r:id="Rb2b6f1d0663842e7"/>
-    <p:sldId xmlns:r="http://schemas.openxmlformats.org/officeDocument/2006/relationships" id="259" r:id="R5d951067a262499a"/>
-    <p:sldId xmlns:r="http://schemas.openxmlformats.org/officeDocument/2006/relationships" id="260" r:id="Rc31b81ac4b6b4239"/>
-    <p:sldId xmlns:r="http://schemas.openxmlformats.org/officeDocument/2006/relationships" id="261" r:id="Rc8921de810d2453d"/>
-    <p:sldId xmlns:r="http://schemas.openxmlformats.org/officeDocument/2006/relationships" id="262" r:id="R4e1cdb065a8942d7"/>
-    <p:sldId xmlns:r="http://schemas.openxmlformats.org/officeDocument/2006/relationships" id="263" r:id="R7cbcbaa9b6eb467c"/>
-    <p:sldId xmlns:r="http://schemas.openxmlformats.org/officeDocument/2006/relationships" id="264" r:id="R0dcfa5e028c04da7"/>
-    <p:sldId xmlns:r="http://schemas.openxmlformats.org/officeDocument/2006/relationships" id="265" r:id="Rfe0e6b4dd8ac417c"/>
-    <p:sldId xmlns:r="http://schemas.openxmlformats.org/officeDocument/2006/relationships" id="266" r:id="Re5b8a5eb882941ef"/>
-    <p:sldId xmlns:r="http://schemas.openxmlformats.org/officeDocument/2006/relationships" id="267" r:id="Rc6c7163d6ccc404f"/>
-    <p:sldId xmlns:r="http://schemas.openxmlformats.org/officeDocument/2006/relationships" id="268" r:id="R3be87fe429054dd0"/>
-    <p:sldId xmlns:r="http://schemas.openxmlformats.org/officeDocument/2006/relationships" id="269" r:id="R0092d5832a8f41e2"/>
-    <p:sldId xmlns:r="http://schemas.openxmlformats.org/officeDocument/2006/relationships" id="270" r:id="R20eedbf3eaa04127"/>
+    <p:sldId xmlns:r="http://schemas.openxmlformats.org/officeDocument/2006/relationships" id="256" r:id="Ra9700f4774c74e40"/>
+    <p:sldId xmlns:r="http://schemas.openxmlformats.org/officeDocument/2006/relationships" id="257" r:id="R0b5724cc13ec42d8"/>
+    <p:sldId xmlns:r="http://schemas.openxmlformats.org/officeDocument/2006/relationships" id="258" r:id="Re0541d774b1f490d"/>
+    <p:sldId xmlns:r="http://schemas.openxmlformats.org/officeDocument/2006/relationships" id="259" r:id="R042d9643f4894980"/>
+    <p:sldId xmlns:r="http://schemas.openxmlformats.org/officeDocument/2006/relationships" id="260" r:id="R322560d5e3cb485b"/>
+    <p:sldId xmlns:r="http://schemas.openxmlformats.org/officeDocument/2006/relationships" id="261" r:id="R03e626d27f7c461b"/>
+    <p:sldId xmlns:r="http://schemas.openxmlformats.org/officeDocument/2006/relationships" id="262" r:id="R36197e68d3d84cfc"/>
+    <p:sldId xmlns:r="http://schemas.openxmlformats.org/officeDocument/2006/relationships" id="263" r:id="Re8dd90425759474b"/>
+    <p:sldId xmlns:r="http://schemas.openxmlformats.org/officeDocument/2006/relationships" id="264" r:id="R06a93d5ebdba498f"/>
+    <p:sldId xmlns:r="http://schemas.openxmlformats.org/officeDocument/2006/relationships" id="265" r:id="R255535622d2d486a"/>
+    <p:sldId xmlns:r="http://schemas.openxmlformats.org/officeDocument/2006/relationships" id="266" r:id="Re2dbc08ceb1744c2"/>
+    <p:sldId xmlns:r="http://schemas.openxmlformats.org/officeDocument/2006/relationships" id="267" r:id="Re3bceb5d977a421c"/>
+    <p:sldId xmlns:r="http://schemas.openxmlformats.org/officeDocument/2006/relationships" id="268" r:id="R9e97aac43b5f4796"/>
+    <p:sldId xmlns:r="http://schemas.openxmlformats.org/officeDocument/2006/relationships" id="269" r:id="R4816d2fcef2644e2"/>
+    <p:sldId xmlns:r="http://schemas.openxmlformats.org/officeDocument/2006/relationships" id="270" r:id="R1cbdab027e30448d"/>
   </p:sldIdLst>
   <p:sldSz cx="12192000" cy="6858000"/>
   <p:notesSz cx="6858000" cy="9144000"/>
@@ -1539,7 +1539,7 @@
   </p:cSld>
   <p:clrMap bg1="lt1" tx1="dk1" bg2="lt2" tx2="dk2" accent1="accent1" accent2="accent2" accent3="accent3" accent4="accent4" accent5="accent5" accent6="accent6" hlink="hlink" folHlink="folHlink"/>
   <p:sldLayoutIdLst>
-    <p:sldLayoutId xmlns:r="http://schemas.openxmlformats.org/officeDocument/2006/relationships" id="2147483649" r:id="R9fe39ea40b9d4baf"/>
+    <p:sldLayoutId xmlns:r="http://schemas.openxmlformats.org/officeDocument/2006/relationships" id="2147483649" r:id="R774d2d2c2c0c474c"/>
   </p:sldLayoutIdLst>
   <p:txStyles>
     <p:titleStyle>
@@ -2319,7 +2319,7 @@
                   <a:srgbClr val="2E6F73"/>
                 </a:solidFill>
               </a:rPr>
-              <a:t>Soutenance - 10 juillet 2026</a:t>
+              <a:t>Soutenance — juillet 2026</a:t>
             </a:r>
           </a:p>
         </p:txBody>
@@ -2723,7 +2723,7 @@
                   <a:srgbClr val="132A3A"/>
                 </a:solidFill>
               </a:rPr>
-              <a:t>Scenario 2 - Parle-moi de SALON DE LA PHOTO a Paris</a:t>
+              <a:t>Démo cas limite — une demande hors périmètre</a:t>
             </a:r>
           </a:p>
         </p:txBody>
@@ -2774,7 +2774,7 @@
                   <a:srgbClr val="5F6B73"/>
                 </a:solidFill>
               </a:rPr>
-              <a:t>Question precise sur un evenement photo reel et stable du corpus livre.</a:t>
+              <a:t>Le corpus Paris ne doit pas inventer d'exposition photo à Lyon.</a:t>
             </a:r>
           </a:p>
         </p:txBody>
@@ -2860,7 +2860,7 @@
                   <a:srgbClr val="132A3A"/>
                 </a:solidFill>
               </a:rPr>
-              <a:t>Question</a:t>
+              <a:t>Question posée</a:t>
             </a:r>
           </a:p>
         </p:txBody>
@@ -2911,7 +2911,7 @@
                   <a:srgbClr val="132A3A"/>
                 </a:solidFill>
               </a:rPr>
-              <a:t>Parle-moi de SALON DE LA PHOTO a Paris</a:t>
+              <a:t>Quelles expositions photo a Lyon ?</a:t>
             </a:r>
           </a:p>
         </p:txBody>
@@ -2997,7 +2997,7 @@
                   <a:srgbClr val="132A3A"/>
                 </a:solidFill>
               </a:rPr>
-              <a:t>Observation</a:t>
+              <a:t>Résultat observé</a:t>
             </a:r>
           </a:p>
         </p:txBody>
@@ -3048,7 +3048,7 @@
                   <a:srgbClr val="132A3A"/>
                 </a:solidFill>
               </a:rPr>
-              <a:t>• reponse stable avec date, lieu et URL</a:t>
+              <a:t>• réponse explicite : « Je ne sais pas »</a:t>
             </a:r>
           </a:p>
           <a:p xmlns:a="http://schemas.openxmlformats.org/drawingml/2006/main">
@@ -3066,7 +3066,7 @@
                   <a:srgbClr val="132A3A"/>
                 </a:solidFill>
               </a:rPr>
-              <a:t>• source principale: SALON DE LA PHOTO</a:t>
+              <a:t>• aucun événement lyonnais inventé</a:t>
             </a:r>
           </a:p>
           <a:p xmlns:a="http://schemas.openxmlformats.org/drawingml/2006/main">
@@ -3084,7 +3084,7 @@
                   <a:srgbClr val="132A3A"/>
                 </a:solidFill>
               </a:rPr>
-              <a:t>• bon cas positif precis pour la demo</a:t>
+              <a:t>• démo complète mesurée en 2,240 s</a:t>
             </a:r>
           </a:p>
         </p:txBody>
@@ -3164,7 +3164,7 @@
                   <a:srgbClr val="5F6B73"/>
                 </a:solidFill>
               </a:rPr>
-              <a:t>DEMO</a:t>
+              <a:t>EVALUATION</a:t>
             </a:r>
           </a:p>
         </p:txBody>
@@ -3266,7 +3266,7 @@
                   <a:srgbClr val="132A3A"/>
                 </a:solidFill>
               </a:rPr>
-              <a:t>Scenario 3 - Sortie en famille avec visite theatricalisee</a:t>
+              <a:t>RAGAS mesure la qualité sur 3 cas annotés</a:t>
             </a:r>
           </a:p>
         </p:txBody>
@@ -3317,7 +3317,7 @@
                   <a:srgbClr val="5F6B73"/>
                 </a:solidFill>
               </a:rPr>
-              <a:t>Question orientee usage, utile pour verifier le rappel de plusieurs sources proches.</a:t>
+              <a:t>Question, contextes transmis, réponse Mistral et référence humaine.</a:t>
             </a:r>
           </a:p>
         </p:txBody>
@@ -3403,7 +3403,7 @@
                   <a:srgbClr val="132A3A"/>
                 </a:solidFill>
               </a:rPr>
-              <a:t>Question</a:t>
+              <a:t>Jeu évalué</a:t>
             </a:r>
           </a:p>
         </p:txBody>
@@ -3454,7 +3454,61 @@
                   <a:srgbClr val="132A3A"/>
                 </a:solidFill>
               </a:rPr>
-              <a:t>Je cherche une sortie en famille a Paris avec une visite theatricalisee</a:t>
+              <a:t>3 questions factuelles</a:t>
+            </a:r>
+          </a:p>
+          <a:p xmlns:a="http://schemas.openxmlformats.org/drawingml/2006/main">
+            <a:pPr>
+              <a:buNone/>
+              <a:defRPr sz="1350" b="0">
+                <a:solidFill>
+                  <a:srgbClr val="132A3A"/>
+                </a:solidFill>
+              </a:defRPr>
+            </a:pPr>
+            <a:r>
+              <a:rPr sz="1350" b="0">
+                <a:solidFill>
+                  <a:srgbClr val="132A3A"/>
+                </a:solidFill>
+              </a:rPr>
+              <a:t>Concert Fishers</a:t>
+            </a:r>
+          </a:p>
+          <a:p xmlns:a="http://schemas.openxmlformats.org/drawingml/2006/main">
+            <a:pPr>
+              <a:buNone/>
+              <a:defRPr sz="1350" b="0">
+                <a:solidFill>
+                  <a:srgbClr val="132A3A"/>
+                </a:solidFill>
+              </a:defRPr>
+            </a:pPr>
+            <a:r>
+              <a:rPr sz="1350" b="0">
+                <a:solidFill>
+                  <a:srgbClr val="132A3A"/>
+                </a:solidFill>
+              </a:rPr>
+              <a:t>Salon de la Photo</a:t>
+            </a:r>
+          </a:p>
+          <a:p xmlns:a="http://schemas.openxmlformats.org/drawingml/2006/main">
+            <a:pPr>
+              <a:buNone/>
+              <a:defRPr sz="1350" b="0">
+                <a:solidFill>
+                  <a:srgbClr val="132A3A"/>
+                </a:solidFill>
+              </a:defRPr>
+            </a:pPr>
+            <a:r>
+              <a:rPr sz="1350" b="0">
+                <a:solidFill>
+                  <a:srgbClr val="132A3A"/>
+                </a:solidFill>
+              </a:rPr>
+              <a:t>Sortie en famille</a:t>
             </a:r>
           </a:p>
         </p:txBody>
@@ -3540,7 +3594,7 @@
                   <a:srgbClr val="132A3A"/>
                 </a:solidFill>
               </a:rPr>
-              <a:t>Observation</a:t>
+              <a:t>4 métriques</a:t>
             </a:r>
           </a:p>
         </p:txBody>
@@ -3591,7 +3645,7 @@
                   <a:srgbClr val="132A3A"/>
                 </a:solidFill>
               </a:rPr>
-              <a:t>• le systeme retrouve deux visites theatralisees familiales</a:t>
+              <a:t>• fidélité au contexte</a:t>
             </a:r>
           </a:p>
           <a:p xmlns:a="http://schemas.openxmlformats.org/drawingml/2006/main">
@@ -3609,7 +3663,7 @@
                   <a:srgbClr val="132A3A"/>
                 </a:solidFill>
               </a:rPr>
-              <a:t>• reponse contextualisee avec dates, lieux et URL</a:t>
+              <a:t>• pertinence de la réponse</a:t>
             </a:r>
           </a:p>
           <a:p xmlns:a="http://schemas.openxmlformats.org/drawingml/2006/main">
@@ -3627,7 +3681,25 @@
                   <a:srgbClr val="132A3A"/>
                 </a:solidFill>
               </a:rPr>
-              <a:t>• bon scenario de demo et du jeu annote</a:t>
+              <a:t>• précision du contexte</a:t>
+            </a:r>
+          </a:p>
+          <a:p xmlns:a="http://schemas.openxmlformats.org/drawingml/2006/main">
+            <a:pPr>
+              <a:buNone/>
+              <a:defRPr sz="1350" b="0">
+                <a:solidFill>
+                  <a:srgbClr val="132A3A"/>
+                </a:solidFill>
+              </a:defRPr>
+            </a:pPr>
+            <a:r>
+              <a:rPr sz="1350" b="0">
+                <a:solidFill>
+                  <a:srgbClr val="132A3A"/>
+                </a:solidFill>
+              </a:rPr>
+              <a:t>• correction vs référence</a:t>
             </a:r>
           </a:p>
         </p:txBody>
@@ -3707,7 +3779,7 @@
                   <a:srgbClr val="5F6B73"/>
                 </a:solidFill>
               </a:rPr>
-              <a:t>BILAN</a:t>
+              <a:t>RAGAS</a:t>
             </a:r>
           </a:p>
         </p:txBody>
@@ -3809,7 +3881,7 @@
                   <a:srgbClr val="132A3A"/>
                 </a:solidFill>
               </a:rPr>
-              <a:t>Resultats observes et points forts</a:t>
+              <a:t>Deux cas précis dépassent 0,82 au global</a:t>
             </a:r>
           </a:p>
         </p:txBody>
@@ -3860,7 +3932,7 @@
                   <a:srgbClr val="5F6B73"/>
                 </a:solidFill>
               </a:rPr>
-              <a:t>Le POC est presentable en local et defendable avec corpus, evaluation et demo alignes.</a:t>
+              <a:t>Les contextes principaux sont classés en première position.</a:t>
             </a:r>
           </a:p>
         </p:txBody>
@@ -3946,7 +4018,7 @@
                   <a:srgbClr val="132A3A"/>
                 </a:solidFill>
               </a:rPr>
-              <a:t>Ce qui fonctionne</a:t>
+              <a:t>Concert Fishers</a:t>
             </a:r>
           </a:p>
         </p:txBody>
@@ -3997,7 +4069,7 @@
                   <a:srgbClr val="132A3A"/>
                 </a:solidFill>
               </a:rPr>
-              <a:t>• chainage complet collecte -&gt; index -&gt; chatbot -&gt; API -&gt; Docker</a:t>
+              <a:t>• global 0,823</a:t>
             </a:r>
           </a:p>
           <a:p xmlns:a="http://schemas.openxmlformats.org/drawingml/2006/main">
@@ -4015,7 +4087,7 @@
                   <a:srgbClr val="132A3A"/>
                 </a:solidFill>
               </a:rPr>
-              <a:t>• artefacts inspectables a chaque etape</a:t>
+              <a:t>• fidélité 0,750</a:t>
             </a:r>
           </a:p>
           <a:p xmlns:a="http://schemas.openxmlformats.org/drawingml/2006/main">
@@ -4033,7 +4105,25 @@
                   <a:srgbClr val="132A3A"/>
                 </a:solidFill>
               </a:rPr>
-              <a:t>• README, demo et deck racontent le meme etat projet</a:t>
+              <a:t>• pertinence 0,805</a:t>
+            </a:r>
+          </a:p>
+          <a:p xmlns:a="http://schemas.openxmlformats.org/drawingml/2006/main">
+            <a:pPr>
+              <a:buNone/>
+              <a:defRPr sz="1350" b="0">
+                <a:solidFill>
+                  <a:srgbClr val="132A3A"/>
+                </a:solidFill>
+              </a:defRPr>
+            </a:pPr>
+            <a:r>
+              <a:rPr sz="1350" b="0">
+                <a:solidFill>
+                  <a:srgbClr val="132A3A"/>
+                </a:solidFill>
+              </a:rPr>
+              <a:t>• contexte 1,000</a:t>
             </a:r>
           </a:p>
         </p:txBody>
@@ -4119,7 +4209,7 @@
                   <a:srgbClr val="132A3A"/>
                 </a:solidFill>
               </a:rPr>
-              <a:t>Verification</a:t>
+              <a:t>Salon de la Photo</a:t>
             </a:r>
           </a:p>
         </p:txBody>
@@ -4170,7 +4260,7 @@
                   <a:srgbClr val="132A3A"/>
                 </a:solidFill>
               </a:rPr>
-              <a:t>• 35 tests automatises passent</a:t>
+              <a:t>• global 0,887</a:t>
             </a:r>
           </a:p>
           <a:p xmlns:a="http://schemas.openxmlformats.org/drawingml/2006/main">
@@ -4188,7 +4278,7 @@
                   <a:srgbClr val="132A3A"/>
                 </a:solidFill>
               </a:rPr>
-              <a:t>• 4/4 cas corrects en evaluation directe</a:t>
+              <a:t>• fidélité 1,000</a:t>
             </a:r>
           </a:p>
           <a:p xmlns:a="http://schemas.openxmlformats.org/drawingml/2006/main">
@@ -4206,7 +4296,7 @@
                   <a:srgbClr val="132A3A"/>
                 </a:solidFill>
               </a:rPr>
-              <a:t>• 4/4 cas corrects en evaluation via API</a:t>
+              <a:t>• pertinence 0,817</a:t>
             </a:r>
           </a:p>
           <a:p xmlns:a="http://schemas.openxmlformats.org/drawingml/2006/main">
@@ -4224,7 +4314,7 @@
                   <a:srgbClr val="132A3A"/>
                 </a:solidFill>
               </a:rPr>
-              <a:t>• scripts/demo_scenarios.sh joue 3 cas solides</a:t>
+              <a:t>• contexte 1,000</a:t>
             </a:r>
           </a:p>
         </p:txBody>
@@ -4310,7 +4400,7 @@
                   <a:srgbClr val="132A3A"/>
                 </a:solidFill>
               </a:rPr>
-              <a:t>Valeur pour Puls-Events</a:t>
+              <a:t>Lecture</a:t>
             </a:r>
           </a:p>
         </p:txBody>
@@ -4361,7 +4451,7 @@
                   <a:srgbClr val="132A3A"/>
                 </a:solidFill>
               </a:rPr>
-              <a:t>• prototype concret pour arbitrer la suite</a:t>
+              <a:t>• informations pratiques reprises</a:t>
             </a:r>
           </a:p>
           <a:p xmlns:a="http://schemas.openxmlformats.org/drawingml/2006/main">
@@ -4379,7 +4469,7 @@
                   <a:srgbClr val="132A3A"/>
                 </a:solidFill>
               </a:rPr>
-              <a:t>• API testable par les equipes produit et marketing</a:t>
+              <a:t>• sources vérifiables</a:t>
             </a:r>
           </a:p>
           <a:p xmlns:a="http://schemas.openxmlformats.org/drawingml/2006/main">
@@ -4397,7 +4487,7 @@
                   <a:srgbClr val="132A3A"/>
                 </a:solidFill>
               </a:rPr>
-              <a:t>• fondation reutilisable pour une version produit</a:t>
+              <a:t>• correction à affiner face aux références</a:t>
             </a:r>
           </a:p>
         </p:txBody>
@@ -4477,7 +4567,7 @@
                   <a:srgbClr val="5F6B73"/>
                 </a:solidFill>
               </a:rPr>
-              <a:t>LIMITES</a:t>
+              <a:t>RAGAS</a:t>
             </a:r>
           </a:p>
         </p:txBody>
@@ -4579,7 +4669,7 @@
                   <a:srgbClr val="132A3A"/>
                 </a:solidFill>
               </a:rPr>
-              <a:t>Limites actuelles du POC</a:t>
+              <a:t>Le retrieval est solide, la correction reste prioritaire</a:t>
             </a:r>
           </a:p>
         </p:txBody>
@@ -4630,7 +4720,7 @@
                   <a:srgbClr val="5F6B73"/>
                 </a:solidFill>
               </a:rPr>
-              <a:t>Les choix sont volontaires pour avancer vite, mais ils fixent un perimetre de soutenance clair.</a:t>
+              <a:t>Le cas famille retrouve plusieurs visites et révèle l'écart principal.</a:t>
             </a:r>
           </a:p>
         </p:txBody>
@@ -4716,7 +4806,7 @@
                   <a:srgbClr val="132A3A"/>
                 </a:solidFill>
               </a:rPr>
-              <a:t>Donnees</a:t>
+              <a:t>Sortie en famille</a:t>
             </a:r>
           </a:p>
         </p:txBody>
@@ -4767,7 +4857,7 @@
                   <a:srgbClr val="132A3A"/>
                 </a:solidFill>
               </a:rPr>
-              <a:t>• seed de demo actuellement centre sur Paris</a:t>
+              <a:t>• global 0,862</a:t>
             </a:r>
           </a:p>
           <a:p xmlns:a="http://schemas.openxmlformats.org/drawingml/2006/main">
@@ -4785,7 +4875,7 @@
                   <a:srgbClr val="132A3A"/>
                 </a:solidFill>
               </a:rPr>
-              <a:t>• bruit et qualite variables selon les descriptions source</a:t>
+              <a:t>• fidélité 0,950</a:t>
             </a:r>
           </a:p>
           <a:p xmlns:a="http://schemas.openxmlformats.org/drawingml/2006/main">
@@ -4803,7 +4893,25 @@
                   <a:srgbClr val="132A3A"/>
                 </a:solidFill>
               </a:rPr>
-              <a:t>• certaines categories restent peu normalisees</a:t>
+              <a:t>• pertinence 0,916</a:t>
+            </a:r>
+          </a:p>
+          <a:p xmlns:a="http://schemas.openxmlformats.org/drawingml/2006/main">
+            <a:pPr>
+              <a:buNone/>
+              <a:defRPr sz="1350" b="0">
+                <a:solidFill>
+                  <a:srgbClr val="132A3A"/>
+                </a:solidFill>
+              </a:defRPr>
+            </a:pPr>
+            <a:r>
+              <a:rPr sz="1350" b="0">
+                <a:solidFill>
+                  <a:srgbClr val="132A3A"/>
+                </a:solidFill>
+              </a:rPr>
+              <a:t>• contexte 1,000</a:t>
             </a:r>
           </a:p>
         </p:txBody>
@@ -4889,7 +4997,7 @@
                   <a:srgbClr val="132A3A"/>
                 </a:solidFill>
               </a:rPr>
-              <a:t>Technique</a:t>
+              <a:t>Moyennes</a:t>
             </a:r>
           </a:p>
         </p:txBody>
@@ -4940,7 +5048,7 @@
                   <a:srgbClr val="132A3A"/>
                 </a:solidFill>
               </a:rPr>
-              <a:t>• generation dependante de Mistral en ligne</a:t>
+              <a:t>• fidélité 0,900</a:t>
             </a:r>
           </a:p>
           <a:p xmlns:a="http://schemas.openxmlformats.org/drawingml/2006/main">
@@ -4958,7 +5066,7 @@
                   <a:srgbClr val="132A3A"/>
                 </a:solidFill>
               </a:rPr>
-              <a:t>• `/rebuild` complet sur corpus large est long</a:t>
+              <a:t>• pertinence 0,846</a:t>
             </a:r>
           </a:p>
           <a:p xmlns:a="http://schemas.openxmlformats.org/drawingml/2006/main">
@@ -4976,7 +5084,25 @@
                   <a:srgbClr val="132A3A"/>
                 </a:solidFill>
               </a:rPr>
-              <a:t>• pas d'historique conversationnel dans ce POC</a:t>
+              <a:t>• précision 1,000</a:t>
+            </a:r>
+          </a:p>
+          <a:p xmlns:a="http://schemas.openxmlformats.org/drawingml/2006/main">
+            <a:pPr>
+              <a:buNone/>
+              <a:defRPr sz="1350" b="0">
+                <a:solidFill>
+                  <a:srgbClr val="132A3A"/>
+                </a:solidFill>
+              </a:defRPr>
+            </a:pPr>
+            <a:r>
+              <a:rPr sz="1350" b="0">
+                <a:solidFill>
+                  <a:srgbClr val="132A3A"/>
+                </a:solidFill>
+              </a:rPr>
+              <a:t>• correction 0,683</a:t>
             </a:r>
           </a:p>
         </p:txBody>
@@ -5062,7 +5188,7 @@
                   <a:srgbClr val="132A3A"/>
                 </a:solidFill>
               </a:rPr>
-              <a:t>Produit</a:t>
+              <a:t>Priorité</a:t>
             </a:r>
           </a:p>
         </p:txBody>
@@ -5113,43 +5239,7 @@
                   <a:srgbClr val="132A3A"/>
                 </a:solidFill>
               </a:rPr>
-              <a:t>• pas encore d'authentification forte</a:t>
-            </a:r>
-          </a:p>
-          <a:p xmlns:a="http://schemas.openxmlformats.org/drawingml/2006/main">
-            <a:pPr>
-              <a:buNone/>
-              <a:defRPr sz="1350" b="0">
-                <a:solidFill>
-                  <a:srgbClr val="132A3A"/>
-                </a:solidFill>
-              </a:defRPr>
-            </a:pPr>
-            <a:r>
-              <a:rPr sz="1350" b="0">
-                <a:solidFill>
-                  <a:srgbClr val="132A3A"/>
-                </a:solidFill>
-              </a:rPr>
-              <a:t>• pas de front utilisateur final</a:t>
-            </a:r>
-          </a:p>
-          <a:p xmlns:a="http://schemas.openxmlformats.org/drawingml/2006/main">
-            <a:pPr>
-              <a:buNone/>
-              <a:defRPr sz="1350" b="0">
-                <a:solidFill>
-                  <a:srgbClr val="132A3A"/>
-                </a:solidFill>
-              </a:defRPr>
-            </a:pPr>
-            <a:r>
-              <a:rPr sz="1350" b="0">
-                <a:solidFill>
-                  <a:srgbClr val="132A3A"/>
-                </a:solidFill>
-              </a:rPr>
-              <a:t>• jeu annote volontairement petit</a:t>
+              <a:t>Mieux cadrer les détails attendus par la référence, sans dégrader la recherche.</a:t>
             </a:r>
           </a:p>
         </p:txBody>
@@ -5229,7 +5319,7 @@
                   <a:srgbClr val="5F6B73"/>
                 </a:solidFill>
               </a:rPr>
-              <a:t>EVALUATION</a:t>
+              <a:t>LIMITES</a:t>
             </a:r>
           </a:p>
         </p:txBody>
@@ -5331,7 +5421,7 @@
                   <a:srgbClr val="132A3A"/>
                 </a:solidFill>
               </a:rPr>
-              <a:t>Evaluation automatisee livree</a:t>
+              <a:t>Le POC valide la faisabilité, pas la production</a:t>
             </a:r>
           </a:p>
         </p:txBody>
@@ -5382,7 +5472,7 @@
                   <a:srgbClr val="5F6B73"/>
                 </a:solidFill>
               </a:rPr>
-              <a:t>Le depot contient un petit jeu annote versionne et un script reproductible.</a:t>
+              <a:t>Les limites sont explicites et orientent la prochaine itération.</a:t>
             </a:r>
           </a:p>
         </p:txBody>
@@ -5468,7 +5558,7 @@
                   <a:srgbClr val="132A3A"/>
                 </a:solidFill>
               </a:rPr>
-              <a:t>Mesures simples</a:t>
+              <a:t>Données</a:t>
             </a:r>
           </a:p>
         </p:txBody>
@@ -5519,7 +5609,7 @@
                   <a:srgbClr val="132A3A"/>
                 </a:solidFill>
               </a:rPr>
-              <a:t>• exact match souple</a:t>
+              <a:t>• Paris uniquement</a:t>
             </a:r>
           </a:p>
           <a:p xmlns:a="http://schemas.openxmlformats.org/drawingml/2006/main">
@@ -5537,7 +5627,7 @@
                   <a:srgbClr val="132A3A"/>
                 </a:solidFill>
               </a:rPr>
-              <a:t>• similarite lexicale</a:t>
+              <a:t>• fenêtre figée d'un an</a:t>
             </a:r>
           </a:p>
           <a:p xmlns:a="http://schemas.openxmlformats.org/drawingml/2006/main">
@@ -5555,25 +5645,7 @@
                   <a:srgbClr val="132A3A"/>
                 </a:solidFill>
               </a:rPr>
-              <a:t>• hit de titres attendus</a:t>
-            </a:r>
-          </a:p>
-          <a:p xmlns:a="http://schemas.openxmlformats.org/drawingml/2006/main">
-            <a:pPr>
-              <a:buNone/>
-              <a:defRPr sz="1350" b="0">
-                <a:solidFill>
-                  <a:srgbClr val="132A3A"/>
-                </a:solidFill>
-              </a:defRPr>
-            </a:pPr>
-            <a:r>
-              <a:rPr sz="1350" b="0">
-                <a:solidFill>
-                  <a:srgbClr val="132A3A"/>
-                </a:solidFill>
-              </a:rPr>
-              <a:t>• classification correct / partial / incorrect</a:t>
+              <a:t>• descriptions source variables</a:t>
             </a:r>
           </a:p>
         </p:txBody>
@@ -5659,7 +5731,7 @@
                   <a:srgbClr val="132A3A"/>
                 </a:solidFill>
               </a:rPr>
-              <a:t>Ragas</a:t>
+              <a:t>Technique</a:t>
             </a:r>
           </a:p>
         </p:txBody>
@@ -5710,7 +5782,7 @@
                   <a:srgbClr val="132A3A"/>
                 </a:solidFill>
               </a:rPr>
-              <a:t>• mode par defaut sans dependance lourde</a:t>
+              <a:t>• dépendance Mistral en ligne</a:t>
             </a:r>
           </a:p>
           <a:p xmlns:a="http://schemas.openxmlformats.org/drawingml/2006/main">
@@ -5728,7 +5800,7 @@
                   <a:srgbClr val="132A3A"/>
                 </a:solidFill>
               </a:rPr>
-              <a:t>• option --ragas si la bibliotheque est disponible</a:t>
+              <a:t>• rebuild complet coûteux</a:t>
             </a:r>
           </a:p>
           <a:p xmlns:a="http://schemas.openxmlformats.org/drawingml/2006/main">
@@ -5746,7 +5818,7 @@
                   <a:srgbClr val="132A3A"/>
                 </a:solidFill>
               </a:rPr>
-              <a:t>• Ragas reste une extension, pas la source de verite</a:t>
+              <a:t>• seuil de rejet à renforcer</a:t>
             </a:r>
           </a:p>
         </p:txBody>
@@ -5832,7 +5904,7 @@
                   <a:srgbClr val="132A3A"/>
                 </a:solidFill>
               </a:rPr>
-              <a:t>Resultat observe</a:t>
+              <a:t>Évaluation</a:t>
             </a:r>
           </a:p>
         </p:txBody>
@@ -5883,7 +5955,43 @@
                   <a:srgbClr val="132A3A"/>
                 </a:solidFill>
               </a:rPr>
-              <a:t>Le 10 juillet 2026 : 4 cas sur 4 corrects en direct et via API sur le corpus Paris livre.</a:t>
+              <a:t>• 3 cas RAGAS seulement</a:t>
+            </a:r>
+          </a:p>
+          <a:p xmlns:a="http://schemas.openxmlformats.org/drawingml/2006/main">
+            <a:pPr>
+              <a:buNone/>
+              <a:defRPr sz="1350" b="0">
+                <a:solidFill>
+                  <a:srgbClr val="132A3A"/>
+                </a:solidFill>
+              </a:defRPr>
+            </a:pPr>
+            <a:r>
+              <a:rPr sz="1350" b="0">
+                <a:solidFill>
+                  <a:srgbClr val="132A3A"/>
+                </a:solidFill>
+              </a:rPr>
+              <a:t>• scores non déterministes au mot près</a:t>
+            </a:r>
+          </a:p>
+          <a:p xmlns:a="http://schemas.openxmlformats.org/drawingml/2006/main">
+            <a:pPr>
+              <a:buNone/>
+              <a:defRPr sz="1350" b="0">
+                <a:solidFill>
+                  <a:srgbClr val="132A3A"/>
+                </a:solidFill>
+              </a:defRPr>
+            </a:pPr>
+            <a:r>
+              <a:rPr sz="1350" b="0">
+                <a:solidFill>
+                  <a:srgbClr val="132A3A"/>
+                </a:solidFill>
+              </a:rPr>
+              <a:t>• tests de charge absents</a:t>
             </a:r>
           </a:p>
         </p:txBody>
@@ -6065,7 +6173,7 @@
                   <a:srgbClr val="132A3A"/>
                 </a:solidFill>
               </a:rPr>
-              <a:t>Perspectives d'amelioration et conclusion</a:t>
+              <a:t>La prochaine étape est un pilote multi-villes mesuré</a:t>
             </a:r>
           </a:p>
         </p:txBody>
@@ -6116,7 +6224,7 @@
                   <a:srgbClr val="5F6B73"/>
                 </a:solidFill>
               </a:rPr>
-              <a:t>Le POC est exploitable maintenant, et extensible sans rearchitecture majeure.</a:t>
+              <a:t>L'architecture peut évoluer sans réécriture majeure.</a:t>
             </a:r>
           </a:p>
         </p:txBody>
@@ -6202,7 +6310,7 @@
                   <a:srgbClr val="132A3A"/>
                 </a:solidFill>
               </a:rPr>
-              <a:t>Ameliorations prioritaires</a:t>
+              <a:t>Améliorations prioritaires</a:t>
             </a:r>
           </a:p>
         </p:txBody>
@@ -6253,7 +6361,7 @@
                   <a:srgbClr val="132A3A"/>
                 </a:solidFill>
               </a:rPr>
-              <a:t>• seeds multi-villes</a:t>
+              <a:t>• élargir le jeu annoté</a:t>
             </a:r>
           </a:p>
           <a:p xmlns:a="http://schemas.openxmlformats.org/drawingml/2006/main">
@@ -6271,7 +6379,7 @@
                   <a:srgbClr val="132A3A"/>
                 </a:solidFill>
               </a:rPr>
-              <a:t>• filtrage plus fin par date, categorie et public</a:t>
+              <a:t>• ajouter un seuil de similarité</a:t>
             </a:r>
           </a:p>
           <a:p xmlns:a="http://schemas.openxmlformats.org/drawingml/2006/main">
@@ -6289,7 +6397,7 @@
                   <a:srgbClr val="132A3A"/>
                 </a:solidFill>
               </a:rPr>
-              <a:t>• evaluation plus large et continue</a:t>
+              <a:t>• automatiser collecte et CI</a:t>
             </a:r>
           </a:p>
           <a:p xmlns:a="http://schemas.openxmlformats.org/drawingml/2006/main">
@@ -6307,7 +6415,7 @@
                   <a:srgbClr val="132A3A"/>
                 </a:solidFill>
               </a:rPr>
-              <a:t>• rebuild asynchrone ou incremental</a:t>
+              <a:t>• superviser coût et latence</a:t>
             </a:r>
           </a:p>
         </p:txBody>
@@ -6393,7 +6501,7 @@
                   <a:srgbClr val="132A3A"/>
                 </a:solidFill>
               </a:rPr>
-              <a:t>Message cle</a:t>
+              <a:t>Message clé</a:t>
             </a:r>
           </a:p>
         </p:txBody>
@@ -6444,7 +6552,7 @@
                   <a:srgbClr val="132A3A"/>
                 </a:solidFill>
               </a:rPr>
-              <a:t>La faisabilite technique est validee: corpus borne, index local, API Dockerisee et evaluation reproductible.</a:t>
+              <a:t>7 586 événements, 14 903 chunks, API Docker et RAGAS réel : la faisabilité est démontrée.</a:t>
             </a:r>
           </a:p>
         </p:txBody>
@@ -6581,79 +6689,7 @@
                   <a:srgbClr val="132A3A"/>
                 </a:solidFill>
               </a:rPr>
-              <a:t>Points defendables en soutenance:</a:t>
-            </a:r>
-          </a:p>
-          <a:p xmlns:a="http://schemas.openxmlformats.org/drawingml/2006/main">
-            <a:pPr>
-              <a:buNone/>
-              <a:defRPr sz="1350" b="0">
-                <a:solidFill>
-                  <a:srgbClr val="132A3A"/>
-                </a:solidFill>
-              </a:defRPr>
-            </a:pPr>
-            <a:r>
-              <a:rPr sz="1350" b="0">
-                <a:solidFill>
-                  <a:srgbClr val="132A3A"/>
-                </a:solidFill>
-              </a:rPr>
-              <a:t>• pourquoi FAISS ?</a:t>
-            </a:r>
-          </a:p>
-          <a:p xmlns:a="http://schemas.openxmlformats.org/drawingml/2006/main">
-            <a:pPr>
-              <a:buNone/>
-              <a:defRPr sz="1350" b="0">
-                <a:solidFill>
-                  <a:srgbClr val="132A3A"/>
-                </a:solidFill>
-              </a:defRPr>
-            </a:pPr>
-            <a:r>
-              <a:rPr sz="1350" b="0">
-                <a:solidFill>
-                  <a:srgbClr val="132A3A"/>
-                </a:solidFill>
-              </a:rPr>
-              <a:t>• pourquoi Mistral ?</a:t>
-            </a:r>
-          </a:p>
-          <a:p xmlns:a="http://schemas.openxmlformats.org/drawingml/2006/main">
-            <a:pPr>
-              <a:buNone/>
-              <a:defRPr sz="1350" b="0">
-                <a:solidFill>
-                  <a:srgbClr val="132A3A"/>
-                </a:solidFill>
-              </a:defRPr>
-            </a:pPr>
-            <a:r>
-              <a:rPr sz="1350" b="0">
-                <a:solidFill>
-                  <a:srgbClr val="132A3A"/>
-                </a:solidFill>
-              </a:rPr>
-              <a:t>• pourquoi Paris et ce corpus borne ?</a:t>
-            </a:r>
-          </a:p>
-          <a:p xmlns:a="http://schemas.openxmlformats.org/drawingml/2006/main">
-            <a:pPr>
-              <a:buNone/>
-              <a:defRPr sz="1350" b="0">
-                <a:solidFill>
-                  <a:srgbClr val="132A3A"/>
-                </a:solidFill>
-              </a:defRPr>
-            </a:pPr>
-            <a:r>
-              <a:rPr sz="1350" b="0">
-                <a:solidFill>
-                  <a:srgbClr val="132A3A"/>
-                </a:solidFill>
-              </a:rPr>
-              <a:t>• quelles limites restent a lever ?</a:t>
+              <a:t>Décision proposée : tester le POC avec les équipes produit sur un corpus multi-villes.</a:t>
             </a:r>
           </a:p>
         </p:txBody>
@@ -13047,7 +13083,7 @@
                   <a:srgbClr val="132A3A"/>
                 </a:solidFill>
               </a:rPr>
-              <a:t>Scenario 1 - Parle-moi de Concert Fishers a Paris</a:t>
+              <a:t>Démo nominale — Concert Fishers à Paris</a:t>
             </a:r>
           </a:p>
         </p:txBody>
@@ -13098,7 +13134,7 @@
                   <a:srgbClr val="5F6B73"/>
                 </a:solidFill>
               </a:rPr>
-              <a:t>Question de demo precise sur un evenement reel du corpus livre.</a:t>
+              <a:t>Une question précise produit une réponse sourcée en quelques secondes.</a:t>
             </a:r>
           </a:p>
         </p:txBody>
@@ -13184,7 +13220,7 @@
                   <a:srgbClr val="132A3A"/>
                 </a:solidFill>
               </a:rPr>
-              <a:t>Question</a:t>
+              <a:t>Question posée</a:t>
             </a:r>
           </a:p>
         </p:txBody>
@@ -13321,7 +13357,7 @@
                   <a:srgbClr val="132A3A"/>
                 </a:solidFill>
               </a:rPr>
-              <a:t>Observation</a:t>
+              <a:t>Résultat observé</a:t>
             </a:r>
           </a:p>
         </p:txBody>
@@ -13372,7 +13408,7 @@
                   <a:srgbClr val="132A3A"/>
                 </a:solidFill>
               </a:rPr>
-              <a:t>• reponse stable avec date, lieu et URL</a:t>
+              <a:t>• date, lieu et URL correctement repris</a:t>
             </a:r>
           </a:p>
           <a:p xmlns:a="http://schemas.openxmlformats.org/drawingml/2006/main">
@@ -13390,7 +13426,7 @@
                   <a:srgbClr val="132A3A"/>
                 </a:solidFill>
               </a:rPr>
-              <a:t>• source principale: Concert Fishers</a:t>
+              <a:t>• 4 sources retournées</a:t>
             </a:r>
           </a:p>
           <a:p xmlns:a="http://schemas.openxmlformats.org/drawingml/2006/main">
@@ -13408,7 +13444,7 @@
                   <a:srgbClr val="132A3A"/>
                 </a:solidFill>
               </a:rPr>
-              <a:t>• cas positif precis du jeu annote</a:t>
+              <a:t>• réponse non vide et traçable</a:t>
             </a:r>
           </a:p>
         </p:txBody>

</xml_diff>

<commit_message>
fix: make final Docker demo reproducible from Git
</commit_message>
<xml_diff>
--- a/outputs/openagenda-rag-soutenance.pptx
+++ b/outputs/openagenda-rag-soutenance.pptx
@@ -2,27 +2,27 @@
 <file path=ppt/presentation.xml><?xml version="1.0" encoding="utf-8"?>
 <p:presentation xmlns:p="http://schemas.openxmlformats.org/presentationml/2006/main">
   <p:sldMasterIdLst>
-    <p:sldMasterId xmlns:r="http://schemas.openxmlformats.org/officeDocument/2006/relationships" id="2147483648" r:id="R3bec24a006d94845"/>
+    <p:sldMasterId xmlns:r="http://schemas.openxmlformats.org/officeDocument/2006/relationships" id="2147483648" r:id="R90fe4c54b6da4a4d"/>
   </p:sldMasterIdLst>
   <p:notesMasterIdLst>
-    <p:notesMasterId xmlns:r="http://schemas.openxmlformats.org/officeDocument/2006/relationships" r:id="R35ceb18aa94241b0"/>
+    <p:notesMasterId xmlns:r="http://schemas.openxmlformats.org/officeDocument/2006/relationships" r:id="R441723173b3a4774"/>
   </p:notesMasterIdLst>
   <p:sldIdLst>
-    <p:sldId xmlns:r="http://schemas.openxmlformats.org/officeDocument/2006/relationships" id="256" r:id="Ra9700f4774c74e40"/>
-    <p:sldId xmlns:r="http://schemas.openxmlformats.org/officeDocument/2006/relationships" id="257" r:id="R0b5724cc13ec42d8"/>
-    <p:sldId xmlns:r="http://schemas.openxmlformats.org/officeDocument/2006/relationships" id="258" r:id="Re0541d774b1f490d"/>
-    <p:sldId xmlns:r="http://schemas.openxmlformats.org/officeDocument/2006/relationships" id="259" r:id="R042d9643f4894980"/>
-    <p:sldId xmlns:r="http://schemas.openxmlformats.org/officeDocument/2006/relationships" id="260" r:id="R322560d5e3cb485b"/>
-    <p:sldId xmlns:r="http://schemas.openxmlformats.org/officeDocument/2006/relationships" id="261" r:id="R03e626d27f7c461b"/>
-    <p:sldId xmlns:r="http://schemas.openxmlformats.org/officeDocument/2006/relationships" id="262" r:id="R36197e68d3d84cfc"/>
-    <p:sldId xmlns:r="http://schemas.openxmlformats.org/officeDocument/2006/relationships" id="263" r:id="Re8dd90425759474b"/>
-    <p:sldId xmlns:r="http://schemas.openxmlformats.org/officeDocument/2006/relationships" id="264" r:id="R06a93d5ebdba498f"/>
-    <p:sldId xmlns:r="http://schemas.openxmlformats.org/officeDocument/2006/relationships" id="265" r:id="R255535622d2d486a"/>
-    <p:sldId xmlns:r="http://schemas.openxmlformats.org/officeDocument/2006/relationships" id="266" r:id="Re2dbc08ceb1744c2"/>
-    <p:sldId xmlns:r="http://schemas.openxmlformats.org/officeDocument/2006/relationships" id="267" r:id="Re3bceb5d977a421c"/>
-    <p:sldId xmlns:r="http://schemas.openxmlformats.org/officeDocument/2006/relationships" id="268" r:id="R9e97aac43b5f4796"/>
-    <p:sldId xmlns:r="http://schemas.openxmlformats.org/officeDocument/2006/relationships" id="269" r:id="R4816d2fcef2644e2"/>
-    <p:sldId xmlns:r="http://schemas.openxmlformats.org/officeDocument/2006/relationships" id="270" r:id="R1cbdab027e30448d"/>
+    <p:sldId xmlns:r="http://schemas.openxmlformats.org/officeDocument/2006/relationships" id="256" r:id="R7b61768a04064bd6"/>
+    <p:sldId xmlns:r="http://schemas.openxmlformats.org/officeDocument/2006/relationships" id="257" r:id="R2d5e12647a6f43e3"/>
+    <p:sldId xmlns:r="http://schemas.openxmlformats.org/officeDocument/2006/relationships" id="258" r:id="Rc9ea71ed348b485c"/>
+    <p:sldId xmlns:r="http://schemas.openxmlformats.org/officeDocument/2006/relationships" id="259" r:id="R1cf2627c52b2436b"/>
+    <p:sldId xmlns:r="http://schemas.openxmlformats.org/officeDocument/2006/relationships" id="260" r:id="R9057ce71c206443e"/>
+    <p:sldId xmlns:r="http://schemas.openxmlformats.org/officeDocument/2006/relationships" id="261" r:id="R94ec275244c3481f"/>
+    <p:sldId xmlns:r="http://schemas.openxmlformats.org/officeDocument/2006/relationships" id="262" r:id="R625484fff7dd449a"/>
+    <p:sldId xmlns:r="http://schemas.openxmlformats.org/officeDocument/2006/relationships" id="263" r:id="Rccc4e85971284bea"/>
+    <p:sldId xmlns:r="http://schemas.openxmlformats.org/officeDocument/2006/relationships" id="264" r:id="R3fbba4ec5a2c4973"/>
+    <p:sldId xmlns:r="http://schemas.openxmlformats.org/officeDocument/2006/relationships" id="265" r:id="R8ecb5eb6886a42cb"/>
+    <p:sldId xmlns:r="http://schemas.openxmlformats.org/officeDocument/2006/relationships" id="266" r:id="R9373d95132e14670"/>
+    <p:sldId xmlns:r="http://schemas.openxmlformats.org/officeDocument/2006/relationships" id="267" r:id="R7667ee215f01490c"/>
+    <p:sldId xmlns:r="http://schemas.openxmlformats.org/officeDocument/2006/relationships" id="268" r:id="Ra8ecd13237d547e5"/>
+    <p:sldId xmlns:r="http://schemas.openxmlformats.org/officeDocument/2006/relationships" id="269" r:id="R9fbdf85763974473"/>
+    <p:sldId xmlns:r="http://schemas.openxmlformats.org/officeDocument/2006/relationships" id="270" r:id="Re5bb3d3bcd894c1c"/>
   </p:sldIdLst>
   <p:sldSz cx="12192000" cy="6858000"/>
   <p:notesSz cx="6858000" cy="9144000"/>
@@ -1539,7 +1539,7 @@
   </p:cSld>
   <p:clrMap bg1="lt1" tx1="dk1" bg2="lt2" tx2="dk2" accent1="accent1" accent2="accent2" accent3="accent3" accent4="accent4" accent5="accent5" accent6="accent6" hlink="hlink" folHlink="folHlink"/>
   <p:sldLayoutIdLst>
-    <p:sldLayoutId xmlns:r="http://schemas.openxmlformats.org/officeDocument/2006/relationships" id="2147483649" r:id="R774d2d2c2c0c474c"/>
+    <p:sldLayoutId xmlns:r="http://schemas.openxmlformats.org/officeDocument/2006/relationships" id="2147483649" r:id="R6bc311fd4a5044b3"/>
   </p:sldLayoutIdLst>
   <p:txStyles>
     <p:titleStyle>
@@ -3084,7 +3084,7 @@
                   <a:srgbClr val="132A3A"/>
                 </a:solidFill>
               </a:rPr>
-              <a:t>• démo complète mesurée en 2,240 s</a:t>
+              <a:t>• démo complète mesurée en 2,406 s</a:t>
             </a:r>
           </a:p>
         </p:txBody>
@@ -12059,7 +12059,7 @@
                   <a:srgbClr val="132A3A"/>
                 </a:solidFill>
               </a:rPr>
-              <a:t>• 35 tests Python passent</a:t>
+              <a:t>• 59 tests Python passent</a:t>
             </a:r>
           </a:p>
           <a:p xmlns:a="http://schemas.openxmlformats.org/drawingml/2006/main">
@@ -12077,7 +12077,7 @@
                   <a:srgbClr val="132A3A"/>
                 </a:solidFill>
               </a:rPr>
-              <a:t>• python scripts/api_test.py valide /health et /ask</a:t>
+              <a:t>• api_test.py valide /health et /ask</a:t>
             </a:r>
           </a:p>
           <a:p xmlns:a="http://schemas.openxmlformats.org/drawingml/2006/main">
@@ -12095,7 +12095,7 @@
                   <a:srgbClr val="132A3A"/>
                 </a:solidFill>
               </a:rPr>
-              <a:t>• python scripts/evaluate_rag.py passe en direct et via API</a:t>
+              <a:t>• évaluation directe et API disponible</a:t>
             </a:r>
           </a:p>
           <a:p xmlns:a="http://schemas.openxmlformats.org/drawingml/2006/main">
@@ -12113,7 +12113,7 @@
                   <a:srgbClr val="132A3A"/>
                 </a:solidFill>
               </a:rPr>
-              <a:t>• reponses non vides avec sources exploitables</a:t>
+              <a:t>• réponses sourcées et exploitables</a:t>
             </a:r>
           </a:p>
         </p:txBody>
@@ -12483,7 +12483,7 @@
                   <a:srgbClr val="132A3A"/>
                 </a:solidFill>
               </a:rPr>
-              <a:t>• Base python:3.12-slim</a:t>
+              <a:t>• base python:3.12-slim</a:t>
             </a:r>
           </a:p>
           <a:p xmlns:a="http://schemas.openxmlformats.org/drawingml/2006/main">
@@ -12501,7 +12501,7 @@
                   <a:srgbClr val="132A3A"/>
                 </a:solidFill>
               </a:rPr>
-              <a:t>• dependances Python installees</a:t>
+              <a:t>• dépendances Python figées</a:t>
             </a:r>
           </a:p>
           <a:p xmlns:a="http://schemas.openxmlformats.org/drawingml/2006/main">
@@ -12519,7 +12519,7 @@
                   <a:srgbClr val="132A3A"/>
                 </a:solidFill>
               </a:rPr>
-              <a:t>• code source + scripts copies</a:t>
+              <a:t>• code source + scripts copiés</a:t>
             </a:r>
           </a:p>
           <a:p xmlns:a="http://schemas.openxmlformats.org/drawingml/2006/main">
@@ -12537,7 +12537,7 @@
                   <a:srgbClr val="132A3A"/>
                 </a:solidFill>
               </a:rPr>
-              <a:t>• seed de data/processed et data/index integre</a:t>
+              <a:t>• seed-data versionné et intégré</a:t>
             </a:r>
           </a:p>
         </p:txBody>

</xml_diff>

<commit_message>
fix: renforcer les contrastes du support
</commit_message>
<xml_diff>
--- a/outputs/openagenda-rag-soutenance.pptx
+++ b/outputs/openagenda-rag-soutenance.pptx
@@ -2,24 +2,24 @@
 <file path=ppt/presentation.xml><?xml version="1.0" encoding="utf-8"?>
 <p:presentation xmlns:p="http://schemas.openxmlformats.org/presentationml/2006/main">
   <p:sldMasterIdLst>
-    <p:sldMasterId xmlns:r="http://schemas.openxmlformats.org/officeDocument/2006/relationships" id="2147483648" r:id="Rd688ddbb532749f9"/>
+    <p:sldMasterId xmlns:r="http://schemas.openxmlformats.org/officeDocument/2006/relationships" id="2147483648" r:id="R023b6907214645d4"/>
   </p:sldMasterIdLst>
   <p:notesMasterIdLst>
-    <p:notesMasterId xmlns:r="http://schemas.openxmlformats.org/officeDocument/2006/relationships" r:id="Rf6be637c86cb49b7"/>
+    <p:notesMasterId xmlns:r="http://schemas.openxmlformats.org/officeDocument/2006/relationships" r:id="R136f33c4591740ee"/>
   </p:notesMasterIdLst>
   <p:sldIdLst>
-    <p:sldId xmlns:r="http://schemas.openxmlformats.org/officeDocument/2006/relationships" id="256" r:id="R4092ff671edb4fc5"/>
-    <p:sldId xmlns:r="http://schemas.openxmlformats.org/officeDocument/2006/relationships" id="257" r:id="R3fc22591307a4a55"/>
-    <p:sldId xmlns:r="http://schemas.openxmlformats.org/officeDocument/2006/relationships" id="258" r:id="Rb90b1f65a2d54eb6"/>
-    <p:sldId xmlns:r="http://schemas.openxmlformats.org/officeDocument/2006/relationships" id="259" r:id="R4fa7950f34314645"/>
-    <p:sldId xmlns:r="http://schemas.openxmlformats.org/officeDocument/2006/relationships" id="260" r:id="R5fdfd3428762487d"/>
-    <p:sldId xmlns:r="http://schemas.openxmlformats.org/officeDocument/2006/relationships" id="261" r:id="R0efed5a1cc674674"/>
-    <p:sldId xmlns:r="http://schemas.openxmlformats.org/officeDocument/2006/relationships" id="262" r:id="R68468d6a5ba34195"/>
-    <p:sldId xmlns:r="http://schemas.openxmlformats.org/officeDocument/2006/relationships" id="263" r:id="R868cb1140b8343d2"/>
-    <p:sldId xmlns:r="http://schemas.openxmlformats.org/officeDocument/2006/relationships" id="264" r:id="Rac87da97d3804ae9"/>
-    <p:sldId xmlns:r="http://schemas.openxmlformats.org/officeDocument/2006/relationships" id="265" r:id="R60c29bfcb674465d"/>
-    <p:sldId xmlns:r="http://schemas.openxmlformats.org/officeDocument/2006/relationships" id="266" r:id="R8ef310d7a21e4cbd"/>
-    <p:sldId xmlns:r="http://schemas.openxmlformats.org/officeDocument/2006/relationships" id="267" r:id="R961f0348b8bf409e"/>
+    <p:sldId xmlns:r="http://schemas.openxmlformats.org/officeDocument/2006/relationships" id="256" r:id="Ra7f3c216dfb840da"/>
+    <p:sldId xmlns:r="http://schemas.openxmlformats.org/officeDocument/2006/relationships" id="257" r:id="R732b5935a44f4c01"/>
+    <p:sldId xmlns:r="http://schemas.openxmlformats.org/officeDocument/2006/relationships" id="258" r:id="R0a1911443d914d9e"/>
+    <p:sldId xmlns:r="http://schemas.openxmlformats.org/officeDocument/2006/relationships" id="259" r:id="Raef1e9973e104108"/>
+    <p:sldId xmlns:r="http://schemas.openxmlformats.org/officeDocument/2006/relationships" id="260" r:id="R1d0459a0ccee4535"/>
+    <p:sldId xmlns:r="http://schemas.openxmlformats.org/officeDocument/2006/relationships" id="261" r:id="R2466ced80d4b441b"/>
+    <p:sldId xmlns:r="http://schemas.openxmlformats.org/officeDocument/2006/relationships" id="262" r:id="Rd17ce74b47e74c79"/>
+    <p:sldId xmlns:r="http://schemas.openxmlformats.org/officeDocument/2006/relationships" id="263" r:id="R9e92b42d126a4cb7"/>
+    <p:sldId xmlns:r="http://schemas.openxmlformats.org/officeDocument/2006/relationships" id="264" r:id="R9e3afb61f5a54134"/>
+    <p:sldId xmlns:r="http://schemas.openxmlformats.org/officeDocument/2006/relationships" id="265" r:id="R3ec1c7c04bc7438c"/>
+    <p:sldId xmlns:r="http://schemas.openxmlformats.org/officeDocument/2006/relationships" id="266" r:id="Ra3c0f12cf5734073"/>
+    <p:sldId xmlns:r="http://schemas.openxmlformats.org/officeDocument/2006/relationships" id="267" r:id="Rc1952b0af17f48bc"/>
   </p:sldIdLst>
   <p:sldSz cx="12192000" cy="6858000"/>
   <p:notesSz cx="6858000" cy="9144000"/>
@@ -1566,7 +1566,7 @@
   </p:cSld>
   <p:clrMap bg1="lt1" tx1="dk1" bg2="lt2" tx2="dk2" accent1="accent1" accent2="accent2" accent3="accent3" accent4="accent4" accent5="accent5" accent6="accent6" hlink="hlink" folHlink="folHlink"/>
   <p:sldLayoutIdLst>
-    <p:sldLayoutId xmlns:r="http://schemas.openxmlformats.org/officeDocument/2006/relationships" id="2147483649" r:id="Rb71b4a76308a4c55"/>
+    <p:sldLayoutId xmlns:r="http://schemas.openxmlformats.org/officeDocument/2006/relationships" id="2147483649" r:id="R831d2d7645f047ea"/>
   </p:sldLayoutIdLst>
   <p:txStyles>
     <p:titleStyle>
@@ -2951,7 +2951,7 @@
               <a:buNone/>
               <a:defRPr sz="975" b="1">
                 <a:solidFill>
-                  <a:srgbClr val="FFFFFF"/>
+                  <a:srgbClr val="17234C"/>
                 </a:solidFill>
                 <a:latin typeface="Montserrat"/>
                 <a:ea typeface="Montserrat"/>
@@ -2961,7 +2961,7 @@
             <a:r>
               <a:rPr sz="975" b="1">
                 <a:solidFill>
-                  <a:srgbClr val="FFFFFF"/>
+                  <a:srgbClr val="17234C"/>
                 </a:solidFill>
                 <a:latin typeface="Montserrat"/>
                 <a:ea typeface="Montserrat"/>
@@ -3010,7 +3010,7 @@
               <a:buNone/>
               <a:defRPr sz="900" b="0">
                 <a:solidFill>
-                  <a:srgbClr val="FFFFFF"/>
+                  <a:srgbClr val="17234C"/>
                 </a:solidFill>
                 <a:latin typeface="Noto Sans"/>
                 <a:ea typeface="Noto Sans"/>
@@ -3020,7 +3020,7 @@
             <a:r>
               <a:rPr sz="900" b="0">
                 <a:solidFill>
-                  <a:srgbClr val="FFFFFF"/>
+                  <a:srgbClr val="17234C"/>
                 </a:solidFill>
                 <a:latin typeface="Noto Sans"/>
                 <a:ea typeface="Noto Sans"/>
@@ -9860,7 +9860,7 @@
               <a:buNone/>
               <a:defRPr sz="900" b="1">
                 <a:solidFill>
-                  <a:srgbClr val="FF7A45"/>
+                  <a:srgbClr val="FFFFFF"/>
                 </a:solidFill>
                 <a:latin typeface="Montserrat"/>
                 <a:ea typeface="Montserrat"/>
@@ -9870,7 +9870,7 @@
             <a:r>
               <a:rPr sz="900" b="1">
                 <a:solidFill>
-                  <a:srgbClr val="FF7A45"/>
+                  <a:srgbClr val="FFFFFF"/>
                 </a:solidFill>
                 <a:latin typeface="Montserrat"/>
                 <a:ea typeface="Montserrat"/>
@@ -9919,7 +9919,7 @@
               <a:buNone/>
               <a:defRPr sz="1275" b="1">
                 <a:solidFill>
-                  <a:srgbClr val="17234C"/>
+                  <a:srgbClr val="FFFFFF"/>
                 </a:solidFill>
                 <a:latin typeface="Montserrat"/>
                 <a:ea typeface="Montserrat"/>
@@ -9929,7 +9929,7 @@
             <a:r>
               <a:rPr sz="1275" b="1">
                 <a:solidFill>
-                  <a:srgbClr val="17234C"/>
+                  <a:srgbClr val="FFFFFF"/>
                 </a:solidFill>
                 <a:latin typeface="Montserrat"/>
                 <a:ea typeface="Montserrat"/>
@@ -9978,7 +9978,7 @@
               <a:buNone/>
               <a:defRPr sz="1050" b="1">
                 <a:solidFill>
-                  <a:srgbClr val="17234C"/>
+                  <a:srgbClr val="FFFFFF"/>
                 </a:solidFill>
                 <a:latin typeface="Noto Sans"/>
                 <a:ea typeface="Noto Sans"/>
@@ -9988,7 +9988,7 @@
             <a:r>
               <a:rPr sz="1050" b="1">
                 <a:solidFill>
-                  <a:srgbClr val="17234C"/>
+                  <a:srgbClr val="FFFFFF"/>
                 </a:solidFill>
                 <a:latin typeface="Noto Sans"/>
                 <a:ea typeface="Noto Sans"/>
@@ -10002,7 +10002,7 @@
               <a:buNone/>
               <a:defRPr sz="1050" b="1">
                 <a:solidFill>
-                  <a:srgbClr val="17234C"/>
+                  <a:srgbClr val="FFFFFF"/>
                 </a:solidFill>
                 <a:latin typeface="Noto Sans"/>
                 <a:ea typeface="Noto Sans"/>
@@ -10012,7 +10012,7 @@
             <a:r>
               <a:rPr sz="1050" b="1">
                 <a:solidFill>
-                  <a:srgbClr val="17234C"/>
+                  <a:srgbClr val="FFFFFF"/>
                 </a:solidFill>
                 <a:latin typeface="Noto Sans"/>
                 <a:ea typeface="Noto Sans"/>
@@ -10092,7 +10092,7 @@
               <a:buNone/>
               <a:defRPr sz="1350" b="1">
                 <a:solidFill>
-                  <a:srgbClr val="33BF82"/>
+                  <a:srgbClr val="FFFFFF"/>
                 </a:solidFill>
                 <a:latin typeface="Montserrat"/>
                 <a:ea typeface="Montserrat"/>
@@ -10102,7 +10102,7 @@
             <a:r>
               <a:rPr sz="1350" b="1">
                 <a:solidFill>
-                  <a:srgbClr val="33BF82"/>
+                  <a:srgbClr val="FFFFFF"/>
                 </a:solidFill>
                 <a:latin typeface="Montserrat"/>
                 <a:ea typeface="Montserrat"/>
@@ -13819,7 +13819,7 @@
               <a:buNone/>
               <a:defRPr sz="900" b="1">
                 <a:solidFill>
-                  <a:srgbClr val="FF7A45"/>
+                  <a:srgbClr val="FFFFFF"/>
                 </a:solidFill>
                 <a:latin typeface="Montserrat"/>
                 <a:ea typeface="Montserrat"/>
@@ -13829,7 +13829,7 @@
             <a:r>
               <a:rPr sz="900" b="1">
                 <a:solidFill>
-                  <a:srgbClr val="FF7A45"/>
+                  <a:srgbClr val="FFFFFF"/>
                 </a:solidFill>
                 <a:latin typeface="Montserrat"/>
                 <a:ea typeface="Montserrat"/>
@@ -13878,7 +13878,7 @@
               <a:buNone/>
               <a:defRPr sz="1275" b="1">
                 <a:solidFill>
-                  <a:srgbClr val="17234C"/>
+                  <a:srgbClr val="FFFFFF"/>
                 </a:solidFill>
                 <a:latin typeface="Montserrat"/>
                 <a:ea typeface="Montserrat"/>
@@ -13888,7 +13888,7 @@
             <a:r>
               <a:rPr sz="1275" b="1">
                 <a:solidFill>
-                  <a:srgbClr val="17234C"/>
+                  <a:srgbClr val="FFFFFF"/>
                 </a:solidFill>
                 <a:latin typeface="Montserrat"/>
                 <a:ea typeface="Montserrat"/>
@@ -13937,7 +13937,7 @@
               <a:buNone/>
               <a:defRPr sz="1050" b="1">
                 <a:solidFill>
-                  <a:srgbClr val="17234C"/>
+                  <a:srgbClr val="FFFFFF"/>
                 </a:solidFill>
                 <a:latin typeface="Noto Sans"/>
                 <a:ea typeface="Noto Sans"/>
@@ -13947,7 +13947,7 @@
             <a:r>
               <a:rPr sz="1050" b="1">
                 <a:solidFill>
-                  <a:srgbClr val="17234C"/>
+                  <a:srgbClr val="FFFFFF"/>
                 </a:solidFill>
                 <a:latin typeface="Noto Sans"/>
                 <a:ea typeface="Noto Sans"/>
@@ -13961,7 +13961,7 @@
               <a:buNone/>
               <a:defRPr sz="1050" b="1">
                 <a:solidFill>
-                  <a:srgbClr val="17234C"/>
+                  <a:srgbClr val="FFFFFF"/>
                 </a:solidFill>
                 <a:latin typeface="Noto Sans"/>
                 <a:ea typeface="Noto Sans"/>
@@ -13971,7 +13971,7 @@
             <a:r>
               <a:rPr sz="1050" b="1">
                 <a:solidFill>
-                  <a:srgbClr val="17234C"/>
+                  <a:srgbClr val="FFFFFF"/>
                 </a:solidFill>
                 <a:latin typeface="Noto Sans"/>
                 <a:ea typeface="Noto Sans"/>
@@ -14051,7 +14051,7 @@
               <a:buNone/>
               <a:defRPr sz="1350" b="1">
                 <a:solidFill>
-                  <a:srgbClr val="33BF82"/>
+                  <a:srgbClr val="FFFFFF"/>
                 </a:solidFill>
                 <a:latin typeface="Montserrat"/>
                 <a:ea typeface="Montserrat"/>
@@ -14061,7 +14061,7 @@
             <a:r>
               <a:rPr sz="1350" b="1">
                 <a:solidFill>
-                  <a:srgbClr val="33BF82"/>
+                  <a:srgbClr val="FFFFFF"/>
                 </a:solidFill>
                 <a:latin typeface="Montserrat"/>
                 <a:ea typeface="Montserrat"/>
@@ -14787,7 +14787,7 @@
               <a:buNone/>
               <a:defRPr sz="1125" b="1">
                 <a:solidFill>
-                  <a:srgbClr val="FF7A45"/>
+                  <a:srgbClr val="FFFFFF"/>
                 </a:solidFill>
                 <a:latin typeface="Montserrat"/>
                 <a:ea typeface="Montserrat"/>
@@ -14797,7 +14797,7 @@
             <a:r>
               <a:rPr sz="1125" b="1">
                 <a:solidFill>
-                  <a:srgbClr val="FF7A45"/>
+                  <a:srgbClr val="FFFFFF"/>
                 </a:solidFill>
                 <a:latin typeface="Montserrat"/>
                 <a:ea typeface="Montserrat"/>
@@ -14909,7 +14909,7 @@
               <a:buNone/>
               <a:defRPr sz="1125" b="1">
                 <a:solidFill>
-                  <a:srgbClr val="FF7A45"/>
+                  <a:srgbClr val="FFFFFF"/>
                 </a:solidFill>
                 <a:latin typeface="Montserrat"/>
                 <a:ea typeface="Montserrat"/>
@@ -14919,7 +14919,7 @@
             <a:r>
               <a:rPr sz="1125" b="1">
                 <a:solidFill>
-                  <a:srgbClr val="FF7A45"/>
+                  <a:srgbClr val="FFFFFF"/>
                 </a:solidFill>
                 <a:latin typeface="Montserrat"/>
                 <a:ea typeface="Montserrat"/>
@@ -15031,7 +15031,7 @@
               <a:buNone/>
               <a:defRPr sz="1125" b="1">
                 <a:solidFill>
-                  <a:srgbClr val="33BF82"/>
+                  <a:srgbClr val="FFFFFF"/>
                 </a:solidFill>
                 <a:latin typeface="Montserrat"/>
                 <a:ea typeface="Montserrat"/>
@@ -15041,7 +15041,7 @@
             <a:r>
               <a:rPr sz="1125" b="1">
                 <a:solidFill>
-                  <a:srgbClr val="33BF82"/>
+                  <a:srgbClr val="FFFFFF"/>
                 </a:solidFill>
                 <a:latin typeface="Montserrat"/>
                 <a:ea typeface="Montserrat"/>
@@ -15161,7 +15161,7 @@
           <p:nvPr/>
         </p:nvPicPr>
         <p:blipFill>
-          <a:blip xmlns:r="http://schemas.openxmlformats.org/officeDocument/2006/relationships" xmlns:a="http://schemas.openxmlformats.org/drawingml/2006/main" r:embed="Rb62e64b6584c411a"/>
+          <a:blip xmlns:r="http://schemas.openxmlformats.org/officeDocument/2006/relationships" xmlns:a="http://schemas.openxmlformats.org/drawingml/2006/main" r:embed="R4b56819ab4284b94"/>
           <a:stretch xmlns:a="http://schemas.openxmlformats.org/drawingml/2006/main"/>
         </p:blipFill>
         <p:spPr>
@@ -15236,7 +15236,7 @@
                 <a:latin typeface="Montserrat"/>
                 <a:ea typeface="Montserrat"/>
                 <a:cs typeface="Montserrat"/>
-                <a:hlinkClick xmlns:r="http://schemas.openxmlformats.org/officeDocument/2006/relationships" r:id="R4060e70668244060"/>
+                <a:hlinkClick xmlns:r="http://schemas.openxmlformats.org/officeDocument/2006/relationships" r:id="R6844438907d94cc3"/>
               </a:rPr>
               <a:t>TEMPÉRATURE 0,1</a:t>
             </a:r>
@@ -15305,7 +15305,7 @@
                 <a:latin typeface="Montserrat"/>
                 <a:ea typeface="Montserrat"/>
                 <a:cs typeface="Montserrat"/>
-                <a:hlinkClick xmlns:r="http://schemas.openxmlformats.org/officeDocument/2006/relationships" r:id="Rb16ddbfed0564566"/>
+                <a:hlinkClick xmlns:r="http://schemas.openxmlformats.org/officeDocument/2006/relationships" r:id="R0b78160179b54897"/>
               </a:rPr>
               <a:t>SOURCES DISTINCTES</a:t>
             </a:r>
@@ -17150,7 +17150,7 @@
               <a:buNone/>
               <a:defRPr sz="900" b="1">
                 <a:solidFill>
-                  <a:srgbClr val="6847FF"/>
+                  <a:srgbClr val="FFFFFF"/>
                 </a:solidFill>
                 <a:latin typeface="Montserrat"/>
                 <a:ea typeface="Montserrat"/>
@@ -17160,7 +17160,7 @@
             <a:r>
               <a:rPr sz="900" b="1">
                 <a:solidFill>
-                  <a:srgbClr val="6847FF"/>
+                  <a:srgbClr val="FFFFFF"/>
                 </a:solidFill>
                 <a:latin typeface="Montserrat"/>
                 <a:ea typeface="Montserrat"/>
@@ -17209,7 +17209,7 @@
               <a:buNone/>
               <a:defRPr sz="1275" b="1">
                 <a:solidFill>
-                  <a:srgbClr val="17234C"/>
+                  <a:srgbClr val="FFFFFF"/>
                 </a:solidFill>
                 <a:latin typeface="Montserrat"/>
                 <a:ea typeface="Montserrat"/>
@@ -17219,7 +17219,7 @@
             <a:r>
               <a:rPr sz="1275" b="1">
                 <a:solidFill>
-                  <a:srgbClr val="17234C"/>
+                  <a:srgbClr val="FFFFFF"/>
                 </a:solidFill>
                 <a:latin typeface="Montserrat"/>
                 <a:ea typeface="Montserrat"/>
@@ -17268,7 +17268,7 @@
               <a:buNone/>
               <a:defRPr sz="1050" b="1">
                 <a:solidFill>
-                  <a:srgbClr val="17234C"/>
+                  <a:srgbClr val="FFFFFF"/>
                 </a:solidFill>
                 <a:latin typeface="Noto Sans"/>
                 <a:ea typeface="Noto Sans"/>
@@ -17278,7 +17278,7 @@
             <a:r>
               <a:rPr sz="1050" b="1">
                 <a:solidFill>
-                  <a:srgbClr val="17234C"/>
+                  <a:srgbClr val="FFFFFF"/>
                 </a:solidFill>
                 <a:latin typeface="Noto Sans"/>
                 <a:ea typeface="Noto Sans"/>
@@ -17358,7 +17358,7 @@
               <a:buNone/>
               <a:defRPr sz="1350" b="1">
                 <a:solidFill>
-                  <a:srgbClr val="33BF82"/>
+                  <a:srgbClr val="FFFFFF"/>
                 </a:solidFill>
                 <a:latin typeface="Montserrat"/>
                 <a:ea typeface="Montserrat"/>
@@ -17368,7 +17368,7 @@
             <a:r>
               <a:rPr sz="1350" b="1">
                 <a:solidFill>
-                  <a:srgbClr val="33BF82"/>
+                  <a:srgbClr val="FFFFFF"/>
                 </a:solidFill>
                 <a:latin typeface="Montserrat"/>
                 <a:ea typeface="Montserrat"/>
@@ -18094,7 +18094,7 @@
               <a:buNone/>
               <a:defRPr sz="1125" b="1">
                 <a:solidFill>
-                  <a:srgbClr val="FF7A45"/>
+                  <a:srgbClr val="FFFFFF"/>
                 </a:solidFill>
                 <a:latin typeface="Montserrat"/>
                 <a:ea typeface="Montserrat"/>
@@ -18104,7 +18104,7 @@
             <a:r>
               <a:rPr sz="1125" b="1">
                 <a:solidFill>
-                  <a:srgbClr val="FF7A45"/>
+                  <a:srgbClr val="FFFFFF"/>
                 </a:solidFill>
                 <a:latin typeface="Montserrat"/>
                 <a:ea typeface="Montserrat"/>
@@ -18216,7 +18216,7 @@
               <a:buNone/>
               <a:defRPr sz="1125" b="1">
                 <a:solidFill>
-                  <a:srgbClr val="FF7A45"/>
+                  <a:srgbClr val="FFFFFF"/>
                 </a:solidFill>
                 <a:latin typeface="Montserrat"/>
                 <a:ea typeface="Montserrat"/>
@@ -18226,7 +18226,7 @@
             <a:r>
               <a:rPr sz="1125" b="1">
                 <a:solidFill>
-                  <a:srgbClr val="FF7A45"/>
+                  <a:srgbClr val="FFFFFF"/>
                 </a:solidFill>
                 <a:latin typeface="Montserrat"/>
                 <a:ea typeface="Montserrat"/>
@@ -18338,7 +18338,7 @@
               <a:buNone/>
               <a:defRPr sz="1125" b="1">
                 <a:solidFill>
-                  <a:srgbClr val="33BF82"/>
+                  <a:srgbClr val="FFFFFF"/>
                 </a:solidFill>
                 <a:latin typeface="Montserrat"/>
                 <a:ea typeface="Montserrat"/>
@@ -18348,7 +18348,7 @@
             <a:r>
               <a:rPr sz="1125" b="1">
                 <a:solidFill>
-                  <a:srgbClr val="33BF82"/>
+                  <a:srgbClr val="FFFFFF"/>
                 </a:solidFill>
                 <a:latin typeface="Montserrat"/>
                 <a:ea typeface="Montserrat"/>
@@ -18468,7 +18468,7 @@
           <p:nvPr/>
         </p:nvPicPr>
         <p:blipFill>
-          <a:blip xmlns:r="http://schemas.openxmlformats.org/officeDocument/2006/relationships" xmlns:a="http://schemas.openxmlformats.org/drawingml/2006/main" r:embed="R400fbf218463405b"/>
+          <a:blip xmlns:r="http://schemas.openxmlformats.org/officeDocument/2006/relationships" xmlns:a="http://schemas.openxmlformats.org/drawingml/2006/main" r:embed="R6b569ac3944242bd"/>
           <a:srcRect xmlns:a="http://schemas.openxmlformats.org/drawingml/2006/main" l="5000" t="0" r="5000" b="0"/>
           <a:stretch xmlns:a="http://schemas.openxmlformats.org/drawingml/2006/main">
             <a:fillRect l="0" t="0" r="0" b="0"/>
@@ -18546,7 +18546,7 @@
                 <a:latin typeface="Montserrat"/>
                 <a:ea typeface="Montserrat"/>
                 <a:cs typeface="Montserrat"/>
-                <a:hlinkClick xmlns:r="http://schemas.openxmlformats.org/officeDocument/2006/relationships" r:id="R1186b270f0794084"/>
+                <a:hlinkClick xmlns:r="http://schemas.openxmlformats.org/officeDocument/2006/relationships" r:id="R7343f8f3aeb44311"/>
               </a:rPr>
               <a:t>DOCKER COMPOSE</a:t>
             </a:r>
@@ -18615,7 +18615,7 @@
                 <a:latin typeface="Montserrat"/>
                 <a:ea typeface="Montserrat"/>
                 <a:cs typeface="Montserrat"/>
-                <a:hlinkClick xmlns:r="http://schemas.openxmlformats.org/officeDocument/2006/relationships" r:id="R759438e076d242c5"/>
+                <a:hlinkClick xmlns:r="http://schemas.openxmlformats.org/officeDocument/2006/relationships" r:id="R0cc91732c0cc4dd5"/>
               </a:rPr>
               <a:t>SWAGGER /docs</a:t>
             </a:r>
@@ -20140,7 +20140,7 @@
                 <a:latin typeface="Montserrat"/>
                 <a:ea typeface="Montserrat"/>
                 <a:cs typeface="Montserrat"/>
-                <a:hlinkClick xmlns:r="http://schemas.openxmlformats.org/officeDocument/2006/relationships" r:id="R1002320bc2b04cd8"/>
+                <a:hlinkClick xmlns:r="http://schemas.openxmlformats.org/officeDocument/2006/relationships" r:id="Rdc0d2bd3f0bb4434"/>
               </a:rPr>
               <a:t>API</a:t>
             </a:r>
@@ -20209,7 +20209,7 @@
                 <a:latin typeface="Montserrat"/>
                 <a:ea typeface="Montserrat"/>
                 <a:cs typeface="Montserrat"/>
-                <a:hlinkClick xmlns:r="http://schemas.openxmlformats.org/officeDocument/2006/relationships" r:id="R9697debca81842ce"/>
+                <a:hlinkClick xmlns:r="http://schemas.openxmlformats.org/officeDocument/2006/relationships" r:id="R2ef9d6a475dc4c6d"/>
               </a:rPr>
               <a:t>SOURCES</a:t>
             </a:r>
@@ -20278,7 +20278,7 @@
                 <a:latin typeface="Montserrat"/>
                 <a:ea typeface="Montserrat"/>
                 <a:cs typeface="Montserrat"/>
-                <a:hlinkClick xmlns:r="http://schemas.openxmlformats.org/officeDocument/2006/relationships" r:id="R6267e6adce514204"/>
+                <a:hlinkClick xmlns:r="http://schemas.openxmlformats.org/officeDocument/2006/relationships" r:id="Rf96b4979790041db"/>
               </a:rPr>
               <a:t>PRUDENCE</a:t>
             </a:r>
@@ -20347,7 +20347,7 @@
                 <a:latin typeface="Montserrat"/>
                 <a:ea typeface="Montserrat"/>
                 <a:cs typeface="Montserrat"/>
-                <a:hlinkClick xmlns:r="http://schemas.openxmlformats.org/officeDocument/2006/relationships" r:id="Ra0d036a237fd45c1"/>
+                <a:hlinkClick xmlns:r="http://schemas.openxmlformats.org/officeDocument/2006/relationships" r:id="R520f488127a54c0a"/>
               </a:rPr>
               <a:t>DOCKER</a:t>
             </a:r>

</xml_diff>

<commit_message>
fix: fiabiliser la démo et publier les livrables de soutenance
</commit_message>
<xml_diff>
--- a/outputs/openagenda-rag-soutenance.pptx
+++ b/outputs/openagenda-rag-soutenance.pptx
@@ -2,24 +2,24 @@
 <file path=ppt/presentation.xml><?xml version="1.0" encoding="utf-8"?>
 <p:presentation xmlns:p="http://schemas.openxmlformats.org/presentationml/2006/main">
   <p:sldMasterIdLst>
-    <p:sldMasterId xmlns:r="http://schemas.openxmlformats.org/officeDocument/2006/relationships" id="2147483648" r:id="R023b6907214645d4"/>
+    <p:sldMasterId xmlns:r="http://schemas.openxmlformats.org/officeDocument/2006/relationships" id="2147483648" r:id="R6a8fbe256a314e47"/>
   </p:sldMasterIdLst>
   <p:notesMasterIdLst>
-    <p:notesMasterId xmlns:r="http://schemas.openxmlformats.org/officeDocument/2006/relationships" r:id="R136f33c4591740ee"/>
+    <p:notesMasterId xmlns:r="http://schemas.openxmlformats.org/officeDocument/2006/relationships" r:id="R7fe5560f40fe46c4"/>
   </p:notesMasterIdLst>
   <p:sldIdLst>
-    <p:sldId xmlns:r="http://schemas.openxmlformats.org/officeDocument/2006/relationships" id="256" r:id="Ra7f3c216dfb840da"/>
-    <p:sldId xmlns:r="http://schemas.openxmlformats.org/officeDocument/2006/relationships" id="257" r:id="R732b5935a44f4c01"/>
-    <p:sldId xmlns:r="http://schemas.openxmlformats.org/officeDocument/2006/relationships" id="258" r:id="R0a1911443d914d9e"/>
-    <p:sldId xmlns:r="http://schemas.openxmlformats.org/officeDocument/2006/relationships" id="259" r:id="Raef1e9973e104108"/>
-    <p:sldId xmlns:r="http://schemas.openxmlformats.org/officeDocument/2006/relationships" id="260" r:id="R1d0459a0ccee4535"/>
-    <p:sldId xmlns:r="http://schemas.openxmlformats.org/officeDocument/2006/relationships" id="261" r:id="R2466ced80d4b441b"/>
-    <p:sldId xmlns:r="http://schemas.openxmlformats.org/officeDocument/2006/relationships" id="262" r:id="Rd17ce74b47e74c79"/>
-    <p:sldId xmlns:r="http://schemas.openxmlformats.org/officeDocument/2006/relationships" id="263" r:id="R9e92b42d126a4cb7"/>
-    <p:sldId xmlns:r="http://schemas.openxmlformats.org/officeDocument/2006/relationships" id="264" r:id="R9e3afb61f5a54134"/>
-    <p:sldId xmlns:r="http://schemas.openxmlformats.org/officeDocument/2006/relationships" id="265" r:id="R3ec1c7c04bc7438c"/>
-    <p:sldId xmlns:r="http://schemas.openxmlformats.org/officeDocument/2006/relationships" id="266" r:id="Ra3c0f12cf5734073"/>
-    <p:sldId xmlns:r="http://schemas.openxmlformats.org/officeDocument/2006/relationships" id="267" r:id="Rc1952b0af17f48bc"/>
+    <p:sldId xmlns:r="http://schemas.openxmlformats.org/officeDocument/2006/relationships" id="256" r:id="Rccb5c49d54b645ba"/>
+    <p:sldId xmlns:r="http://schemas.openxmlformats.org/officeDocument/2006/relationships" id="257" r:id="R333589e2f24e4976"/>
+    <p:sldId xmlns:r="http://schemas.openxmlformats.org/officeDocument/2006/relationships" id="258" r:id="R7da47506f2e94179"/>
+    <p:sldId xmlns:r="http://schemas.openxmlformats.org/officeDocument/2006/relationships" id="259" r:id="R403d53b9ecfb4732"/>
+    <p:sldId xmlns:r="http://schemas.openxmlformats.org/officeDocument/2006/relationships" id="260" r:id="R15d30d183d8c47a5"/>
+    <p:sldId xmlns:r="http://schemas.openxmlformats.org/officeDocument/2006/relationships" id="261" r:id="Re32567accb2a42e2"/>
+    <p:sldId xmlns:r="http://schemas.openxmlformats.org/officeDocument/2006/relationships" id="262" r:id="R44037b23f42d4317"/>
+    <p:sldId xmlns:r="http://schemas.openxmlformats.org/officeDocument/2006/relationships" id="263" r:id="R054b16c23fd84cb0"/>
+    <p:sldId xmlns:r="http://schemas.openxmlformats.org/officeDocument/2006/relationships" id="264" r:id="R02302282292e477a"/>
+    <p:sldId xmlns:r="http://schemas.openxmlformats.org/officeDocument/2006/relationships" id="265" r:id="Re98d3fb59f444e3f"/>
+    <p:sldId xmlns:r="http://schemas.openxmlformats.org/officeDocument/2006/relationships" id="266" r:id="R871bba280d4d4d50"/>
+    <p:sldId xmlns:r="http://schemas.openxmlformats.org/officeDocument/2006/relationships" id="267" r:id="R84cf7f04a2e6446b"/>
   </p:sldIdLst>
   <p:sldSz cx="12192000" cy="6858000"/>
   <p:notesSz cx="6858000" cy="9144000"/>
@@ -548,22 +548,112 @@
           <a:lstStyle xmlns:a="http://schemas.openxmlformats.org/drawingml/2006/main"/>
           <a:p xmlns:a="http://schemas.openxmlformats.org/drawingml/2006/main">
             <a:r>
-              <a:t>Durée cible : 50 secondes.</a:t>
-            </a:r>
-          </a:p>
-          <a:p xmlns:a="http://schemas.openxmlformats.org/drawingml/2006/main">
-            <a:r>
-              <a:t>Bonjour Jérémy. Mon objectif est de démontrer qu’un assistant peut recommander des événements réels sans en inventer.</a:t>
-            </a:r>
-          </a:p>
-          <a:p xmlns:a="http://schemas.openxmlformats.org/drawingml/2006/main">
-            <a:r>
-              <a:t>Le POC part de 7 586 événements, les transforme en 14 903 passages FAISS, puis les expose dans une API Docker testée 59 fois.</a:t>
-            </a:r>
-          </a:p>
-          <a:p xmlns:a="http://schemas.openxmlformats.org/drawingml/2006/main">
-            <a:r>
-              <a:t>La décision attendue est un pilote mesuré, pas une production immédiate.</a:t>
+              <a:t>00:00–00:45 (45 s)</a:t>
+            </a:r>
+          </a:p>
+          <a:p xmlns:a="http://schemas.openxmlformats.org/drawingml/2006/main">
+            <a:r>
+              <a:t/>
+            </a:r>
+          </a:p>
+          <a:p xmlns:a="http://schemas.openxmlformats.org/drawingml/2006/main">
+            <a:r>
+              <a:t>À LIRE</a:t>
+            </a:r>
+          </a:p>
+          <a:p xmlns:a="http://schemas.openxmlformats.org/drawingml/2006/main">
+            <a:r>
+              <a:t>Bonjour Jérémy. Je vais vous présenter le prototype réalisé pour Puls-Events, un assistant de recommandation culturelle qui utilise les événements OpenAgenda. Le besoin est de permettre aux utilisateurs de poser une question naturellement, puis de recevoir une réponse qu'ils peuvent vérifier grâce aux sources. Mon livrable couvre toute la chaîne : collecte et préparation des données, recherche vectorielle, génération de réponse, API et conteneur Docker. Le corpus livré contient 7 586 événements parisiens. Il s'agit d'un POC, donc d'une preuve de faisabilité. Je vais expliquer les choix, montrer l'API et présenter les résultats ainsi que les limites avant un déploiement plus large.</a:t>
+            </a:r>
+          </a:p>
+          <a:p xmlns:a="http://schemas.openxmlformats.org/drawingml/2006/main">
+            <a:r>
+              <a:t/>
+            </a:r>
+          </a:p>
+          <a:p xmlns:a="http://schemas.openxmlformats.org/drawingml/2006/main">
+            <a:r>
+              <a:t>À MONTRER</a:t>
+            </a:r>
+          </a:p>
+          <a:p xmlns:a="http://schemas.openxmlformats.org/drawingml/2006/main">
+            <a:r>
+              <a:t>Partage uniquement la fenêtre du diaporama. Garde ce guide hors du partage.</a:t>
+            </a:r>
+          </a:p>
+          <a:p xmlns:a="http://schemas.openxmlformats.org/drawingml/2006/main">
+            <a:r>
+              <a:t/>
+            </a:r>
+          </a:p>
+          <a:p xmlns:a="http://schemas.openxmlformats.org/drawingml/2006/main">
+            <a:r>
+              <a:t>COMPRENDRE</a:t>
+            </a:r>
+          </a:p>
+          <a:p xmlns:a="http://schemas.openxmlformats.org/drawingml/2006/main">
+            <a:r>
+              <a:t>Tu joues le rôle du freelance qui livre un prototype à son client. Jérémy est le responsable technique. Tu présentes une solution testable, avec ses preuves et ses limites. POC signifie preuve de concept : vérifier que l'idée fonctionne avant de construire un produit à grande échelle.</a:t>
+            </a:r>
+          </a:p>
+          <a:p xmlns:a="http://schemas.openxmlformats.org/drawingml/2006/main">
+            <a:r>
+              <a:t/>
+            </a:r>
+          </a:p>
+          <a:p xmlns:a="http://schemas.openxmlformats.org/drawingml/2006/main">
+            <a:r>
+              <a:t>DÉTAIL TECHNIQUE</a:t>
+            </a:r>
+          </a:p>
+          <a:p xmlns:a="http://schemas.openxmlformats.org/drawingml/2006/main">
+            <a:r>
+              <a:t>Le brief demande LangChain, Mistral, FAISS, une API, les scripts de reconstruction, des tests, un jeu annoté, un rapport, Docker et une démo. L'historique de conversation n'est pas nécessaire. Le modèle n'a pas été entraîné ou ajusté dans ce projet.</a:t>
+            </a:r>
+          </a:p>
+          <a:p xmlns:a="http://schemas.openxmlformats.org/drawingml/2006/main">
+            <a:r>
+              <a:t/>
+            </a:r>
+          </a:p>
+          <a:p xmlns:a="http://schemas.openxmlformats.org/drawingml/2006/main">
+            <a:r>
+              <a:t>PIÈGE</a:t>
+            </a:r>
+          </a:p>
+          <a:p xmlns:a="http://schemas.openxmlformats.org/drawingml/2006/main">
+            <a:r>
+              <a:t>Ne dis pas que c'est déjà un produit en production ni que tu as entraîné Mistral.</a:t>
+            </a:r>
+          </a:p>
+          <a:p xmlns:a="http://schemas.openxmlformats.org/drawingml/2006/main">
+            <a:r>
+              <a:t/>
+            </a:r>
+          </a:p>
+          <a:p xmlns:a="http://schemas.openxmlformats.org/drawingml/2006/main">
+            <a:r>
+              <a:t>PREUVE</a:t>
+            </a:r>
+          </a:p>
+          <a:p xmlns:a="http://schemas.openxmlformats.org/drawingml/2006/main">
+            <a:r>
+              <a:t>README.md ; document de mission, message de Jérémy ; seed-data/processed/fetch_manifest.json.</a:t>
+            </a:r>
+          </a:p>
+          <a:p xmlns:a="http://schemas.openxmlformats.org/drawingml/2006/main">
+            <a:r>
+              <a:t/>
+            </a:r>
+          </a:p>
+          <a:p xmlns:a="http://schemas.openxmlformats.org/drawingml/2006/main">
+            <a:r>
+              <a:t>TRANSITION</a:t>
+            </a:r>
+          </a:p>
+          <a:p xmlns:a="http://schemas.openxmlformats.org/drawingml/2006/main">
+            <a:r>
+              <a:t>Commençons par le risque métier que le RAG cherche à réduire.</a:t>
             </a:r>
           </a:p>
         </p:txBody>
@@ -633,22 +723,112 @@
           <a:lstStyle xmlns:a="http://schemas.openxmlformats.org/drawingml/2006/main"/>
           <a:p xmlns:a="http://schemas.openxmlformats.org/drawingml/2006/main">
             <a:r>
-              <a:t>Durée cible : 80 secondes.</a:t>
-            </a:r>
-          </a:p>
-          <a:p xmlns:a="http://schemas.openxmlformats.org/drawingml/2006/main">
-            <a:r>
-              <a:t>RAGAS compare question, contextes, réponse générée et réponse de référence. Il distingue retrieval et génération.</a:t>
-            </a:r>
-          </a:p>
-          <a:p xmlns:a="http://schemas.openxmlformats.org/drawingml/2006/main">
-            <a:r>
-              <a:t>La fidélité, la pertinence et la précision du contexte sont prometteuses sur trois cas.</a:t>
-            </a:r>
-          </a:p>
-          <a:p xmlns:a="http://schemas.openxmlformats.org/drawingml/2006/main">
-            <a:r>
-              <a:t>La correction à 0,683 est la priorité : je dois structurer la réponse et élargir le benchmark, pas changer de modèle à l’aveugle.</a:t>
+              <a:t>11:00–12:40 (100 s)</a:t>
+            </a:r>
+          </a:p>
+          <a:p xmlns:a="http://schemas.openxmlformats.org/drawingml/2006/main">
+            <a:r>
+              <a:t/>
+            </a:r>
+          </a:p>
+          <a:p xmlns:a="http://schemas.openxmlformats.org/drawingml/2006/main">
+            <a:r>
+              <a:t>À LIRE</a:t>
+            </a:r>
+          </a:p>
+          <a:p xmlns:a="http://schemas.openxmlformats.org/drawingml/2006/main">
+            <a:r>
+              <a:t>L'évaluation RAGAS porte sur trois cas : Concert Fishers, le Salon de la Photo et une sortie en famille avec visite théâtralisée. Pour chaque cas, je conserve la question, les passages réellement transmis au modèle, la réponse et une référence humaine. Un modèle juge calcule quatre métriques. La fidélité mesure si la réponse est soutenue par le contexte. La pertinence mesure son adéquation à la question. La précision du contexte apprécie la pertinence et le classement des passages récupérés ; elle ne mesure pas la couverture de tout le catalogue. La correction compare la réponse à la référence. Les moyennes enregistrées le 23 juillet sont 0,900, 0,846, 1,000 et 0,683. Le dernier score montre que des écarts demeurent même avec un contexte utile. Sur le cas famille, le score de correction est d'environ 0,581 et la réponse ajoute des informations pratiques à vérifier. La priorité est donc de mieux cadrer la réponse, contrôler les faits et élargir le jeu d'évaluation. Trois exemples démontrent la méthode, pas la performance générale.</a:t>
+            </a:r>
+          </a:p>
+          <a:p xmlns:a="http://schemas.openxmlformats.org/drawingml/2006/main">
+            <a:r>
+              <a:t/>
+            </a:r>
+          </a:p>
+          <a:p xmlns:a="http://schemas.openxmlformats.org/drawingml/2006/main">
+            <a:r>
+              <a:t>À MONTRER</a:t>
+            </a:r>
+          </a:p>
+          <a:p xmlns:a="http://schemas.openxmlformats.org/drawingml/2006/main">
+            <a:r>
+              <a:t>Lis les quatre scores avec leur sens, puis donne la limite du petit échantillon. En discussion, ouvre les exemples RAGAS du rapport.</a:t>
+            </a:r>
+          </a:p>
+          <a:p xmlns:a="http://schemas.openxmlformats.org/drawingml/2006/main">
+            <a:r>
+              <a:t/>
+            </a:r>
+          </a:p>
+          <a:p xmlns:a="http://schemas.openxmlformats.org/drawingml/2006/main">
+            <a:r>
+              <a:t>COMPRENDRE</a:t>
+            </a:r>
+          </a:p>
+          <a:p xmlns:a="http://schemas.openxmlformats.org/drawingml/2006/main">
+            <a:r>
+              <a:t>Fidélité : est-ce écrit dans les fiches ? Pertinence : est-ce que ça répond à la question ? Précision du contexte : les passages utiles arrivent-ils bien placés ? Correction : est-ce conforme à ce que la réponse humaine attend ? Une réponse peut être fidèle à un document, mais incomplète ou mal ciblée.</a:t>
+            </a:r>
+          </a:p>
+          <a:p xmlns:a="http://schemas.openxmlformats.org/drawingml/2006/main">
+            <a:r>
+              <a:t/>
+            </a:r>
+          </a:p>
+          <a:p xmlns:a="http://schemas.openxmlformats.org/drawingml/2006/main">
+            <a:r>
+              <a:t>DÉTAIL TECHNIQUE</a:t>
+            </a:r>
+          </a:p>
+          <a:p xmlns:a="http://schemas.openxmlformats.org/drawingml/2006/main">
+            <a:r>
+              <a:t>RAGAS 0.4.3 ; juge ministral-8b-2512 ; embeddings mistral-embed. Faithfulness juge les affirmations soutenues. ContextPrecision s'appuie sur une référence pour évaluer les contextes récupérés et leur classement : 1,0 ne signifie ni tous les chunks utiles ni rappel parfait. AnswerCorrectness combine comparaison factuelle et similarité. Le script appelle les métriques séquentiellement avec reprises après erreurs transitoires. Les seuils fort≥0,8 et acceptable≥0,6 sont des conventions du projet. Le même fournisseur sert à générer et juger : biais possible, review humaine nécessaire. Les références courtes peuvent pénaliser des développements utiles, mais cela ne justifie pas les faits inventés.</a:t>
+            </a:r>
+          </a:p>
+          <a:p xmlns:a="http://schemas.openxmlformats.org/drawingml/2006/main">
+            <a:r>
+              <a:t/>
+            </a:r>
+          </a:p>
+          <a:p xmlns:a="http://schemas.openxmlformats.org/drawingml/2006/main">
+            <a:r>
+              <a:t>PIÈGE</a:t>
+            </a:r>
+          </a:p>
+          <a:p xmlns:a="http://schemas.openxmlformats.org/drawingml/2006/main">
+            <a:r>
+              <a:t>0,900 n'est pas un taux de satisfaction de 90 %. 1,000 n'est pas un rappel de 100 %. Ces scores historiques n'ont pas été recalculés aujourd'hui.</a:t>
+            </a:r>
+          </a:p>
+          <a:p xmlns:a="http://schemas.openxmlformats.org/drawingml/2006/main">
+            <a:r>
+              <a:t/>
+            </a:r>
+          </a:p>
+          <a:p xmlns:a="http://schemas.openxmlformats.org/drawingml/2006/main">
+            <a:r>
+              <a:t>PREUVE</a:t>
+            </a:r>
+          </a:p>
+          <a:p xmlns:a="http://schemas.openxmlformats.org/drawingml/2006/main">
+            <a:r>
+              <a:t>scripts/evaluate_ragas.py ; src/openagenda_rag/ragas_evaluation.py ; outputs/evaluation/ragas_results.json ; rapport, section 7.</a:t>
+            </a:r>
+          </a:p>
+          <a:p xmlns:a="http://schemas.openxmlformats.org/drawingml/2006/main">
+            <a:r>
+              <a:t/>
+            </a:r>
+          </a:p>
+          <a:p xmlns:a="http://schemas.openxmlformats.org/drawingml/2006/main">
+            <a:r>
+              <a:t>TRANSITION</a:t>
+            </a:r>
+          </a:p>
+          <a:p xmlns:a="http://schemas.openxmlformats.org/drawingml/2006/main">
+            <a:r>
+              <a:t>Ces résultats et la démonstration permettent d'identifier les limites prioritaires.</a:t>
             </a:r>
           </a:p>
         </p:txBody>
@@ -718,22 +898,112 @@
           <a:lstStyle xmlns:a="http://schemas.openxmlformats.org/drawingml/2006/main"/>
           <a:p xmlns:a="http://schemas.openxmlformats.org/drawingml/2006/main">
             <a:r>
-              <a:t>Durée cible : 60 secondes.</a:t>
-            </a:r>
-          </a:p>
-          <a:p xmlns:a="http://schemas.openxmlformats.org/drawingml/2006/main">
-            <a:r>
-              <a:t>Je présente les limites par familles et toujours avec leur action corrective.</a:t>
-            </a:r>
-          </a:p>
-          <a:p xmlns:a="http://schemas.openxmlformats.org/drawingml/2006/main">
-            <a:r>
-              <a:t>Le risque métier principal est une réponse plausible mais incomplète : les sources, la prudence du prompt et un futur seuil métier réduisent ce risque.</a:t>
-            </a:r>
-          </a:p>
-          <a:p xmlns:a="http://schemas.openxmlformats.org/drawingml/2006/main">
-            <a:r>
-              <a:t>Docker prouve la reproductibilité locale, pas l’industrialisation complète.</a:t>
+              <a:t>12:40–13:45 (65 s)</a:t>
+            </a:r>
+          </a:p>
+          <a:p xmlns:a="http://schemas.openxmlformats.org/drawingml/2006/main">
+            <a:r>
+              <a:t/>
+            </a:r>
+          </a:p>
+          <a:p xmlns:a="http://schemas.openxmlformats.org/drawingml/2006/main">
+            <a:r>
+              <a:t>À LIRE</a:t>
+            </a:r>
+          </a:p>
+          <a:p xmlns:a="http://schemas.openxmlformats.org/drawingml/2006/main">
+            <a:r>
+              <a:t>La première limite est le corpus : il est limité à Paris et figé en juillet. Pour recommander des sorties actuelles, il faut automatiser son actualisation et filtrer les dates au moment de la demande. La deuxième concerne la recherche : le top-k renvoie les voisins les plus proches même lorsqu'ils ne répondent pas réellement à la question. Le refus repose alors sur le prompt et le modèle. Un seuil calibré et des filtres explicites seraient plus robustes. La troisième limite est l'exploitation. L'index est local, mais les embeddings de question et la génération appellent Mistral. Aujourd'hui, Mistral Small était limité. La démo a été rétablie avec Ministral 8B, sans changer les embeddings. Les erreurs fournisseur sont désormais contrôlées. Ce nouveau modèle doit être réévalué ; les anciens scores ne lui sont pas attribués. Enfin, trois cas RAGAS restent insuffisants pour conclure à une qualité générale.</a:t>
+            </a:r>
+          </a:p>
+          <a:p xmlns:a="http://schemas.openxmlformats.org/drawingml/2006/main">
+            <a:r>
+              <a:t/>
+            </a:r>
+          </a:p>
+          <a:p xmlns:a="http://schemas.openxmlformats.org/drawingml/2006/main">
+            <a:r>
+              <a:t>À MONTRER</a:t>
+            </a:r>
+          </a:p>
+          <a:p xmlns:a="http://schemas.openxmlformats.org/drawingml/2006/main">
+            <a:r>
+              <a:t>Relie chaque limite à une amélioration. Si la démo enregistrée a été utilisée, rappelle simplement la cause observée.</a:t>
+            </a:r>
+          </a:p>
+          <a:p xmlns:a="http://schemas.openxmlformats.org/drawingml/2006/main">
+            <a:r>
+              <a:t/>
+            </a:r>
+          </a:p>
+          <a:p xmlns:a="http://schemas.openxmlformats.org/drawingml/2006/main">
+            <a:r>
+              <a:t>COMPRENDRE</a:t>
+            </a:r>
+          </a:p>
+          <a:p xmlns:a="http://schemas.openxmlformats.org/drawingml/2006/main">
+            <a:r>
+              <a:t>Tu n'as pas besoin de défendre le prototype comme parfait. Tu dois connaître ses limites, montrer leur effet et proposer une action concrète. La panne initiale a été contournée par un modèle Mistral disponible. Ce changement permet la démo, mais ne prouve pas une qualité équivalente.</a:t>
+            </a:r>
+          </a:p>
+          <a:p xmlns:a="http://schemas.openxmlformats.org/drawingml/2006/main">
+            <a:r>
+              <a:t/>
+            </a:r>
+          </a:p>
+          <a:p xmlns:a="http://schemas.openxmlformats.org/drawingml/2006/main">
+            <a:r>
+              <a:t>DÉTAIL TECHNIQUE</a:t>
+            </a:r>
+          </a:p>
+          <a:p xmlns:a="http://schemas.openxmlformats.org/drawingml/2006/main">
+            <a:r>
+              <a:t>Pas de reranker, recherche hybride, seuil de distance, filtre de métadonnées par question, authentification globale, limitation de débit ni supervision livrés. Reconstruction destructive sur le répertoire cible : pas de bascule atomique et risque de concurrence à traiter en production. Pickle de FAISS chargé avec allow_dangerous_deserialization=True : uniquement artefacts de confiance. Les noms latest et les dépendances transitives non totalement figées limitent la reproductibilité stricte.</a:t>
+            </a:r>
+          </a:p>
+          <a:p xmlns:a="http://schemas.openxmlformats.org/drawingml/2006/main">
+            <a:r>
+              <a:t/>
+            </a:r>
+          </a:p>
+          <a:p xmlns:a="http://schemas.openxmlformats.org/drawingml/2006/main">
+            <a:r>
+              <a:t>PIÈGE</a:t>
+            </a:r>
+          </a:p>
+          <a:p xmlns:a="http://schemas.openxmlformats.org/drawingml/2006/main">
+            <a:r>
+              <a:t>Ne prétends pas que Docker rend le projet entièrement hors ligne, qu'un seuil seul comprend toutes les contraintes, ou que l'API est prête pour une exposition publique.</a:t>
+            </a:r>
+          </a:p>
+          <a:p xmlns:a="http://schemas.openxmlformats.org/drawingml/2006/main">
+            <a:r>
+              <a:t/>
+            </a:r>
+          </a:p>
+          <a:p xmlns:a="http://schemas.openxmlformats.org/drawingml/2006/main">
+            <a:r>
+              <a:t>PREUVE</a:t>
+            </a:r>
+          </a:p>
+          <a:p xmlns:a="http://schemas.openxmlformats.org/drawingml/2006/main">
+            <a:r>
+              <a:t>README.md : limites ; src/openagenda_rag/rag.py ; api.py ; indexing.py ; état de préparation.</a:t>
+            </a:r>
+          </a:p>
+          <a:p xmlns:a="http://schemas.openxmlformats.org/drawingml/2006/main">
+            <a:r>
+              <a:t/>
+            </a:r>
+          </a:p>
+          <a:p xmlns:a="http://schemas.openxmlformats.org/drawingml/2006/main">
+            <a:r>
+              <a:t>TRANSITION</a:t>
+            </a:r>
+          </a:p>
+          <a:p xmlns:a="http://schemas.openxmlformats.org/drawingml/2006/main">
+            <a:r>
+              <a:t>Je propose donc une suite mesurée, fondée sur les risques identifiés.</a:t>
             </a:r>
           </a:p>
         </p:txBody>
@@ -803,22 +1073,112 @@
           <a:lstStyle xmlns:a="http://schemas.openxmlformats.org/drawingml/2006/main"/>
           <a:p xmlns:a="http://schemas.openxmlformats.org/drawingml/2006/main">
             <a:r>
-              <a:t>Durée cible : 55 secondes, puis 40 secondes pour rapport et dépôt.</a:t>
-            </a:r>
-          </a:p>
-          <a:p xmlns:a="http://schemas.openxmlformats.org/drawingml/2006/main">
-            <a:r>
-              <a:t>Le POC couvre les données, l’index FAISS, Mistral, l’API Docker, les tests et la première évaluation RAGAS.</a:t>
-            </a:r>
-          </a:p>
-          <a:p xmlns:a="http://schemas.openxmlformats.org/drawingml/2006/main">
-            <a:r>
-              <a:t>Je recommande un pilote multi-villes mesuré, avec plus de données et de cas annotés avant toute industrialisation large.</a:t>
-            </a:r>
-          </a:p>
-          <a:p xmlns:a="http://schemas.openxmlformats.org/drawingml/2006/main">
-            <a:r>
-              <a:t>Merci. Je suis prêt à répondre aux questions.</a:t>
+              <a:t>13:45–15:00 (75 s)</a:t>
+            </a:r>
+          </a:p>
+          <a:p xmlns:a="http://schemas.openxmlformats.org/drawingml/2006/main">
+            <a:r>
+              <a:t/>
+            </a:r>
+          </a:p>
+          <a:p xmlns:a="http://schemas.openxmlformats.org/drawingml/2006/main">
+            <a:r>
+              <a:t>À LIRE</a:t>
+            </a:r>
+          </a:p>
+          <a:p xmlns:a="http://schemas.openxmlformats.org/drawingml/2006/main">
+            <a:r>
+              <a:t>Pour conclure, le POC livre une chaîne complète : des données réelles, un index persistant, une génération augmentée, une API, Docker, des tests et une méthode d'évaluation. Je recommande d'abord d'actualiser le corpus et d'ajouter les garde-fous de ville et de date. Ensuite, d'élargir le jeu annoté et de comparer les paramètres de recherche. Un pilote doit mesurer la réponse utile, les refus corrects, les clics vers les sources, la latence et le coût. Je vous montre brièvement les preuves dans le rapport et le dépôt. Le rapport documente les choix et les résultats. Dans le dépôt, scripts permet de relancer les étapes, src contient le moteur et l'API, tests les validations, et seed-data le corpus de référence. Ces éléments permettent à une autre personne de reproduire et d'examiner le POC. Je suis prêt à répondre à vos questions.</a:t>
+            </a:r>
+          </a:p>
+          <a:p xmlns:a="http://schemas.openxmlformats.org/drawingml/2006/main">
+            <a:r>
+              <a:t/>
+            </a:r>
+          </a:p>
+          <a:p xmlns:a="http://schemas.openxmlformats.org/drawingml/2006/main">
+            <a:r>
+              <a:t>À MONTRER</a:t>
+            </a:r>
+          </a:p>
+          <a:p xmlns:a="http://schemas.openxmlformats.org/drawingml/2006/main">
+            <a:r>
+              <a:t>30 s de conclusion ; 20 s rapport (architecture, évaluation, limites) ; 25 s dépôt (scripts/, src/, tests/, seed-data/). Retourne ensuite au deck. Tous les liens sont dans le guide.</a:t>
+            </a:r>
+          </a:p>
+          <a:p xmlns:a="http://schemas.openxmlformats.org/drawingml/2006/main">
+            <a:r>
+              <a:t/>
+            </a:r>
+          </a:p>
+          <a:p xmlns:a="http://schemas.openxmlformats.org/drawingml/2006/main">
+            <a:r>
+              <a:t>COMPRENDRE</a:t>
+            </a:r>
+          </a:p>
+          <a:p xmlns:a="http://schemas.openxmlformats.org/drawingml/2006/main">
+            <a:r>
+              <a:t>La conclusion répond à la demande du client : est-ce faisable, quelles preuves avons-nous, que faut-il faire ensuite ? Tu proposes une expérimentation, pas une promesse de conversion ou de qualité universelle.</a:t>
+            </a:r>
+          </a:p>
+          <a:p xmlns:a="http://schemas.openxmlformats.org/drawingml/2006/main">
+            <a:r>
+              <a:t/>
+            </a:r>
+          </a:p>
+          <a:p xmlns:a="http://schemas.openxmlformats.org/drawingml/2006/main">
+            <a:r>
+              <a:t>DÉTAIL TECHNIQUE</a:t>
+            </a:r>
+          </a:p>
+          <a:p xmlns:a="http://schemas.openxmlformats.org/drawingml/2006/main">
+            <a:r>
+              <a:t>Priorités : fraîcheur et contraintes métier ; jeu annoté diversifié et cas négatifs ; optimisation mesurée ; gestion quotas/erreurs/secrets ; authentification, logs, CI, tests de charge et mises à jour atomiques. Les clics et la satisfaction doivent être observés avec des utilisateurs. Aucun coût précis ni objectif de latence de production n'a été mesuré dans ce POC.</a:t>
+            </a:r>
+          </a:p>
+          <a:p xmlns:a="http://schemas.openxmlformats.org/drawingml/2006/main">
+            <a:r>
+              <a:t/>
+            </a:r>
+          </a:p>
+          <a:p xmlns:a="http://schemas.openxmlformats.org/drawingml/2006/main">
+            <a:r>
+              <a:t>PIÈGE</a:t>
+            </a:r>
+          </a:p>
+          <a:p xmlns:a="http://schemas.openxmlformats.org/drawingml/2006/main">
+            <a:r>
+              <a:t>Ne consacre pas plusieurs minutes à parcourir le dépôt. La présentation doit rester entre 10 et 20 minutes, cible 15.</a:t>
+            </a:r>
+          </a:p>
+          <a:p xmlns:a="http://schemas.openxmlformats.org/drawingml/2006/main">
+            <a:r>
+              <a:t/>
+            </a:r>
+          </a:p>
+          <a:p xmlns:a="http://schemas.openxmlformats.org/drawingml/2006/main">
+            <a:r>
+              <a:t>PREUVE</a:t>
+            </a:r>
+          </a:p>
+          <a:p xmlns:a="http://schemas.openxmlformats.org/drawingml/2006/main">
+            <a:r>
+              <a:t>README.md ; outputs/rapport-technique-openagenda-rag.pdf ; https://github.com/hgbe-GH/Projet7.</a:t>
+            </a:r>
+          </a:p>
+          <a:p xmlns:a="http://schemas.openxmlformats.org/drawingml/2006/main">
+            <a:r>
+              <a:t/>
+            </a:r>
+          </a:p>
+          <a:p xmlns:a="http://schemas.openxmlformats.org/drawingml/2006/main">
+            <a:r>
+              <a:t>TRANSITION</a:t>
+            </a:r>
+          </a:p>
+          <a:p xmlns:a="http://schemas.openxmlformats.org/drawingml/2006/main">
+            <a:r>
+              <a:t>Discussion : écoute la question, réponds en une phrase, puis donne la preuve ou la limite utile.</a:t>
             </a:r>
           </a:p>
         </p:txBody>
@@ -888,22 +1248,112 @@
           <a:lstStyle xmlns:a="http://schemas.openxmlformats.org/drawingml/2006/main"/>
           <a:p xmlns:a="http://schemas.openxmlformats.org/drawingml/2006/main">
             <a:r>
-              <a:t>Durée cible : 60 secondes.</a:t>
-            </a:r>
-          </a:p>
-          <a:p xmlns:a="http://schemas.openxmlformats.org/drawingml/2006/main">
-            <a:r>
-              <a:t>Une recherche par mots-clés est rigide, tandis qu’un LLM seul peut inventer.</a:t>
-            </a:r>
-          </a:p>
-          <a:p xmlns:a="http://schemas.openxmlformats.org/drawingml/2006/main">
-            <a:r>
-              <a:t>Le RAG recherche d’abord dans les événements réels puis Mistral reformule uniquement ce que les sources fournissent.</a:t>
-            </a:r>
-          </a:p>
-          <a:p xmlns:a="http://schemas.openxmlformats.org/drawingml/2006/main">
-            <a:r>
-              <a:t>Les liens retournés rendent la recommandation vérifiable.</a:t>
+              <a:t>00:45–01:50 (65 s)</a:t>
+            </a:r>
+          </a:p>
+          <a:p xmlns:a="http://schemas.openxmlformats.org/drawingml/2006/main">
+            <a:r>
+              <a:t/>
+            </a:r>
+          </a:p>
+          <a:p xmlns:a="http://schemas.openxmlformats.org/drawingml/2006/main">
+            <a:r>
+              <a:t>À LIRE</a:t>
+            </a:r>
+          </a:p>
+          <a:p xmlns:a="http://schemas.openxmlformats.org/drawingml/2006/main">
+            <a:r>
+              <a:t>Le problème métier est qu'une recherche par mots-clés ne correspond pas toujours à la façon dont un utilisateur exprime son envie. Par exemple, une sortie en famille peut correspondre à une visite jouée par des comédiens, même si les mots utilisés diffèrent. Un modèle de langage seul peut produire une réponse convaincante sans connaître les événements du catalogue. Le RAG combine deux capacités. Il recherche d'abord des passages proches du sens de la question. Il ajoute ensuite ces passages au contexte du modèle. Enfin, Mistral formule une réponse en français. Les sources permettent de revenir aux événements d'origine. Le RAG réduit ainsi le risque d'invention, mais ne le supprime pas : il faut encore vérifier la pertinence des passages et la fidélité de la réponse.</a:t>
+            </a:r>
+          </a:p>
+          <a:p xmlns:a="http://schemas.openxmlformats.org/drawingml/2006/main">
+            <a:r>
+              <a:t/>
+            </a:r>
+          </a:p>
+          <a:p xmlns:a="http://schemas.openxmlformats.org/drawingml/2006/main">
+            <a:r>
+              <a:t>À MONTRER</a:t>
+            </a:r>
+          </a:p>
+          <a:p xmlns:a="http://schemas.openxmlformats.org/drawingml/2006/main">
+            <a:r>
+              <a:t>Pointe les trois étapes. L'exemple famille existe dans le jeu RAGAS ; ce n'est pas une nouvelle preuve live.</a:t>
+            </a:r>
+          </a:p>
+          <a:p xmlns:a="http://schemas.openxmlformats.org/drawingml/2006/main">
+            <a:r>
+              <a:t/>
+            </a:r>
+          </a:p>
+          <a:p xmlns:a="http://schemas.openxmlformats.org/drawingml/2006/main">
+            <a:r>
+              <a:t>COMPRENDRE</a:t>
+            </a:r>
+          </a:p>
+          <a:p xmlns:a="http://schemas.openxmlformats.org/drawingml/2006/main">
+            <a:r>
+              <a:t>Imagine un conseiller avec un catalogue devant lui. FAISS trouve les fiches utiles ; Mistral les lit et rédige. Retrieval = recherche. Augmented = on ajoute les fiches à la question. Generation = le modèle rédige. Le catalogue reste à l'extérieur du modèle.</a:t>
+            </a:r>
+          </a:p>
+          <a:p xmlns:a="http://schemas.openxmlformats.org/drawingml/2006/main">
+            <a:r>
+              <a:t/>
+            </a:r>
+          </a:p>
+          <a:p xmlns:a="http://schemas.openxmlformats.org/drawingml/2006/main">
+            <a:r>
+              <a:t>DÉTAIL TECHNIQUE</a:t>
+            </a:r>
+          </a:p>
+          <a:p xmlns:a="http://schemas.openxmlformats.org/drawingml/2006/main">
+            <a:r>
+              <a:t>Ce n'est ni du fine-tuning ni de l'entraînement. L'embedding représente le texte numériquement, le retriever sélectionne des documents et ChatPromptTemplate assemble les messages transmis au chat. Les documents sont consultés à chaque question.</a:t>
+            </a:r>
+          </a:p>
+          <a:p xmlns:a="http://schemas.openxmlformats.org/drawingml/2006/main">
+            <a:r>
+              <a:t/>
+            </a:r>
+          </a:p>
+          <a:p xmlns:a="http://schemas.openxmlformats.org/drawingml/2006/main">
+            <a:r>
+              <a:t>PIÈGE</a:t>
+            </a:r>
+          </a:p>
+          <a:p xmlns:a="http://schemas.openxmlformats.org/drawingml/2006/main">
+            <a:r>
+              <a:t>Ne promets pas zéro hallucination. Une recherche proche n'est pas nécessairement une réponse pertinente.</a:t>
+            </a:r>
+          </a:p>
+          <a:p xmlns:a="http://schemas.openxmlformats.org/drawingml/2006/main">
+            <a:r>
+              <a:t/>
+            </a:r>
+          </a:p>
+          <a:p xmlns:a="http://schemas.openxmlformats.org/drawingml/2006/main">
+            <a:r>
+              <a:t>PREUVE</a:t>
+            </a:r>
+          </a:p>
+          <a:p xmlns:a="http://schemas.openxmlformats.org/drawingml/2006/main">
+            <a:r>
+              <a:t>src/openagenda_rag/rag.py : answer_question(), build_prompt() ; tests/fixtures/ragas_eval_dataset.csv.</a:t>
+            </a:r>
+          </a:p>
+          <a:p xmlns:a="http://schemas.openxmlformats.org/drawingml/2006/main">
+            <a:r>
+              <a:t/>
+            </a:r>
+          </a:p>
+          <a:p xmlns:a="http://schemas.openxmlformats.org/drawingml/2006/main">
+            <a:r>
+              <a:t>TRANSITION</a:t>
+            </a:r>
+          </a:p>
+          <a:p xmlns:a="http://schemas.openxmlformats.org/drawingml/2006/main">
+            <a:r>
+              <a:t>Cette approche dépend d'abord de la qualité du catalogue préparé.</a:t>
             </a:r>
           </a:p>
         </p:txBody>
@@ -973,22 +1423,112 @@
           <a:lstStyle xmlns:a="http://schemas.openxmlformats.org/drawingml/2006/main"/>
           <a:p xmlns:a="http://schemas.openxmlformats.org/drawingml/2006/main">
             <a:r>
-              <a:t>Durée cible : 70 secondes.</a:t>
-            </a:r>
-          </a:p>
-          <a:p xmlns:a="http://schemas.openxmlformats.org/drawingml/2006/main">
-            <a:r>
-              <a:t>OpenAgenda est riche mais hétérogène : HTML, valeurs absentes, dates variées et doublons.</a:t>
-            </a:r>
-          </a:p>
-          <a:p xmlns:a="http://schemas.openxmlformats.org/drawingml/2006/main">
-            <a:r>
-              <a:t>Je filtre Paris et les événements récents, nettoie les textes, normalise les champs et déduplique par event_uid.</a:t>
-            </a:r>
-          </a:p>
-          <a:p xmlns:a="http://schemas.openxmlformats.org/drawingml/2006/main">
-            <a:r>
-              <a:t>Le parquet obtenu est un snapshot reproductible, et la conservation des métadonnées garantit la traçabilité.</a:t>
+              <a:t>01:50–03:05 (75 s)</a:t>
+            </a:r>
+          </a:p>
+          <a:p xmlns:a="http://schemas.openxmlformats.org/drawingml/2006/main">
+            <a:r>
+              <a:t/>
+            </a:r>
+          </a:p>
+          <a:p xmlns:a="http://schemas.openxmlformats.org/drawingml/2006/main">
+            <a:r>
+              <a:t>À LIRE</a:t>
+            </a:r>
+          </a:p>
+          <a:p xmlns:a="http://schemas.openxmlformats.org/drawingml/2006/main">
+            <a:r>
+              <a:t>Les données proviennent d'OpenAgenda à travers le jeu public exposé par Opendatasoft. Cette source est celle du lien donné dans la mission et ne demande pas de clé pour la collecte. Le script filtre Paris et la première date des événements, du 10 juillet 2025 au 10 juillet 2026. Il parcourt les résultats, nettoie les descriptions HTML, gère les champs absents et supprime les doublons par identifiant. Il produit un fichier Parquet structuré et un manifeste qui trace les paramètres et le volume. Je conserve les dates, le lieu et l'URL pour que la réponse soit vérifiable. Cette fenêtre était celle du POC construit en juillet. Pour une utilisation aujourd'hui, le corpus doit être actualisé : je ne présente pas ce catalogue figé comme un agenda à jour.</a:t>
+            </a:r>
+          </a:p>
+          <a:p xmlns:a="http://schemas.openxmlformats.org/drawingml/2006/main">
+            <a:r>
+              <a:t/>
+            </a:r>
+          </a:p>
+          <a:p xmlns:a="http://schemas.openxmlformats.org/drawingml/2006/main">
+            <a:r>
+              <a:t>À MONTRER</a:t>
+            </a:r>
+          </a:p>
+          <a:p xmlns:a="http://schemas.openxmlformats.org/drawingml/2006/main">
+            <a:r>
+              <a:t>Explique la fenêtre telle qu'elle est. Si on te demande le fichier, ouvre le manifeste de collecte, pas le JSON brut entier.</a:t>
+            </a:r>
+          </a:p>
+          <a:p xmlns:a="http://schemas.openxmlformats.org/drawingml/2006/main">
+            <a:r>
+              <a:t/>
+            </a:r>
+          </a:p>
+          <a:p xmlns:a="http://schemas.openxmlformats.org/drawingml/2006/main">
+            <a:r>
+              <a:t>COMPRENDRE</a:t>
+            </a:r>
+          </a:p>
+          <a:p xmlns:a="http://schemas.openxmlformats.org/drawingml/2006/main">
+            <a:r>
+              <a:t>Une API de données donne des fiches d'événements. Le nettoyage rend leurs champs utilisables. Parquet est un format de tableau compact. Le manifeste est la fiche d'identité de la collecte : source, filtres, date et quantité. Le seed est la copie de référence livrée avec le projet.</a:t>
+            </a:r>
+          </a:p>
+          <a:p xmlns:a="http://schemas.openxmlformats.org/drawingml/2006/main">
+            <a:r>
+              <a:t/>
+            </a:r>
+          </a:p>
+          <a:p xmlns:a="http://schemas.openxmlformats.org/drawingml/2006/main">
+            <a:r>
+              <a:t>DÉTAIL TECHNIQUE</a:t>
+            </a:r>
+          </a:p>
+          <a:p xmlns:a="http://schemas.openxmlformats.org/drawingml/2006/main">
+            <a:r>
+              <a:t>build_records_where_clause() filtre firstdate_begin, pas chaque occurrence récurrente. last_timing peut dépasser juillet 2026. La borne haute fixe exclut les événements qui commencent après la collecte. Les données ne sont pas automatiquement rafraîchies. 39 titres sont absents dans le seed, mais leurs descriptions peuvent rester indexables. Déduplication par event_uid ; les titres identiques avec des UID différents ne sont pas fusionnés.</a:t>
+            </a:r>
+          </a:p>
+          <a:p xmlns:a="http://schemas.openxmlformats.org/drawingml/2006/main">
+            <a:r>
+              <a:t/>
+            </a:r>
+          </a:p>
+          <a:p xmlns:a="http://schemas.openxmlformats.org/drawingml/2006/main">
+            <a:r>
+              <a:t>PIÈGE</a:t>
+            </a:r>
+          </a:p>
+          <a:p xmlns:a="http://schemas.openxmlformats.org/drawingml/2006/main">
+            <a:r>
+              <a:t>La consigne demande des événements récents et vise des recommandations à venir. Au 1er octobre, certains événements du seed ont plus d'un an. La fraîcheur constitue donc un écart actuel à signaler et à corriger par une nouvelle collecte, pas à masquer.</a:t>
+            </a:r>
+          </a:p>
+          <a:p xmlns:a="http://schemas.openxmlformats.org/drawingml/2006/main">
+            <a:r>
+              <a:t/>
+            </a:r>
+          </a:p>
+          <a:p xmlns:a="http://schemas.openxmlformats.org/drawingml/2006/main">
+            <a:r>
+              <a:t>PREUVE</a:t>
+            </a:r>
+          </a:p>
+          <a:p xmlns:a="http://schemas.openxmlformats.org/drawingml/2006/main">
+            <a:r>
+              <a:t>scripts/fetch_events.py ; src/openagenda_rag/ingestion.py ; seed-data/processed/fetch_manifest.json ; events.parquet.</a:t>
+            </a:r>
+          </a:p>
+          <a:p xmlns:a="http://schemas.openxmlformats.org/drawingml/2006/main">
+            <a:r>
+              <a:t/>
+            </a:r>
+          </a:p>
+          <a:p xmlns:a="http://schemas.openxmlformats.org/drawingml/2006/main">
+            <a:r>
+              <a:t>TRANSITION</a:t>
+            </a:r>
+          </a:p>
+          <a:p xmlns:a="http://schemas.openxmlformats.org/drawingml/2006/main">
+            <a:r>
+              <a:t>Une fois les fiches préparées, il faut les rendre recherchables par leur sens.</a:t>
             </a:r>
           </a:p>
         </p:txBody>
@@ -1058,22 +1598,112 @@
           <a:lstStyle xmlns:a="http://schemas.openxmlformats.org/drawingml/2006/main"/>
           <a:p xmlns:a="http://schemas.openxmlformats.org/drawingml/2006/main">
             <a:r>
-              <a:t>Durée cible : 70 secondes.</a:t>
-            </a:r>
-          </a:p>
-          <a:p xmlns:a="http://schemas.openxmlformats.org/drawingml/2006/main">
-            <a:r>
-              <a:t>CHIMERE a une description de 10 273 caractères : elle est trop longue pour une recherche précise.</a:t>
-            </a:r>
-          </a:p>
-          <a:p xmlns:a="http://schemas.openxmlformats.org/drawingml/2006/main">
-            <a:r>
-              <a:t>Je la découpe en chunks de 1 000 caractères avec 200 de chevauchement, puis mistral-embed produit des vecteurs de 1 024 dimensions.</a:t>
-            </a:r>
-          </a:p>
-          <a:p xmlns:a="http://schemas.openxmlformats.org/drawingml/2006/main">
-            <a:r>
-              <a:t>FAISS stocke 14 903 passages avec date, lieu et URL pour retrouver le bon contexte.</a:t>
+              <a:t>03:05–04:20 (75 s)</a:t>
+            </a:r>
+          </a:p>
+          <a:p xmlns:a="http://schemas.openxmlformats.org/drawingml/2006/main">
+            <a:r>
+              <a:t/>
+            </a:r>
+          </a:p>
+          <a:p xmlns:a="http://schemas.openxmlformats.org/drawingml/2006/main">
+            <a:r>
+              <a:t>À LIRE</a:t>
+            </a:r>
+          </a:p>
+          <a:p xmlns:a="http://schemas.openxmlformats.org/drawingml/2006/main">
+            <a:r>
+              <a:t>Certaines fiches sont longues. Les indexer comme un seul bloc risquerait de diluer une information utile. J'utilise donc le découpage récursif de LangChain, configuré à 1 000 caractères avec un chevauchement maximal de 200 caractères. Le chevauchement limite la perte d'information aux frontières. Par exemple, une fiche CHIMERE contient 10 273 caractères et produit 15 passages, car le découpage tient aussi compte des séparateurs. Le modèle mistral-embed transforme chaque passage en un vecteur de 1 024 dimensions, autrement dit une liste de nombres représentant son sens. La construction se fait par lots de 50. Au total, FAISS contient 14 903 vecteurs pour les 7 586 événements. Chaque passage conserve l'identifiant de l'événement, ses dates, son lieu et son lien.</a:t>
+            </a:r>
+          </a:p>
+          <a:p xmlns:a="http://schemas.openxmlformats.org/drawingml/2006/main">
+            <a:r>
+              <a:t/>
+            </a:r>
+          </a:p>
+          <a:p xmlns:a="http://schemas.openxmlformats.org/drawingml/2006/main">
+            <a:r>
+              <a:t>À MONTRER</a:t>
+            </a:r>
+          </a:p>
+          <a:p xmlns:a="http://schemas.openxmlformats.org/drawingml/2006/main">
+            <a:r>
+              <a:t>Distingue la fiche d'exemple et les volumes de tout le corpus. Aucun réindexage en direct.</a:t>
+            </a:r>
+          </a:p>
+          <a:p xmlns:a="http://schemas.openxmlformats.org/drawingml/2006/main">
+            <a:r>
+              <a:t/>
+            </a:r>
+          </a:p>
+          <a:p xmlns:a="http://schemas.openxmlformats.org/drawingml/2006/main">
+            <a:r>
+              <a:t>COMPRENDRE</a:t>
+            </a:r>
+          </a:p>
+          <a:p xmlns:a="http://schemas.openxmlformats.org/drawingml/2006/main">
+            <a:r>
+              <a:t>Un chunk est un morceau de texte. Un embedding est une liste de nombres qui permet de comparer le sens des textes. FAISS est l'outil qui range ces vecteurs et retrouve les plus proches. Il ne rédige aucune phrase et ne remplace pas Mistral.</a:t>
+            </a:r>
+          </a:p>
+          <a:p xmlns:a="http://schemas.openxmlformats.org/drawingml/2006/main">
+            <a:r>
+              <a:t/>
+            </a:r>
+          </a:p>
+          <a:p xmlns:a="http://schemas.openxmlformats.org/drawingml/2006/main">
+            <a:r>
+              <a:t>DÉTAIL TECHNIQUE</a:t>
+            </a:r>
+          </a:p>
+          <a:p xmlns:a="http://schemas.openxmlformats.org/drawingml/2006/main">
+            <a:r>
+              <a:t>RecursiveCharacterTextSplitter, add_start_index=True. Le chevauchement est un paramètre maximal, pas 200 caractères garantis à chaque frontière. chunk_id = event_uid::chunk-N. L'index réel est IndexFlatL2 : recherche exacte selon la distance euclidienne au carré, sans normalisation explicite dans le code. Moins la distance est élevée, plus les vecteurs sont proches. Tous les 7 586 UID sont représentés. CHIMERE 69427795 a 15 chunks ; une autre fiche porte le même titre avec un UID différent.</a:t>
+            </a:r>
+          </a:p>
+          <a:p xmlns:a="http://schemas.openxmlformats.org/drawingml/2006/main">
+            <a:r>
+              <a:t/>
+            </a:r>
+          </a:p>
+          <a:p xmlns:a="http://schemas.openxmlformats.org/drawingml/2006/main">
+            <a:r>
+              <a:t>PIÈGE</a:t>
+            </a:r>
+          </a:p>
+          <a:p xmlns:a="http://schemas.openxmlformats.org/drawingml/2006/main">
+            <a:r>
+              <a:t>Caractères et tokens sont différents. Ne dis pas que CHIMERE seul produit 14 903 chunks. Un vecteur n'est ni un résumé ni une réponse.</a:t>
+            </a:r>
+          </a:p>
+          <a:p xmlns:a="http://schemas.openxmlformats.org/drawingml/2006/main">
+            <a:r>
+              <a:t/>
+            </a:r>
+          </a:p>
+          <a:p xmlns:a="http://schemas.openxmlformats.org/drawingml/2006/main">
+            <a:r>
+              <a:t>PREUVE</a:t>
+            </a:r>
+          </a:p>
+          <a:p xmlns:a="http://schemas.openxmlformats.org/drawingml/2006/main">
+            <a:r>
+              <a:t>src/openagenda_rag/indexing.py : build_documents(), build_vector_store() ; seed-data/index/index_manifest.json ; index.faiss.</a:t>
+            </a:r>
+          </a:p>
+          <a:p xmlns:a="http://schemas.openxmlformats.org/drawingml/2006/main">
+            <a:r>
+              <a:t/>
+            </a:r>
+          </a:p>
+          <a:p xmlns:a="http://schemas.openxmlformats.org/drawingml/2006/main">
+            <a:r>
+              <a:t>TRANSITION</a:t>
+            </a:r>
+          </a:p>
+          <a:p xmlns:a="http://schemas.openxmlformats.org/drawingml/2006/main">
+            <a:r>
+              <a:t>L'index est préparé. Voyons ce qui se passe lorsqu'un utilisateur pose une question.</a:t>
             </a:r>
           </a:p>
         </p:txBody>
@@ -1143,22 +1773,112 @@
           <a:lstStyle xmlns:a="http://schemas.openxmlformats.org/drawingml/2006/main"/>
           <a:p xmlns:a="http://schemas.openxmlformats.org/drawingml/2006/main">
             <a:r>
-              <a:t>Durée cible : 65 secondes.</a:t>
-            </a:r>
-          </a:p>
-          <a:p xmlns:a="http://schemas.openxmlformats.org/drawingml/2006/main">
-            <a:r>
-              <a:t>La question est vectorisée et FAISS retourne les quatre passages les plus proches.</a:t>
-            </a:r>
-          </a:p>
-          <a:p xmlns:a="http://schemas.openxmlformats.org/drawingml/2006/main">
-            <a:r>
-              <a:t>Le prompt contient la question, le contexte et une règle centrale : répondre uniquement avec les sources, sans invention.</a:t>
-            </a:r>
-          </a:p>
-          <a:p xmlns:a="http://schemas.openxmlformats.org/drawingml/2006/main">
-            <a:r>
-              <a:t>mistral-embed sert à la recherche ; mistral-small-latest sert à la génération. La température à 0,1 stabilise le POC.</a:t>
+              <a:t>04:20–05:30 (70 s)</a:t>
+            </a:r>
+          </a:p>
+          <a:p xmlns:a="http://schemas.openxmlformats.org/drawingml/2006/main">
+            <a:r>
+              <a:t/>
+            </a:r>
+          </a:p>
+          <a:p xmlns:a="http://schemas.openxmlformats.org/drawingml/2006/main">
+            <a:r>
+              <a:t>À LIRE</a:t>
+            </a:r>
+          </a:p>
+          <a:p xmlns:a="http://schemas.openxmlformats.org/drawingml/2006/main">
+            <a:r>
+              <a:t>Au moment d'une question, on utilise le même modèle d'embedding que pour les documents. Cela rend leurs vecteurs comparables. FAISS sélectionne les quatre passages les plus proches : c'est le paramètre top-k. Le code assemble ensuite un contexte avec le texte et les métadonnées, puis le transmet avec la question à ministral-8b-2512. Pour la soutenance, ce modèle remplace mistral-small-latest, limité par Mistral aujourd'hui. Le prompt demande de répondre seulement à partir du contexte, de citer les informations disponibles et de ne pas inventer. La température est basse, à 0,1, pour limiter la variation ; la réponse est limitée à 700 tokens. Le JSON renvoie la réponse et les sources récupérées, regroupées par événement. Attention : quatre passages peuvent provenir du même événement. Et l'absence de seuil de pertinence signifie que le modèle doit encore décider si le contexte permet de répondre.</a:t>
+            </a:r>
+          </a:p>
+          <a:p xmlns:a="http://schemas.openxmlformats.org/drawingml/2006/main">
+            <a:r>
+              <a:t/>
+            </a:r>
+          </a:p>
+          <a:p xmlns:a="http://schemas.openxmlformats.org/drawingml/2006/main">
+            <a:r>
+              <a:t>À MONTRER</a:t>
+            </a:r>
+          </a:p>
+          <a:p xmlns:a="http://schemas.openxmlformats.org/drawingml/2006/main">
+            <a:r>
+              <a:t>Pointe la séparation embedding/chat et le texte du prompt. Si demandé, ouvre SYSTEM_PROMPT dans rag.py.</a:t>
+            </a:r>
+          </a:p>
+          <a:p xmlns:a="http://schemas.openxmlformats.org/drawingml/2006/main">
+            <a:r>
+              <a:t/>
+            </a:r>
+          </a:p>
+          <a:p xmlns:a="http://schemas.openxmlformats.org/drawingml/2006/main">
+            <a:r>
+              <a:t>COMPRENDRE</a:t>
+            </a:r>
+          </a:p>
+          <a:p xmlns:a="http://schemas.openxmlformats.org/drawingml/2006/main">
+            <a:r>
+              <a:t>Les deux modèles ont deux métiers différents. mistral-embed transforme textes et questions en nombres. ministral-8b-2512 lit le contexte et produit des phrases. top-k signifie combien de passages on lui donne ; cela ne signifie pas quatre recommandations.</a:t>
+            </a:r>
+          </a:p>
+          <a:p xmlns:a="http://schemas.openxmlformats.org/drawingml/2006/main">
+            <a:r>
+              <a:t/>
+            </a:r>
+          </a:p>
+          <a:p xmlns:a="http://schemas.openxmlformats.org/drawingml/2006/main">
+            <a:r>
+              <a:t>DÉTAIL TECHNIQUE</a:t>
+            </a:r>
+          </a:p>
+          <a:p xmlns:a="http://schemas.openxmlformats.org/drawingml/2006/main">
+            <a:r>
+              <a:t>answer_question() appelle retriever.invoke(), build_source_entries(), puis prompt.invoke() et chat_model.invoke(). Les sources sont les événements récupérés, pas une validation que chaque source soutient chaque phrase. Aucun filtre de date ou de ville n'est appliqué dynamiquement dans le retriever. L'absence de documents déclenche un refus déterministe ; en recherche top-k, le résultat non vide est fréquent même hors sujet. random_seed=42 stabilise sans garantir une sortie identique. L'alias latest peut évoluer. Le modèle de démonstration est fixé à ministral-8b-2512 dans .env. L’embedding reste mistral-embed : l’index est compatible sans reconstruction. Les scores RAGAS historiques concernent mistral-small-latest et ne valident pas ce changement. La date du jour et un statut temporel calculé sont transmis au prompt ; aucun filtre de date ne supprime les passages.</a:t>
+            </a:r>
+          </a:p>
+          <a:p xmlns:a="http://schemas.openxmlformats.org/drawingml/2006/main">
+            <a:r>
+              <a:t/>
+            </a:r>
+          </a:p>
+          <a:p xmlns:a="http://schemas.openxmlformats.org/drawingml/2006/main">
+            <a:r>
+              <a:t>PIÈGE</a:t>
+            </a:r>
+          </a:p>
+          <a:p xmlns:a="http://schemas.openxmlformats.org/drawingml/2006/main">
+            <a:r>
+              <a:t>Ne dis pas que les sources renvoyées sont toutes utilisées dans la réponse ni que le refus Lyon est codé comme une règle de ville.</a:t>
+            </a:r>
+          </a:p>
+          <a:p xmlns:a="http://schemas.openxmlformats.org/drawingml/2006/main">
+            <a:r>
+              <a:t/>
+            </a:r>
+          </a:p>
+          <a:p xmlns:a="http://schemas.openxmlformats.org/drawingml/2006/main">
+            <a:r>
+              <a:t>PREUVE</a:t>
+            </a:r>
+          </a:p>
+          <a:p xmlns:a="http://schemas.openxmlformats.org/drawingml/2006/main">
+            <a:r>
+              <a:t>src/openagenda_rag/rag.py ; src/openagenda_rag/settings.py : load_rag_settings().</a:t>
+            </a:r>
+          </a:p>
+          <a:p xmlns:a="http://schemas.openxmlformats.org/drawingml/2006/main">
+            <a:r>
+              <a:t/>
+            </a:r>
+          </a:p>
+          <a:p xmlns:a="http://schemas.openxmlformats.org/drawingml/2006/main">
+            <a:r>
+              <a:t>TRANSITION</a:t>
+            </a:r>
+          </a:p>
+          <a:p xmlns:a="http://schemas.openxmlformats.org/drawingml/2006/main">
+            <a:r>
+              <a:t>Ces étapes sont séparées dans le code pour pouvoir les tester et les remplacer.</a:t>
             </a:r>
           </a:p>
         </p:txBody>
@@ -1228,22 +1948,112 @@
           <a:lstStyle xmlns:a="http://schemas.openxmlformats.org/drawingml/2006/main"/>
           <a:p xmlns:a="http://schemas.openxmlformats.org/drawingml/2006/main">
             <a:r>
-              <a:t>Durée cible : 55 secondes.</a:t>
-            </a:r>
-          </a:p>
-          <a:p xmlns:a="http://schemas.openxmlformats.org/drawingml/2006/main">
-            <a:r>
-              <a:t>La collecte, le nettoyage et l’indexation sont réalisés hors ligne et peuvent être reconstruits par scripts.</a:t>
-            </a:r>
-          </a:p>
-          <a:p xmlns:a="http://schemas.openxmlformats.org/drawingml/2006/main">
-            <a:r>
-              <a:t>En ligne, l’API charge l’index persistant, retrouve le contexte, construit le prompt et génère une réponse.</a:t>
-            </a:r>
-          </a:p>
-          <a:p xmlns:a="http://schemas.openxmlformats.org/drawingml/2006/main">
-            <a:r>
-              <a:t>Cette séparation rend chaque brique testable et évite de reconstruire FAISS à chaque question.</a:t>
+              <a:t>05:30–06:30 (60 s)</a:t>
+            </a:r>
+          </a:p>
+          <a:p xmlns:a="http://schemas.openxmlformats.org/drawingml/2006/main">
+            <a:r>
+              <a:t/>
+            </a:r>
+          </a:p>
+          <a:p xmlns:a="http://schemas.openxmlformats.org/drawingml/2006/main">
+            <a:r>
+              <a:t>À LIRE</a:t>
+            </a:r>
+          </a:p>
+          <a:p xmlns:a="http://schemas.openxmlformats.org/drawingml/2006/main">
+            <a:r>
+              <a:t>L'architecture distingue la préparation des données du traitement des questions. La préparation collecte les fiches, les normalise, calcule leurs embeddings et sauvegarde l'index. Elle est faite avant l'utilisation du chatbot et appelle déjà Mistral pour les vecteurs. À chaque question, l'API appelle le service RAG, qui recharge l'index si nécessaire, recherche les passages et sollicite le modèle de chat. Le retriever et le client Mistral sont initialisés à la première question puis conservés en mémoire pour les suivantes. Le dossier scripts contient les commandes de lancement, tandis que src contient la logique métier. Cette séparation permet d'utiliser le même moteur depuis le terminal, l'API et l'évaluation. Elle évite de relancer la collecte ou l'indexation pour chaque demande.</a:t>
+            </a:r>
+          </a:p>
+          <a:p xmlns:a="http://schemas.openxmlformats.org/drawingml/2006/main">
+            <a:r>
+              <a:t/>
+            </a:r>
+          </a:p>
+          <a:p xmlns:a="http://schemas.openxmlformats.org/drawingml/2006/main">
+            <a:r>
+              <a:t>À MONTRER</a:t>
+            </a:r>
+          </a:p>
+          <a:p xmlns:a="http://schemas.openxmlformats.org/drawingml/2006/main">
+            <a:r>
+              <a:t>Si Jérémy demande le code, montre service.py puis rag.py. Évite de naviguer entre toutes les fonctions.</a:t>
+            </a:r>
+          </a:p>
+          <a:p xmlns:a="http://schemas.openxmlformats.org/drawingml/2006/main">
+            <a:r>
+              <a:t/>
+            </a:r>
+          </a:p>
+          <a:p xmlns:a="http://schemas.openxmlformats.org/drawingml/2006/main">
+            <a:r>
+              <a:t>COMPRENDRE</a:t>
+            </a:r>
+          </a:p>
+          <a:p xmlns:a="http://schemas.openxmlformats.org/drawingml/2006/main">
+            <a:r>
+              <a:t>La préparation construit une bibliothèque. L'usage consulte cette bibliothèque. Le service est le point central qui relie les briques. LangChain fournit les objets pour les documents, le découpage, la recherche et les messages ; il ne remplace pas le code du projet.</a:t>
+            </a:r>
+          </a:p>
+          <a:p xmlns:a="http://schemas.openxmlformats.org/drawingml/2006/main">
+            <a:r>
+              <a:t/>
+            </a:r>
+          </a:p>
+          <a:p xmlns:a="http://schemas.openxmlformats.org/drawingml/2006/main">
+            <a:r>
+              <a:t>DÉTAIL TECHNIQUE</a:t>
+            </a:r>
+          </a:p>
+          <a:p xmlns:a="http://schemas.openxmlformats.org/drawingml/2006/main">
+            <a:r>
+              <a:t>OpenAgendaRAGService._ensure_runtime() initialise les objets paresseusement. Ce sont des clients et un retriever en mémoire, pas les poids de Mistral en local. rebuild() reconstruit depuis le Parquet et invalide ces objets ; il ne recollecte pas les événements. La CLI réutilise le service ; la génération reste distante même sans HTTP local.</a:t>
+            </a:r>
+          </a:p>
+          <a:p xmlns:a="http://schemas.openxmlformats.org/drawingml/2006/main">
+            <a:r>
+              <a:t/>
+            </a:r>
+          </a:p>
+          <a:p xmlns:a="http://schemas.openxmlformats.org/drawingml/2006/main">
+            <a:r>
+              <a:t>PIÈGE</a:t>
+            </a:r>
+          </a:p>
+          <a:p xmlns:a="http://schemas.openxmlformats.org/drawingml/2006/main">
+            <a:r>
+              <a:t>Ne qualifie pas la préparation de complètement hors ligne : elle appelle Mistral. /health ne charge pas l'index et ne teste pas la clé.</a:t>
+            </a:r>
+          </a:p>
+          <a:p xmlns:a="http://schemas.openxmlformats.org/drawingml/2006/main">
+            <a:r>
+              <a:t/>
+            </a:r>
+          </a:p>
+          <a:p xmlns:a="http://schemas.openxmlformats.org/drawingml/2006/main">
+            <a:r>
+              <a:t>PREUVE</a:t>
+            </a:r>
+          </a:p>
+          <a:p xmlns:a="http://schemas.openxmlformats.org/drawingml/2006/main">
+            <a:r>
+              <a:t>src/openagenda_rag/service.py ; scripts/chatbot.py ; scripts/run_api.py.</a:t>
+            </a:r>
+          </a:p>
+          <a:p xmlns:a="http://schemas.openxmlformats.org/drawingml/2006/main">
+            <a:r>
+              <a:t/>
+            </a:r>
+          </a:p>
+          <a:p xmlns:a="http://schemas.openxmlformats.org/drawingml/2006/main">
+            <a:r>
+              <a:t>TRANSITION</a:t>
+            </a:r>
+          </a:p>
+          <a:p xmlns:a="http://schemas.openxmlformats.org/drawingml/2006/main">
+            <a:r>
+              <a:t>L'API donne aux équipes un contrat simple pour tester cette chaîne.</a:t>
             </a:r>
           </a:p>
         </p:txBody>
@@ -1313,22 +2123,112 @@
           <a:lstStyle xmlns:a="http://schemas.openxmlformats.org/drawingml/2006/main"/>
           <a:p xmlns:a="http://schemas.openxmlformats.org/drawingml/2006/main">
             <a:r>
-              <a:t>Durée cible : 50 secondes.</a:t>
-            </a:r>
-          </a:p>
-          <a:p xmlns:a="http://schemas.openxmlformats.org/drawingml/2006/main">
-            <a:r>
-              <a:t>FastAPI fournit le contrat de service : health vérifie que l’index est prêt, ask reçoit une question et retourne la réponse avec ses sources.</a:t>
-            </a:r>
-          </a:p>
-          <a:p xmlns:a="http://schemas.openxmlformats.org/drawingml/2006/main">
-            <a:r>
-              <a:t>Docker Compose rend ce runtime local reproductible. La documentation Swagger visible ici est une vraie capture de l’API locale.</a:t>
-            </a:r>
-          </a:p>
-          <a:p xmlns:a="http://schemas.openxmlformats.org/drawingml/2006/main">
-            <a:r>
-              <a:t>Je passe maintenant à la démonstration de deux comportements métier.</a:t>
+              <a:t>06:30–07:35 (65 s)</a:t>
+            </a:r>
+          </a:p>
+          <a:p xmlns:a="http://schemas.openxmlformats.org/drawingml/2006/main">
+            <a:r>
+              <a:t/>
+            </a:r>
+          </a:p>
+          <a:p xmlns:a="http://schemas.openxmlformats.org/drawingml/2006/main">
+            <a:r>
+              <a:t>À LIRE</a:t>
+            </a:r>
+          </a:p>
+          <a:p xmlns:a="http://schemas.openxmlformats.org/drawingml/2006/main">
+            <a:r>
+              <a:t>FastAPI expose trois routes métier. Health indique que le serveur répond et montre sa configuration. Ask accepte une question et renvoie un JSON avec la réponse, les sources et le nombre de passages récupérés. Rebuild reconstruit l'index depuis le fichier Parquet ; il ne lance pas une nouvelle collecte. Swagger, sur docs, permet de lire et tester le contrat sans écrire de client. Docker embarque le code, les dépendances et le seed. Au premier démarrage, l'index et les données sont copiés dans un volume persistant. La clé Mistral est injectée par l'environnement et n'est pas versionnée. Le jeton d'administration de rebuild est optionnel et doit être configuré avant une exposition publique. Le POC reste dépendant d'internet pour vectoriser la question et générer la réponse.</a:t>
+            </a:r>
+          </a:p>
+          <a:p xmlns:a="http://schemas.openxmlformats.org/drawingml/2006/main">
+            <a:r>
+              <a:t/>
+            </a:r>
+          </a:p>
+          <a:p xmlns:a="http://schemas.openxmlformats.org/drawingml/2006/main">
+            <a:r>
+              <a:t>À MONTRER</a:t>
+            </a:r>
+          </a:p>
+          <a:p xmlns:a="http://schemas.openxmlformats.org/drawingml/2006/main">
+            <a:r>
+              <a:t>Pendant la démo, ouvre Swagger et montre les routes ; garde /rebuild fermé. Tu peux cliquer le lien Démo de la slide suivante.</a:t>
+            </a:r>
+          </a:p>
+          <a:p xmlns:a="http://schemas.openxmlformats.org/drawingml/2006/main">
+            <a:r>
+              <a:t/>
+            </a:r>
+          </a:p>
+          <a:p xmlns:a="http://schemas.openxmlformats.org/drawingml/2006/main">
+            <a:r>
+              <a:t>COMPRENDRE</a:t>
+            </a:r>
+          </a:p>
+          <a:p xmlns:a="http://schemas.openxmlformats.org/drawingml/2006/main">
+            <a:r>
+              <a:t>Une API est une porte d'entrée pour d'autres logiciels. GET lit, POST envoie une action ou des données. JSON est le format des messages. Swagger est la page de documentation interactive. Docker fournit le même environnement ; le volume garde les fichiers modifiés lorsque le conteneur est recréé.</a:t>
+            </a:r>
+          </a:p>
+          <a:p xmlns:a="http://schemas.openxmlformats.org/drawingml/2006/main">
+            <a:r>
+              <a:t/>
+            </a:r>
+          </a:p>
+          <a:p xmlns:a="http://schemas.openxmlformats.org/drawingml/2006/main">
+            <a:r>
+              <a:t>DÉTAIL TECHNIQUE</a:t>
+            </a:r>
+          </a:p>
+          <a:p xmlns:a="http://schemas.openxmlformats.org/drawingml/2006/main">
+            <a:r>
+              <a:t>Validation Pydantic : question vide → 422 ; espaces seuls → 400 ; index absent → 503. Les erreurs HTTP Mistral 429 et d’accès sont contrôlées en 503, les autres erreurs HTTP fournisseur en 502, les erreurs réseau en 503. Les détails des exceptions fournisseur et inattendues ne sont plus exposés. /rebuild est protégé uniquement si API_REBUILD_TOKEN est défini. /health vérifie le serveur et sa configuration, sans appeler Mistral.</a:t>
+            </a:r>
+          </a:p>
+          <a:p xmlns:a="http://schemas.openxmlformats.org/drawingml/2006/main">
+            <a:r>
+              <a:t/>
+            </a:r>
+          </a:p>
+          <a:p xmlns:a="http://schemas.openxmlformats.org/drawingml/2006/main">
+            <a:r>
+              <a:t>PIÈGE</a:t>
+            </a:r>
+          </a:p>
+          <a:p xmlns:a="http://schemas.openxmlformats.org/drawingml/2006/main">
+            <a:r>
+              <a:t>Ne dis pas que /rebuild est forcément protégé ou que /health valide Mistral et l'index.</a:t>
+            </a:r>
+          </a:p>
+          <a:p xmlns:a="http://schemas.openxmlformats.org/drawingml/2006/main">
+            <a:r>
+              <a:t/>
+            </a:r>
+          </a:p>
+          <a:p xmlns:a="http://schemas.openxmlformats.org/drawingml/2006/main">
+            <a:r>
+              <a:t>PREUVE</a:t>
+            </a:r>
+          </a:p>
+          <a:p xmlns:a="http://schemas.openxmlformats.org/drawingml/2006/main">
+            <a:r>
+              <a:t>src/openagenda_rag/api.py ; Dockerfile ; docker-compose.yml ; scripts/docker_entrypoint.sh.</a:t>
+            </a:r>
+          </a:p>
+          <a:p xmlns:a="http://schemas.openxmlformats.org/drawingml/2006/main">
+            <a:r>
+              <a:t/>
+            </a:r>
+          </a:p>
+          <a:p xmlns:a="http://schemas.openxmlformats.org/drawingml/2006/main">
+            <a:r>
+              <a:t>TRANSITION</a:t>
+            </a:r>
+          </a:p>
+          <a:p xmlns:a="http://schemas.openxmlformats.org/drawingml/2006/main">
+            <a:r>
+              <a:t>Je vais maintenant montrer un cas présent dans le corpus et un cas hors périmètre.</a:t>
             </a:r>
           </a:p>
         </p:txBody>
@@ -1398,22 +2298,112 @@
           <a:lstStyle xmlns:a="http://schemas.openxmlformats.org/drawingml/2006/main"/>
           <a:p xmlns:a="http://schemas.openxmlformats.org/drawingml/2006/main">
             <a:r>
-              <a:t>Durée cible : 25 secondes sur la slide, puis 2 minutes au terminal.</a:t>
-            </a:r>
-          </a:p>
-          <a:p xmlns:a="http://schemas.openxmlformats.org/drawingml/2006/main">
-            <a:r>
-              <a:t>Je vérifie d’abord health, puis Concert Fishers à Paris : réponse, date, lieu, URL et quatre sources.</a:t>
-            </a:r>
-          </a:p>
-          <a:p xmlns:a="http://schemas.openxmlformats.org/drawingml/2006/main">
-            <a:r>
-              <a:t>Ensuite je demande des expositions à Lyon. Comme le corpus couvre Paris, le comportement attendu est prudent : aucune invention.</a:t>
-            </a:r>
-          </a:p>
-          <a:p xmlns:a="http://schemas.openxmlformats.org/drawingml/2006/main">
-            <a:r>
-              <a:t>Commande : bash scripts/demo_api_5min.sh.</a:t>
+              <a:t>07:35–09:55 (140 s)</a:t>
+            </a:r>
+          </a:p>
+          <a:p xmlns:a="http://schemas.openxmlformats.org/drawingml/2006/main">
+            <a:r>
+              <a:t/>
+            </a:r>
+          </a:p>
+          <a:p xmlns:a="http://schemas.openxmlformats.org/drawingml/2006/main">
+            <a:r>
+              <a:t>À LIRE</a:t>
+            </a:r>
+          </a:p>
+          <a:p xmlns:a="http://schemas.openxmlformats.org/drawingml/2006/main">
+            <a:r>
+              <a:t>Je commence par montrer que l'API répond et que ses routes sont documentées. Pour le premier cas, je demande des informations sur Concert Fishers à Paris. Le résultat doit permettre de retrouver l'événement, son lieu, sa date et son URL. Il s'agit d'un exemple du corpus livré, pas d'une sortie à venir aujourd'hui. Je compare la réponse au premier événement source. Les autres sources sont les voisins récupérés et ne sont pas toutes nécessaires à cette réponse. Pour le second cas, je demande des expositions photo à Lyon. Le corpus contient Paris. Dans la répétition directe d'aujourd'hui, le modèle dit qu'il ne sait pas et n'invente pas d'exposition lyonnaise. FAISS renvoie quand même des passages : cela illustre la limite de la recherche sans seuil de pertinence.</a:t>
+            </a:r>
+          </a:p>
+          <a:p xmlns:a="http://schemas.openxmlformats.org/drawingml/2006/main">
+            <a:r>
+              <a:t/>
+            </a:r>
+          </a:p>
+          <a:p xmlns:a="http://schemas.openxmlformats.org/drawingml/2006/main">
+            <a:r>
+              <a:t>À MONTRER</a:t>
+            </a:r>
+          </a:p>
+          <a:p xmlns:a="http://schemas.openxmlformats.org/drawingml/2006/main">
+            <a:r>
+              <a:t>140 s au total : 20 s health/Swagger ; 50 s cas nominal ; 40 s Lyon ; 30 s explication et retour au deck. Une tentative live maximum en cas de quota, puis enregistrement. Mode secours disponible hors réseau.</a:t>
+            </a:r>
+          </a:p>
+          <a:p xmlns:a="http://schemas.openxmlformats.org/drawingml/2006/main">
+            <a:r>
+              <a:t/>
+            </a:r>
+          </a:p>
+          <a:p xmlns:a="http://schemas.openxmlformats.org/drawingml/2006/main">
+            <a:r>
+              <a:t>COMPRENDRE</a:t>
+            </a:r>
+          </a:p>
+          <a:p xmlns:a="http://schemas.openxmlformats.org/drawingml/2006/main">
+            <a:r>
+              <a:t>Ta démo doit prouver trois choses : le contrat API existe ; la réponse utilise une vraie fiche ; le système sait reconnaître au moins un cas hors corpus. Le premier événement est ancien : annonce-le. Si Mistral est indisponible, montre les réponses enregistrées en le disant explicitement.</a:t>
+            </a:r>
+          </a:p>
+          <a:p xmlns:a="http://schemas.openxmlformats.org/drawingml/2006/main">
+            <a:r>
+              <a:t/>
+            </a:r>
+          </a:p>
+          <a:p xmlns:a="http://schemas.openxmlformats.org/drawingml/2006/main">
+            <a:r>
+              <a:t>DÉTAIL TECHNIQUE</a:t>
+            </a:r>
+          </a:p>
+          <a:p xmlns:a="http://schemas.openxmlformats.org/drawingml/2006/main">
+            <a:r>
+              <a:t>Le 1er octobre, les deux scénarios /ask ont réussi en direct avec ministral-8b-2512. Le rapport outputs/demo/demo_api_2026-10-01.json en conserve les réponses, le modèle et l’horodatage. La mesure couvre health et les deux questions, pas chaque requête ni un benchmark. Mistral Small renvoyait 429 ; le modèle de génération a été changé, sans modifier mistral-embed ni reconstruire FAISS. La sortie peut encore contenir un conseil général non sourcé : le signaler si présent.</a:t>
+            </a:r>
+          </a:p>
+          <a:p xmlns:a="http://schemas.openxmlformats.org/drawingml/2006/main">
+            <a:r>
+              <a:t/>
+            </a:r>
+          </a:p>
+          <a:p xmlns:a="http://schemas.openxmlformats.org/drawingml/2006/main">
+            <a:r>
+              <a:t>PIÈGE</a:t>
+            </a:r>
+          </a:p>
+          <a:p xmlns:a="http://schemas.openxmlformats.org/drawingml/2006/main">
+            <a:r>
+              <a:t>Ne présente pas un enregistrement comme un appel direct. Compare les faits et les dates aux sources. Si un conseil général non sourcé apparaît, explique que le prompt réduit les erreurs sans les éliminer. Aucun secret à l’écran.</a:t>
+            </a:r>
+          </a:p>
+          <a:p xmlns:a="http://schemas.openxmlformats.org/drawingml/2006/main">
+            <a:r>
+              <a:t/>
+            </a:r>
+          </a:p>
+          <a:p xmlns:a="http://schemas.openxmlformats.org/drawingml/2006/main">
+            <a:r>
+              <a:t>PREUVE</a:t>
+            </a:r>
+          </a:p>
+          <a:p xmlns:a="http://schemas.openxmlformats.org/drawingml/2006/main">
+            <a:r>
+              <a:t>scripts/demo_api_5min.py ; outputs/demo/demo_api_2026-10-01.json ; démonstrateur HTML ; état de préparation.</a:t>
+            </a:r>
+          </a:p>
+          <a:p xmlns:a="http://schemas.openxmlformats.org/drawingml/2006/main">
+            <a:r>
+              <a:t/>
+            </a:r>
+          </a:p>
+          <a:p xmlns:a="http://schemas.openxmlformats.org/drawingml/2006/main">
+            <a:r>
+              <a:t>TRANSITION</a:t>
+            </a:r>
+          </a:p>
+          <a:p xmlns:a="http://schemas.openxmlformats.org/drawingml/2006/main">
+            <a:r>
+              <a:t>La démonstration donne un exemple ; les tests et les métriques complètent cette preuve.</a:t>
             </a:r>
           </a:p>
         </p:txBody>
@@ -1483,22 +2473,112 @@
           <a:lstStyle xmlns:a="http://schemas.openxmlformats.org/drawingml/2006/main"/>
           <a:p xmlns:a="http://schemas.openxmlformats.org/drawingml/2006/main">
             <a:r>
-              <a:t>Durée cible : 75 secondes.</a:t>
-            </a:r>
-          </a:p>
-          <a:p xmlns:a="http://schemas.openxmlformats.org/drawingml/2006/main">
-            <a:r>
-              <a:t>Les 59 tests détectent les régressions techniques : ingestion, normalisation, index, RAG, API et évaluation.</a:t>
-            </a:r>
-          </a:p>
-          <a:p xmlns:a="http://schemas.openxmlformats.org/drawingml/2006/main">
-            <a:r>
-              <a:t>Ils ne remplacent pas l’évaluation de qualité : ils vérifient que le contrat reste intact après un changement.</a:t>
-            </a:r>
-          </a:p>
-          <a:p xmlns:a="http://schemas.openxmlformats.org/drawingml/2006/main">
-            <a:r>
-              <a:t>La CI/CD est une recommandation explicite : elle n’est pas livrée dans ce POC.</a:t>
+              <a:t>09:55–11:00 (65 s)</a:t>
+            </a:r>
+          </a:p>
+          <a:p xmlns:a="http://schemas.openxmlformats.org/drawingml/2006/main">
+            <a:r>
+              <a:t/>
+            </a:r>
+          </a:p>
+          <a:p xmlns:a="http://schemas.openxmlformats.org/drawingml/2006/main">
+            <a:r>
+              <a:t>À LIRE</a:t>
+            </a:r>
+          </a:p>
+          <a:p xmlns:a="http://schemas.openxmlformats.org/drawingml/2006/main">
+            <a:r>
+              <a:t>J'ai exécuté aujourd'hui la suite : les 76 tests passent. Ils vérifient notamment les filtres, la normalisation, la construction et le rechargement de l'index, la forme des réponses, la validation API et le calcul des métriques. Ces tests utilisent des doublures pour les services externes. Ils protègent les comportements du code, sans garantir que Mistral est accessible ni que toutes les réponses métier sont bonnes. Un deuxième niveau contient quatre questions annotées avec des réponses et des titres attendus. Les résultats enregistrés classent les quatre cas comme corrects selon les règles locales. Ces règles sont assez permissives : un titre peut être retrouvé dans les sources sans que la réponse soit parfaite. Je complète donc cette évaluation par RAGAS. L'automatisation en CI serait une prochaine étape ; elle n'est pas implémentée ici.</a:t>
+            </a:r>
+          </a:p>
+          <a:p xmlns:a="http://schemas.openxmlformats.org/drawingml/2006/main">
+            <a:r>
+              <a:t/>
+            </a:r>
+          </a:p>
+          <a:p xmlns:a="http://schemas.openxmlformats.org/drawingml/2006/main">
+            <a:r>
+              <a:t>À MONTRER</a:t>
+            </a:r>
+          </a:p>
+          <a:p xmlns:a="http://schemas.openxmlformats.org/drawingml/2006/main">
+            <a:r>
+              <a:t>Annonce le résultat des tests, puis explique ce qu'ils couvrent. Montre le petit jeu CSV si demandé.</a:t>
+            </a:r>
+          </a:p>
+          <a:p xmlns:a="http://schemas.openxmlformats.org/drawingml/2006/main">
+            <a:r>
+              <a:t/>
+            </a:r>
+          </a:p>
+          <a:p xmlns:a="http://schemas.openxmlformats.org/drawingml/2006/main">
+            <a:r>
+              <a:t>COMPRENDRE</a:t>
+            </a:r>
+          </a:p>
+          <a:p xmlns:a="http://schemas.openxmlformats.org/drawingml/2006/main">
+            <a:r>
+              <a:t>Les tests de code vérifient les mécanismes. Le jeu annoté vérifie des exemples de questions. RAGAS examine la qualité du texte et du contexte. Ce sont trois niveaux de preuve différents. Une doublure simule un service externe pour tester sans internet et sans coût.</a:t>
+            </a:r>
+          </a:p>
+          <a:p xmlns:a="http://schemas.openxmlformats.org/drawingml/2006/main">
+            <a:r>
+              <a:t/>
+            </a:r>
+          </a:p>
+          <a:p xmlns:a="http://schemas.openxmlformats.org/drawingml/2006/main">
+            <a:r>
+              <a:t>DÉTAIL TECHNIQUE</a:t>
+            </a:r>
+          </a:p>
+          <a:p xmlns:a="http://schemas.openxmlformats.org/drawingml/2006/main">
+            <a:r>
+              <a:t>evaluation.py utilise SequenceMatcher sur du texte normalisé : similarité lexicale, pas embedding sémantique. exact_match_soft = égalité après normalisation. matched_expected_titles cherche dans answer OU sources. Sans titre attendu, certaines expressions de refus suffisent à classer correct. Les sorties historiques ont 4 corrects, exact_match_soft_rate=0 et similarité moyenne ~0,131. Ce n'est pas contradictoire, car les mesures ne testent pas la même chose. --ragas sur evaluate_rag.py ne lance pas les quatre métriques ; le vrai script est evaluate_ragas.py.</a:t>
+            </a:r>
+          </a:p>
+          <a:p xmlns:a="http://schemas.openxmlformats.org/drawingml/2006/main">
+            <a:r>
+              <a:t/>
+            </a:r>
+          </a:p>
+          <a:p xmlns:a="http://schemas.openxmlformats.org/drawingml/2006/main">
+            <a:r>
+              <a:t>PIÈGE</a:t>
+            </a:r>
+          </a:p>
+          <a:p xmlns:a="http://schemas.openxmlformats.org/drawingml/2006/main">
+            <a:r>
+              <a:t>Ne transforme pas 4/4 en une précision de 100 % du système. Les tests ne font pas tous des appels Mistral réels.</a:t>
+            </a:r>
+          </a:p>
+          <a:p xmlns:a="http://schemas.openxmlformats.org/drawingml/2006/main">
+            <a:r>
+              <a:t/>
+            </a:r>
+          </a:p>
+          <a:p xmlns:a="http://schemas.openxmlformats.org/drawingml/2006/main">
+            <a:r>
+              <a:t>PREUVE</a:t>
+            </a:r>
+          </a:p>
+          <a:p xmlns:a="http://schemas.openxmlformats.org/drawingml/2006/main">
+            <a:r>
+              <a:t>tests/ ; tests/fixtures/rag_eval_dataset.csv ; scripts/evaluate_rag.py ; outputs/evaluation/latest_summary.json.</a:t>
+            </a:r>
+          </a:p>
+          <a:p xmlns:a="http://schemas.openxmlformats.org/drawingml/2006/main">
+            <a:r>
+              <a:t/>
+            </a:r>
+          </a:p>
+          <a:p xmlns:a="http://schemas.openxmlformats.org/drawingml/2006/main">
+            <a:r>
+              <a:t>TRANSITION</a:t>
+            </a:r>
+          </a:p>
+          <a:p xmlns:a="http://schemas.openxmlformats.org/drawingml/2006/main">
+            <a:r>
+              <a:t>RAGAS nous aide à distinguer une bonne recherche d'une réponse pleinement correcte.</a:t>
             </a:r>
           </a:p>
         </p:txBody>
@@ -1566,7 +2646,7 @@
   </p:cSld>
   <p:clrMap bg1="lt1" tx1="dk1" bg2="lt2" tx2="dk2" accent1="accent1" accent2="accent2" accent3="accent3" accent4="accent4" accent5="accent5" accent6="accent6" hlink="hlink" folHlink="folHlink"/>
   <p:sldLayoutIdLst>
-    <p:sldLayoutId xmlns:r="http://schemas.openxmlformats.org/officeDocument/2006/relationships" id="2147483649" r:id="R831d2d7645f047ea"/>
+    <p:sldLayoutId xmlns:r="http://schemas.openxmlformats.org/officeDocument/2006/relationships" id="2147483649" r:id="R658d5424f4ca4986"/>
   </p:sldLayoutIdLst>
   <p:txStyles>
     <p:titleStyle>
@@ -2352,7 +3432,7 @@
                 <a:ea typeface="Montserrat"/>
                 <a:cs typeface="Montserrat"/>
               </a:rPr>
-              <a:t>Un assistant RAG</a:t>
+              <a:t>Un assistant culturel</a:t>
             </a:r>
           </a:p>
           <a:p xmlns:a="http://schemas.openxmlformats.org/drawingml/2006/main">
@@ -2379,7 +3459,7 @@
                 <a:ea typeface="Montserrat"/>
                 <a:cs typeface="Montserrat"/>
               </a:rPr>
-              <a:t>pour recommander</a:t>
+              <a:t>fondé sur des</a:t>
             </a:r>
           </a:p>
           <a:p xmlns:a="http://schemas.openxmlformats.org/drawingml/2006/main">
@@ -2406,7 +3486,7 @@
                 <a:ea typeface="Montserrat"/>
                 <a:cs typeface="Montserrat"/>
               </a:rPr>
-              <a:t>sans inventer</a:t>
+              <a:t>événements réels</a:t>
             </a:r>
           </a:p>
         </p:txBody>
@@ -2646,7 +3726,7 @@
                 <a:ea typeface="Noto Sans"/>
                 <a:cs typeface="Noto Sans"/>
               </a:rPr>
-              <a:t>Soutenance — reprise</a:t>
+              <a:t>Soutenance · 1er octobre 2026</a:t>
             </a:r>
           </a:p>
         </p:txBody>
@@ -3356,7 +4436,7 @@
                 <a:ea typeface="Montserrat"/>
                 <a:cs typeface="Montserrat"/>
               </a:rPr>
-              <a:t>RAGAS me dit où améliorer la réponse</a:t>
+              <a:t>Les scores RAGAS orientent les améliorations</a:t>
             </a:r>
           </a:p>
         </p:txBody>
@@ -3985,7 +5065,7 @@
                 <a:ea typeface="Noto Sans"/>
                 <a:cs typeface="Noto Sans"/>
               </a:rPr>
-              <a:t>contexte utile</a:t>
+              <a:t>précision du contexte</a:t>
             </a:r>
           </a:p>
         </p:txBody>
@@ -4453,7 +5533,7 @@
                 <a:ea typeface="Montserrat"/>
                 <a:cs typeface="Montserrat"/>
               </a:rPr>
-              <a:t>3 CAS · SIGNAL INITIAL</a:t>
+              <a:t>3 CAS · 23/07/2026</a:t>
             </a:r>
           </a:p>
         </p:txBody>
@@ -5299,7 +6379,7 @@
                 <a:ea typeface="Montserrat"/>
                 <a:cs typeface="Montserrat"/>
               </a:rPr>
-              <a:t>Les limites sont connues, donc pilotables</a:t>
+              <a:t>Les limites définissent le travail avant production</a:t>
             </a:r>
           </a:p>
         </p:txBody>
@@ -5881,7 +6961,7 @@
                 <a:ea typeface="Montserrat"/>
                 <a:cs typeface="Montserrat"/>
               </a:rPr>
-              <a:t>chunks et top_k</a:t>
+              <a:t>top-k sans seuil</a:t>
             </a:r>
           </a:p>
           <a:p xmlns:a="http://schemas.openxmlformats.org/drawingml/2006/main">
@@ -5905,7 +6985,7 @@
                 <a:ea typeface="Montserrat"/>
                 <a:cs typeface="Montserrat"/>
               </a:rPr>
-              <a:t>à calibrer</a:t>
+              <a:t>refus par prompt</a:t>
             </a:r>
           </a:p>
         </p:txBody>
@@ -6241,7 +7321,7 @@
                 <a:ea typeface="Montserrat"/>
                 <a:cs typeface="Montserrat"/>
               </a:rPr>
-              <a:t>FAISS local</a:t>
+              <a:t>Mistral distant</a:t>
             </a:r>
           </a:p>
           <a:p xmlns:a="http://schemas.openxmlformats.org/drawingml/2006/main">
@@ -6265,7 +7345,7 @@
                 <a:ea typeface="Montserrat"/>
                 <a:cs typeface="Montserrat"/>
               </a:rPr>
-              <a:t>instance unique</a:t>
+              <a:t>quota / débit</a:t>
             </a:r>
           </a:p>
         </p:txBody>
@@ -6522,7 +7602,7 @@
               <a:buNone/>
               <a:defRPr sz="1050" b="1">
                 <a:solidFill>
-                  <a:srgbClr val="17234C"/>
+                  <a:srgbClr val="FFFFFF"/>
                 </a:solidFill>
                 <a:latin typeface="Noto Sans"/>
                 <a:ea typeface="Noto Sans"/>
@@ -6532,13 +7612,13 @@
             <a:r>
               <a:rPr sz="1050" b="1">
                 <a:solidFill>
-                  <a:srgbClr val="17234C"/>
+                  <a:srgbClr val="FFFFFF"/>
                 </a:solidFill>
                 <a:latin typeface="Noto Sans"/>
                 <a:ea typeface="Noto Sans"/>
                 <a:cs typeface="Noto Sans"/>
               </a:rPr>
-              <a:t>Le POC prouve la faisabilité. Ces trois chantiers conditionnent un déploiement élargi.</a:t>
+              <a:t>Corpus à actualiser ; refus à renforcer ; modèle de démo changé après une limite sur Small.</a:t>
             </a:r>
           </a:p>
         </p:txBody>
@@ -6930,7 +8010,7 @@
                 <a:ea typeface="Montserrat"/>
                 <a:cs typeface="Montserrat"/>
               </a:rPr>
-              <a:t>Le POC est démontrable.</a:t>
+              <a:t>Un pilote mesuré</a:t>
             </a:r>
           </a:p>
           <a:p xmlns:a="http://schemas.openxmlformats.org/drawingml/2006/main">
@@ -6957,7 +8037,7 @@
                 <a:ea typeface="Montserrat"/>
                 <a:cs typeface="Montserrat"/>
               </a:rPr>
-              <a:t>La suite est mesurée.</a:t>
+              <a:t>est la prochaine étape</a:t>
             </a:r>
           </a:p>
         </p:txBody>
@@ -7891,7 +8971,7 @@
                 <a:ea typeface="Montserrat"/>
                 <a:cs typeface="Montserrat"/>
               </a:rPr>
-              <a:t>pilote multi-villes</a:t>
+              <a:t>pilote mesuré</a:t>
             </a:r>
           </a:p>
         </p:txBody>
@@ -7953,7 +9033,7 @@
                 <a:ea typeface="Noto Sans"/>
                 <a:cs typeface="Noto Sans"/>
               </a:rPr>
-              <a:t>1. élargir les données et le jeu annoté</a:t>
+              <a:t>1. actualiser le corpus et filtrer</a:t>
             </a:r>
           </a:p>
           <a:p xmlns:a="http://schemas.openxmlformats.org/drawingml/2006/main">
@@ -7980,7 +9060,7 @@
                 <a:ea typeface="Noto Sans"/>
                 <a:cs typeface="Noto Sans"/>
               </a:rPr>
-              <a:t>2. ajouter des garde-fous métier</a:t>
+              <a:t>2. élargir le jeu annoté</a:t>
             </a:r>
           </a:p>
           <a:p xmlns:a="http://schemas.openxmlformats.org/drawingml/2006/main">
@@ -8007,7 +9087,7 @@
                 <a:ea typeface="Noto Sans"/>
                 <a:cs typeface="Noto Sans"/>
               </a:rPr>
-              <a:t>3. industrialiser si la valeur est confirmée</a:t>
+              <a:t>3. mesurer avant industrialisation</a:t>
             </a:r>
           </a:p>
         </p:txBody>
@@ -8129,7 +9209,7 @@
                 <a:ea typeface="Noto Sans"/>
                 <a:cs typeface="Noto Sans"/>
               </a:rPr>
-              <a:t>Rapport, scripts et dépôt disponibles pour la discussion technique</a:t>
+              <a:t>Rapport, dépôt, scripts et résultats : preuves consultables pour la discussion technique</a:t>
             </a:r>
           </a:p>
         </p:txBody>
@@ -8369,7 +9449,7 @@
                 <a:ea typeface="Montserrat"/>
                 <a:cs typeface="Montserrat"/>
               </a:rPr>
-              <a:t>Une question devient une recommandation sourcée</a:t>
+              <a:t>Le RAG relie la réponse au catalogue</a:t>
             </a:r>
           </a:p>
         </p:txBody>
@@ -8650,7 +9730,7 @@
                 <a:ea typeface="Noto Sans"/>
                 <a:cs typeface="Noto Sans"/>
               </a:rPr>
-              <a:t>« Que faire</a:t>
+              <a:t>« Une sortie</a:t>
             </a:r>
           </a:p>
           <a:p xmlns:a="http://schemas.openxmlformats.org/drawingml/2006/main">
@@ -8674,7 +9754,7 @@
                 <a:ea typeface="Noto Sans"/>
                 <a:cs typeface="Noto Sans"/>
               </a:rPr>
-              <a:t>ce week-end ? »</a:t>
+              <a:t>en famille ? »</a:t>
             </a:r>
           </a:p>
         </p:txBody>
@@ -10556,7 +11636,7 @@
                 <a:ea typeface="Montserrat"/>
                 <a:cs typeface="Montserrat"/>
               </a:rPr>
-              <a:t>Le nettoyage transforme OpenAgenda en corpus exploitable</a:t>
+              <a:t>Le corpus est un instantané explicite de Paris</a:t>
             </a:r>
           </a:p>
         </p:txBody>
@@ -11210,7 +12290,7 @@
                 <a:ea typeface="Noto Sans"/>
                 <a:cs typeface="Noto Sans"/>
               </a:rPr>
-              <a:t>Paris · &lt; 1 an</a:t>
+              <a:t>Paris · seed juillet 2026</a:t>
             </a:r>
           </a:p>
         </p:txBody>
@@ -11939,7 +13019,7 @@
                 <a:ea typeface="Noto Sans"/>
                 <a:cs typeface="Noto Sans"/>
               </a:rPr>
-              <a:t>Je conserve titre, description, date, lieu et URL : chaque réponse peut revenir à sa source.</a:t>
+              <a:t>Titre, description, date, lieu et URL conservés. Corpus figé : fraîcheur à réévaluer.</a:t>
             </a:r>
           </a:p>
         </p:txBody>
@@ -12328,7 +13408,7 @@
                 <a:ea typeface="Montserrat"/>
                 <a:cs typeface="Montserrat"/>
               </a:rPr>
-              <a:t>CHIMERE devient 14 903 passages recherchables</a:t>
+              <a:t>Les descriptions deviennent des passages recherchables</a:t>
             </a:r>
           </a:p>
         </p:txBody>
@@ -13977,7 +15057,7 @@
                 <a:ea typeface="Noto Sans"/>
                 <a:cs typeface="Noto Sans"/>
               </a:rPr>
-              <a:t>+ métadonnées</a:t>
+              <a:t>14 903 passages</a:t>
             </a:r>
           </a:p>
         </p:txBody>
@@ -14126,7 +15206,7 @@
                 <a:ea typeface="Noto Sans"/>
                 <a:cs typeface="Noto Sans"/>
               </a:rPr>
-              <a:t>Le chevauchement protège les informations placées entre deux passages.</a:t>
+              <a:t>CHIMERE : 15 passages. Tout le corpus : 14 903 vecteurs. Métadonnées conservées.</a:t>
             </a:r>
           </a:p>
         </p:txBody>
@@ -14515,7 +15595,7 @@
                 <a:ea typeface="Montserrat"/>
                 <a:cs typeface="Montserrat"/>
               </a:rPr>
-              <a:t>Le prompt impose une réponse fondée sur les sources</a:t>
+              <a:t>Mistral reçoit la question et quatre passages</a:t>
             </a:r>
           </a:p>
         </p:txBody>
@@ -14740,7 +15820,7 @@
                 <a:ea typeface="Montserrat"/>
                 <a:cs typeface="Montserrat"/>
               </a:rPr>
-              <a:t>La réponse doit rester en français, utiliser le contexte retrouvé, ne pas inventer et dire « Je ne sais pas » lorsque le contexte manque.</a:t>
+              <a:t>Le prompt demande une réponse en français fondée sur le contexte, et un refus si les passages ne permettent pas de répondre. Il réduit le risque sans le supprimer.</a:t>
             </a:r>
           </a:p>
         </p:txBody>
@@ -15106,7 +16186,7 @@
                 <a:ea typeface="Noto Sans"/>
                 <a:cs typeface="Noto Sans"/>
               </a:rPr>
-              <a:t>mistral-small-latest</a:t>
+              <a:t>ministral-8b-2512</a:t>
             </a:r>
           </a:p>
         </p:txBody>
@@ -15161,7 +16241,7 @@
           <p:nvPr/>
         </p:nvPicPr>
         <p:blipFill>
-          <a:blip xmlns:r="http://schemas.openxmlformats.org/officeDocument/2006/relationships" xmlns:a="http://schemas.openxmlformats.org/drawingml/2006/main" r:embed="R4b56819ab4284b94"/>
+          <a:blip xmlns:r="http://schemas.openxmlformats.org/officeDocument/2006/relationships" xmlns:a="http://schemas.openxmlformats.org/drawingml/2006/main" r:embed="R58bece4b608f4c4c"/>
           <a:stretch xmlns:a="http://schemas.openxmlformats.org/drawingml/2006/main"/>
         </p:blipFill>
         <p:spPr>
@@ -15236,7 +16316,7 @@
                 <a:latin typeface="Montserrat"/>
                 <a:ea typeface="Montserrat"/>
                 <a:cs typeface="Montserrat"/>
-                <a:hlinkClick xmlns:r="http://schemas.openxmlformats.org/officeDocument/2006/relationships" r:id="R6844438907d94cc3"/>
+                <a:hlinkClick xmlns:r="http://schemas.openxmlformats.org/officeDocument/2006/relationships" r:id="R0d68c91a4a2f4fbe"/>
               </a:rPr>
               <a:t>TEMPÉRATURE 0,1</a:t>
             </a:r>
@@ -15305,7 +16385,7 @@
                 <a:latin typeface="Montserrat"/>
                 <a:ea typeface="Montserrat"/>
                 <a:cs typeface="Montserrat"/>
-                <a:hlinkClick xmlns:r="http://schemas.openxmlformats.org/officeDocument/2006/relationships" r:id="R0b78160179b54897"/>
+                <a:hlinkClick xmlns:r="http://schemas.openxmlformats.org/officeDocument/2006/relationships" r:id="Rcfdfabe040e647bb"/>
               </a:rPr>
               <a:t>SOURCES DISTINCTES</a:t>
             </a:r>
@@ -15755,7 +16835,7 @@
                 <a:ea typeface="Montserrat"/>
                 <a:cs typeface="Montserrat"/>
               </a:rPr>
-              <a:t>La chaîne RAG sépare préparation et réponse en ligne</a:t>
+              <a:t>La préparation de l’index précède les questions</a:t>
             </a:r>
           </a:p>
         </p:txBody>
@@ -17433,7 +18513,7 @@
                 <a:ea typeface="Noto Sans"/>
                 <a:cs typeface="Noto Sans"/>
               </a:rPr>
-              <a:t>Hors ligne : données → index.  En ligne : question → réponse sourcée.</a:t>
+              <a:t>Préparation : données → index. À chaque question : recherche → réponse. Mistral est distant.</a:t>
             </a:r>
           </a:p>
         </p:txBody>
@@ -17822,7 +18902,7 @@
                 <a:ea typeface="Montserrat"/>
                 <a:cs typeface="Montserrat"/>
               </a:rPr>
-              <a:t>FastAPI expose le RAG comme un service testable</a:t>
+              <a:t>L’API rend le POC accessible aux équipes</a:t>
             </a:r>
           </a:p>
         </p:txBody>
@@ -18413,7 +19493,7 @@
                 <a:ea typeface="Noto Sans"/>
                 <a:cs typeface="Noto Sans"/>
               </a:rPr>
-              <a:t>/rebuild protégé</a:t>
+              <a:t>/rebuild · jeton optionnel</a:t>
             </a:r>
           </a:p>
         </p:txBody>
@@ -18468,7 +19548,7 @@
           <p:nvPr/>
         </p:nvPicPr>
         <p:blipFill>
-          <a:blip xmlns:r="http://schemas.openxmlformats.org/officeDocument/2006/relationships" xmlns:a="http://schemas.openxmlformats.org/drawingml/2006/main" r:embed="R6b569ac3944242bd"/>
+          <a:blip xmlns:r="http://schemas.openxmlformats.org/officeDocument/2006/relationships" xmlns:a="http://schemas.openxmlformats.org/drawingml/2006/main" r:embed="R0b1b0e14e9104d13"/>
           <a:srcRect xmlns:a="http://schemas.openxmlformats.org/drawingml/2006/main" l="5000" t="0" r="5000" b="0"/>
           <a:stretch xmlns:a="http://schemas.openxmlformats.org/drawingml/2006/main">
             <a:fillRect l="0" t="0" r="0" b="0"/>
@@ -18546,7 +19626,7 @@
                 <a:latin typeface="Montserrat"/>
                 <a:ea typeface="Montserrat"/>
                 <a:cs typeface="Montserrat"/>
-                <a:hlinkClick xmlns:r="http://schemas.openxmlformats.org/officeDocument/2006/relationships" r:id="R7343f8f3aeb44311"/>
+                <a:hlinkClick xmlns:r="http://schemas.openxmlformats.org/officeDocument/2006/relationships" r:id="Rf321966d5c544d76"/>
               </a:rPr>
               <a:t>DOCKER COMPOSE</a:t>
             </a:r>
@@ -18615,7 +19695,7 @@
                 <a:latin typeface="Montserrat"/>
                 <a:ea typeface="Montserrat"/>
                 <a:cs typeface="Montserrat"/>
-                <a:hlinkClick xmlns:r="http://schemas.openxmlformats.org/officeDocument/2006/relationships" r:id="R0cc91732c0cc4dd5"/>
+                <a:hlinkClick xmlns:r="http://schemas.openxmlformats.org/officeDocument/2006/relationships" r:id="Ra8253bb7978e4b6e"/>
               </a:rPr>
               <a:t>SWAGGER /docs</a:t>
             </a:r>
@@ -18676,7 +19756,7 @@
                 <a:ea typeface="Noto Sans"/>
                 <a:cs typeface="Noto Sans"/>
               </a:rPr>
-              <a:t>L’index est chargé au démarrage : l’usage courant ne relance ni l’ingestion ni l’indexation.</a:t>
+              <a:t>Retriever chargé à la première question, puis réutilisé. /health ne teste pas Mistral.</a:t>
             </a:r>
           </a:p>
         </p:txBody>
@@ -19065,7 +20145,7 @@
                 <a:ea typeface="Montserrat"/>
                 <a:cs typeface="Montserrat"/>
               </a:rPr>
-              <a:t>La démo vérifie une valeur et une limite métier</a:t>
+              <a:t>La démonstration montre un résultat et une limite</a:t>
             </a:r>
           </a:p>
         </p:txBody>
@@ -19290,7 +20370,7 @@
                 <a:ea typeface="Noto Sans"/>
                 <a:cs typeface="Noto Sans"/>
               </a:rPr>
-              <a:t>index chargé</a:t>
+              <a:t>serveur disponible</a:t>
             </a:r>
           </a:p>
           <a:p xmlns:a="http://schemas.openxmlformats.org/drawingml/2006/main">
@@ -19317,7 +20397,7 @@
                 <a:ea typeface="Noto Sans"/>
                 <a:cs typeface="Noto Sans"/>
               </a:rPr>
-              <a:t>service prêt</a:t>
+              <a:t>configuration déclarée</a:t>
             </a:r>
           </a:p>
         </p:txBody>
@@ -19984,7 +21064,7 @@
                 <a:ea typeface="Montserrat"/>
                 <a:cs typeface="Montserrat"/>
               </a:rPr>
-              <a:t>LATENCE</a:t>
+              <a:t>MODE DIRECT</a:t>
             </a:r>
           </a:p>
         </p:txBody>
@@ -20046,7 +21126,7 @@
                 <a:ea typeface="Noto Sans"/>
                 <a:cs typeface="Noto Sans"/>
               </a:rPr>
-              <a:t>démo complète</a:t>
+              <a:t>Direct rétabli</a:t>
             </a:r>
           </a:p>
           <a:p xmlns:a="http://schemas.openxmlformats.org/drawingml/2006/main">
@@ -20073,7 +21153,7 @@
                 <a:ea typeface="Noto Sans"/>
                 <a:cs typeface="Noto Sans"/>
               </a:rPr>
-              <a:t>≈ 3 secondes</a:t>
+              <a:t>Ministral 8B</a:t>
             </a:r>
           </a:p>
         </p:txBody>
@@ -20140,7 +21220,7 @@
                 <a:latin typeface="Montserrat"/>
                 <a:ea typeface="Montserrat"/>
                 <a:cs typeface="Montserrat"/>
-                <a:hlinkClick xmlns:r="http://schemas.openxmlformats.org/officeDocument/2006/relationships" r:id="Rdc0d2bd3f0bb4434"/>
+                <a:hlinkClick xmlns:r="http://schemas.openxmlformats.org/officeDocument/2006/relationships" r:id="Rade46dc666c6449b"/>
               </a:rPr>
               <a:t>API</a:t>
             </a:r>
@@ -20209,7 +21289,7 @@
                 <a:latin typeface="Montserrat"/>
                 <a:ea typeface="Montserrat"/>
                 <a:cs typeface="Montserrat"/>
-                <a:hlinkClick xmlns:r="http://schemas.openxmlformats.org/officeDocument/2006/relationships" r:id="R2ef9d6a475dc4c6d"/>
+                <a:hlinkClick xmlns:r="http://schemas.openxmlformats.org/officeDocument/2006/relationships" r:id="R84840a9d63364149"/>
               </a:rPr>
               <a:t>SOURCES</a:t>
             </a:r>
@@ -20278,7 +21358,7 @@
                 <a:latin typeface="Montserrat"/>
                 <a:ea typeface="Montserrat"/>
                 <a:cs typeface="Montserrat"/>
-                <a:hlinkClick xmlns:r="http://schemas.openxmlformats.org/officeDocument/2006/relationships" r:id="Rf96b4979790041db"/>
+                <a:hlinkClick xmlns:r="http://schemas.openxmlformats.org/officeDocument/2006/relationships" r:id="R898837321585492a"/>
               </a:rPr>
               <a:t>PRUDENCE</a:t>
             </a:r>
@@ -20347,7 +21427,7 @@
                 <a:latin typeface="Montserrat"/>
                 <a:ea typeface="Montserrat"/>
                 <a:cs typeface="Montserrat"/>
-                <a:hlinkClick xmlns:r="http://schemas.openxmlformats.org/officeDocument/2006/relationships" r:id="R520f488127a54c0a"/>
+                <a:hlinkClick xmlns:r="http://schemas.openxmlformats.org/officeDocument/2006/relationships" r:id="R1657cbd2ebce444f"/>
               </a:rPr>
               <a:t>DOCKER</a:t>
             </a:r>
@@ -20508,7 +21588,7 @@
                 <a:ea typeface="Noto Sans"/>
                 <a:cs typeface="Noto Sans"/>
               </a:rPr>
-              <a:t>Je montre volontairement un cas Paris sourcé et un cas Lyon hors périmètre : pas seulement un exemple favorable.</a:t>
+              <a:t>Secours : réponses du jour explicitement enregistrées. Ne pas les présenter comme du live.</a:t>
             </a:r>
           </a:p>
         </p:txBody>
@@ -20748,7 +21828,7 @@
                 <a:ea typeface="Montserrat"/>
                 <a:cs typeface="Montserrat"/>
               </a:rPr>
-              <a:t>59 tests protègent les comportements critiques</a:t>
+              <a:t>Les tests du code et la qualité se complètent</a:t>
             </a:r>
           </a:p>
         </p:txBody>
@@ -22079,7 +23159,7 @@
                 <a:ea typeface="Noto Sans Mono"/>
                 <a:cs typeface="Noto Sans Mono"/>
               </a:rPr>
-              <a:t>LIVRÉ · pytest passe</a:t>
+              <a:t>01/10/2026 · 76 tests passent</a:t>
             </a:r>
           </a:p>
         </p:txBody>
@@ -22179,7 +23259,7 @@
                 <a:ea typeface="Noto Sans"/>
                 <a:cs typeface="Noto Sans"/>
               </a:rPr>
-              <a:t>CI/CD proposée : à chaque push, tests → image Docker → healthcheck → rapport. Elle n’est pas implémentée dans le POC.</a:t>
+              <a:t>76 tests locaux ; 4 cas fonctionnels aux règles permissives ; CI/CD proposée, non implémentée.</a:t>
             </a:r>
           </a:p>
         </p:txBody>

</xml_diff>

<commit_message>
docs: guider la soutenance avec l'analogie du catalogue
</commit_message>
<xml_diff>
--- a/outputs/openagenda-rag-soutenance.pptx
+++ b/outputs/openagenda-rag-soutenance.pptx
@@ -2,24 +2,24 @@
 <file path=ppt/presentation.xml><?xml version="1.0" encoding="utf-8"?>
 <p:presentation xmlns:p="http://schemas.openxmlformats.org/presentationml/2006/main">
   <p:sldMasterIdLst>
-    <p:sldMasterId xmlns:r="http://schemas.openxmlformats.org/officeDocument/2006/relationships" id="2147483648" r:id="R6a8fbe256a314e47"/>
+    <p:sldMasterId xmlns:r="http://schemas.openxmlformats.org/officeDocument/2006/relationships" id="2147483648" r:id="Rc4ca9f147d284d3e"/>
   </p:sldMasterIdLst>
   <p:notesMasterIdLst>
-    <p:notesMasterId xmlns:r="http://schemas.openxmlformats.org/officeDocument/2006/relationships" r:id="R7fe5560f40fe46c4"/>
+    <p:notesMasterId xmlns:r="http://schemas.openxmlformats.org/officeDocument/2006/relationships" r:id="R640021b1d5804199"/>
   </p:notesMasterIdLst>
   <p:sldIdLst>
-    <p:sldId xmlns:r="http://schemas.openxmlformats.org/officeDocument/2006/relationships" id="256" r:id="Rccb5c49d54b645ba"/>
-    <p:sldId xmlns:r="http://schemas.openxmlformats.org/officeDocument/2006/relationships" id="257" r:id="R333589e2f24e4976"/>
-    <p:sldId xmlns:r="http://schemas.openxmlformats.org/officeDocument/2006/relationships" id="258" r:id="R7da47506f2e94179"/>
-    <p:sldId xmlns:r="http://schemas.openxmlformats.org/officeDocument/2006/relationships" id="259" r:id="R403d53b9ecfb4732"/>
-    <p:sldId xmlns:r="http://schemas.openxmlformats.org/officeDocument/2006/relationships" id="260" r:id="R15d30d183d8c47a5"/>
-    <p:sldId xmlns:r="http://schemas.openxmlformats.org/officeDocument/2006/relationships" id="261" r:id="Re32567accb2a42e2"/>
-    <p:sldId xmlns:r="http://schemas.openxmlformats.org/officeDocument/2006/relationships" id="262" r:id="R44037b23f42d4317"/>
-    <p:sldId xmlns:r="http://schemas.openxmlformats.org/officeDocument/2006/relationships" id="263" r:id="R054b16c23fd84cb0"/>
-    <p:sldId xmlns:r="http://schemas.openxmlformats.org/officeDocument/2006/relationships" id="264" r:id="R02302282292e477a"/>
-    <p:sldId xmlns:r="http://schemas.openxmlformats.org/officeDocument/2006/relationships" id="265" r:id="Re98d3fb59f444e3f"/>
-    <p:sldId xmlns:r="http://schemas.openxmlformats.org/officeDocument/2006/relationships" id="266" r:id="R871bba280d4d4d50"/>
-    <p:sldId xmlns:r="http://schemas.openxmlformats.org/officeDocument/2006/relationships" id="267" r:id="R84cf7f04a2e6446b"/>
+    <p:sldId xmlns:r="http://schemas.openxmlformats.org/officeDocument/2006/relationships" id="256" r:id="R5677905291ee4aa2"/>
+    <p:sldId xmlns:r="http://schemas.openxmlformats.org/officeDocument/2006/relationships" id="257" r:id="R8d039abab63e462c"/>
+    <p:sldId xmlns:r="http://schemas.openxmlformats.org/officeDocument/2006/relationships" id="258" r:id="R4edff52d71024b79"/>
+    <p:sldId xmlns:r="http://schemas.openxmlformats.org/officeDocument/2006/relationships" id="259" r:id="R7fe9351b2b894f60"/>
+    <p:sldId xmlns:r="http://schemas.openxmlformats.org/officeDocument/2006/relationships" id="260" r:id="R7b6285a699d4494d"/>
+    <p:sldId xmlns:r="http://schemas.openxmlformats.org/officeDocument/2006/relationships" id="261" r:id="R8ed9209ba0db47d4"/>
+    <p:sldId xmlns:r="http://schemas.openxmlformats.org/officeDocument/2006/relationships" id="262" r:id="R568fb63f979d4a81"/>
+    <p:sldId xmlns:r="http://schemas.openxmlformats.org/officeDocument/2006/relationships" id="263" r:id="Rb441118189574bef"/>
+    <p:sldId xmlns:r="http://schemas.openxmlformats.org/officeDocument/2006/relationships" id="264" r:id="R008e9bc478ac4d1e"/>
+    <p:sldId xmlns:r="http://schemas.openxmlformats.org/officeDocument/2006/relationships" id="265" r:id="Rc0d455ccc59c468c"/>
+    <p:sldId xmlns:r="http://schemas.openxmlformats.org/officeDocument/2006/relationships" id="266" r:id="Ra1d695ccb8f048ff"/>
+    <p:sldId xmlns:r="http://schemas.openxmlformats.org/officeDocument/2006/relationships" id="267" r:id="R50b5c12ea071479b"/>
   </p:sldIdLst>
   <p:sldSz cx="12192000" cy="6858000"/>
   <p:notesSz cx="6858000" cy="9144000"/>
@@ -563,7 +563,7 @@
           </a:p>
           <a:p xmlns:a="http://schemas.openxmlformats.org/drawingml/2006/main">
             <a:r>
-              <a:t>Bonjour Jérémy. Je vais vous présenter le prototype réalisé pour Puls-Events, un assistant de recommandation culturelle qui utilise les événements OpenAgenda. Le besoin est de permettre aux utilisateurs de poser une question naturellement, puis de recevoir une réponse qu'ils peuvent vérifier grâce aux sources. Mon livrable couvre toute la chaîne : collecte et préparation des données, recherche vectorielle, génération de réponse, API et conteneur Docker. Le corpus livré contient 7 586 événements parisiens. Il s'agit d'un POC, donc d'une preuve de faisabilité. Je vais expliquer les choix, montrer l'API et présenter les résultats ainsi que les limites avant un déploiement plus large.</a:t>
+              <a:t>Bonjour Jérémy. Pour expliquer ce POC, je vous propose une image simple : une bibliothèque d'événements culturels. Un visiteur arrive avec une demande, par exemple une sortie en famille à Paris. Il souhaite une réponse utile et des informations qu'il peut vérifier. Mon travail a été de constituer le catalogue, de préparer ses fiches pour la recherche, puis de relier cette recherche à un modèle qui rédige et à une API que vos équipes peuvent appeler. Le catalogue livré contient 7 586 événements parisiens. Je vais suivre ce parcours avec vous, montrer deux demandes en direct et expliquer ce qui fonctionne ainsi que ce qui reste à améliorer.</a:t>
             </a:r>
           </a:p>
           <a:p xmlns:a="http://schemas.openxmlformats.org/drawingml/2006/main">
@@ -593,7 +593,7 @@
           </a:p>
           <a:p xmlns:a="http://schemas.openxmlformats.org/drawingml/2006/main">
             <a:r>
-              <a:t>Tu joues le rôle du freelance qui livre un prototype à son client. Jérémy est le responsable technique. Tu présentes une solution testable, avec ses preuves et ses limites. POC signifie preuve de concept : vérifier que l'idée fonctionne avant de construire un produit à grande échelle.</a:t>
+              <a:t>Le catalogue est réel. Le bibliothécaire est une image pour expliquer la recherche, pas une personne ni un modèle entraîné sur tes données.</a:t>
             </a:r>
           </a:p>
           <a:p xmlns:a="http://schemas.openxmlformats.org/drawingml/2006/main">
@@ -653,7 +653,7 @@
           </a:p>
           <a:p xmlns:a="http://schemas.openxmlformats.org/drawingml/2006/main">
             <a:r>
-              <a:t>Commençons par le risque métier que le RAG cherche à réduire.</a:t>
+              <a:t>Pour comprendre la solution, séparons le catalogue, la recherche et la rédaction.</a:t>
             </a:r>
           </a:p>
         </p:txBody>
@@ -738,7 +738,7 @@
           </a:p>
           <a:p xmlns:a="http://schemas.openxmlformats.org/drawingml/2006/main">
             <a:r>
-              <a:t>L'évaluation RAGAS porte sur trois cas : Concert Fishers, le Salon de la Photo et une sortie en famille avec visite théâtralisée. Pour chaque cas, je conserve la question, les passages réellement transmis au modèle, la réponse et une référence humaine. Un modèle juge calcule quatre métriques. La fidélité mesure si la réponse est soutenue par le contexte. La pertinence mesure son adéquation à la question. La précision du contexte apprécie la pertinence et le classement des passages récupérés ; elle ne mesure pas la couverture de tout le catalogue. La correction compare la réponse à la référence. Les moyennes enregistrées le 23 juillet sont 0,900, 0,846, 1,000 et 0,683. Le dernier score montre que des écarts demeurent même avec un contexte utile. Sur le cas famille, le score de correction est d'environ 0,581 et la réponse ajoute des informations pratiques à vérifier. La priorité est donc de mieux cadrer la réponse, contrôler les faits et élargir le jeu d'évaluation. Trois exemples démontrent la méthode, pas la performance générale.</a:t>
+              <a:t>J'ai aussi utilisé RAGAS sur trois cas, avec les passages effectivement récupérés, la réponse et une référence humaine. Reprenons la bibliothèque. La fidélité demande si les affirmations du rédacteur sont soutenues par les extraits : sa moyenne est 0,900. La pertinence demande si la réponse traite la demande du visiteur : 0,846. La précision du contexte examine l'utilité et l'ordre des extraits apportés par le bibliothécaire : 1,000. Ce score ne signifie pas qu'il a retrouvé tous les événements pertinents. La correction compare la réponse à la référence attendue : 0,683. Une réponse peut donc être cohérente avec les extraits, tout en oubliant une information ou en s'éloignant de la référence. Le cas famille est le plus faible en correction, autour de 0,581. Ces résultats datent du 23 juillet, utilisent Mistral Small et ne portent que sur trois cas. Ils orientent les améliorations ; ils ne démontrent pas la qualité générale de Ministral 8B.</a:t>
             </a:r>
           </a:p>
           <a:p xmlns:a="http://schemas.openxmlformats.org/drawingml/2006/main">
@@ -768,7 +768,7 @@
           </a:p>
           <a:p xmlns:a="http://schemas.openxmlformats.org/drawingml/2006/main">
             <a:r>
-              <a:t>Fidélité : est-ce écrit dans les fiches ? Pertinence : est-ce que ça répond à la question ? Précision du contexte : les passages utiles arrivent-ils bien placés ? Correction : est-ce conforme à ce que la réponse humaine attend ? Une réponse peut être fidèle à un document, mais incomplète ou mal ciblée.</a:t>
+              <a:t>Fidélité = appui sur les extraits. Pertinence = réponse à la demande. Précision du contexte = utilité des extraits. Correction = accord avec la référence. Ce sont des scores du petit échantillon, pas des pourcentages de satisfaction.</a:t>
             </a:r>
           </a:p>
           <a:p xmlns:a="http://schemas.openxmlformats.org/drawingml/2006/main">
@@ -828,7 +828,7 @@
           </a:p>
           <a:p xmlns:a="http://schemas.openxmlformats.org/drawingml/2006/main">
             <a:r>
-              <a:t>Ces résultats et la démonstration permettent d'identifier les limites prioritaires.</a:t>
+              <a:t>Ces contrôles mettent en évidence trois limites concrètes de notre bibliothèque.</a:t>
             </a:r>
           </a:p>
         </p:txBody>
@@ -913,7 +913,7 @@
           </a:p>
           <a:p xmlns:a="http://schemas.openxmlformats.org/drawingml/2006/main">
             <a:r>
-              <a:t>La première limite est le corpus : il est limité à Paris et figé en juillet. Pour recommander des sorties actuelles, il faut automatiser son actualisation et filtrer les dates au moment de la demande. La deuxième concerne la recherche : le top-k renvoie les voisins les plus proches même lorsqu'ils ne répondent pas réellement à la question. Le refus repose alors sur le prompt et le modèle. Un seuil calibré et des filtres explicites seraient plus robustes. La troisième limite est l'exploitation. L'index est local, mais les embeddings de question et la génération appellent Mistral. Aujourd'hui, Mistral Small était limité. La démo a été rétablie avec Ministral 8B, sans changer les embeddings. Les erreurs fournisseur sont désormais contrôlées. Ce nouveau modèle doit être réévalué ; les anciens scores ne lui sont pas attribués. Enfin, trois cas RAGAS restent insuffisants pour conclure à une qualité générale.</a:t>
+              <a:t>La première limite concerne le catalogue : il est limité à Paris et figé en juillet. Il faut actualiser les fiches et filtrer les occurrences pour recommander des sorties actuelles. La deuxième concerne le bibliothécaire : il apporte les passages les plus proches, même lorsque leur ville ou leur date ne répond pas à la demande. Un seuil calibré et des filtres explicites rendraient le refus plus robuste. La troisième concerne le rédacteur : il dépend de Mistral, peut rencontrer une limite d'usage et peut encore ajouter un conseil hors contexte. J'ai rétabli la démo avec Ministral 8B et contrôlé les erreurs fournisseur, mais cela ne prouve pas une qualité équivalente à Small. Il faut réévaluer ce modèle, diversifier les questions et renforcer les contrôles avant un déploiement plus large.</a:t>
             </a:r>
           </a:p>
           <a:p xmlns:a="http://schemas.openxmlformats.org/drawingml/2006/main">
@@ -943,7 +943,7 @@
           </a:p>
           <a:p xmlns:a="http://schemas.openxmlformats.org/drawingml/2006/main">
             <a:r>
-              <a:t>Tu n'as pas besoin de défendre le prototype comme parfait. Tu dois connaître ses limites, montrer leur effet et proposer une action concrète. La panne initiale a été contournée par un modèle Mistral disponible. Ce changement permet la démo, mais ne prouve pas une qualité équivalente.</a:t>
+              <a:t>Catalogue incomplet → données à actualiser. Mauvais extraits → recherche à calibrer. Conseil fragile → réponse à vérifier. L’analogie explique les responsabilités sans masquer les limites.</a:t>
             </a:r>
           </a:p>
           <a:p xmlns:a="http://schemas.openxmlformats.org/drawingml/2006/main">
@@ -1003,7 +1003,7 @@
           </a:p>
           <a:p xmlns:a="http://schemas.openxmlformats.org/drawingml/2006/main">
             <a:r>
-              <a:t>Je propose donc une suite mesurée, fondée sur les risques identifiés.</a:t>
+              <a:t>La prochaine étape est donc d’améliorer cette bibliothèque et de mesurer son utilité avec vos équipes.</a:t>
             </a:r>
           </a:p>
         </p:txBody>
@@ -1088,7 +1088,7 @@
           </a:p>
           <a:p xmlns:a="http://schemas.openxmlformats.org/drawingml/2006/main">
             <a:r>
-              <a:t>Pour conclure, le POC livre une chaîne complète : des données réelles, un index persistant, une génération augmentée, une API, Docker, des tests et une méthode d'évaluation. Je recommande d'abord d'actualiser le corpus et d'ajouter les garde-fous de ville et de date. Ensuite, d'élargir le jeu annoté et de comparer les paramètres de recherche. Un pilote doit mesurer la réponse utile, les refus corrects, les clics vers les sources, la latence et le coût. Je vous montre brièvement les preuves dans le rapport et le dépôt. Le rapport documente les choix et les résultats. Dans le dépôt, scripts permet de relancer les étapes, src contient le moteur et l'API, tests les validations, et seed-data le corpus de référence. Ces éléments permettent à une autre personne de reproduire et d'examiner le POC. Je suis prêt à répondre à vos questions.</a:t>
+              <a:t>Pour conclure, le POC livre notre bibliothèque : un catalogue réel, des passages indexés, une recherche par proximité de sens, un rédacteur guidé par les sources et un guichet API accessible avec Docker. Je propose d'abord d'actualiser le catalogue et d'ajouter les contraintes de ville et de date. Ensuite, d'élargir les références humaines et de comparer les réglages ainsi que les modèles. Enfin, un pilote doit mesurer l'utilité des réponses, les refus corrects, les clics vers les sources, la latence et le coût. Je vous montre brièvement le rapport et le dépôt : scripts permet de relancer les étapes, src contient le moteur et le guichet, tests les contrôles, et seed-data le catalogue de référence et son index. La solution est examinable et testable ; sa qualité à plus grande échelle reste à mesurer. Je suis prêt à répondre à vos questions.</a:t>
             </a:r>
           </a:p>
           <a:p xmlns:a="http://schemas.openxmlformats.org/drawingml/2006/main">
@@ -1118,7 +1118,7 @@
           </a:p>
           <a:p xmlns:a="http://schemas.openxmlformats.org/drawingml/2006/main">
             <a:r>
-              <a:t>La conclusion répond à la demande du client : est-ce faisable, quelles preuves avons-nous, que faut-il faire ensuite ? Tu proposes une expérimentation, pas une promesse de conversion ou de qualité universelle.</a:t>
+              <a:t>Ta conclusion : une chaîne concrète est livrée, des preuves existent et les prochains travaux répondent aux limites observées. Pas de promesse de production ou de qualité parfaite.</a:t>
             </a:r>
           </a:p>
           <a:p xmlns:a="http://schemas.openxmlformats.org/drawingml/2006/main">
@@ -1178,7 +1178,7 @@
           </a:p>
           <a:p xmlns:a="http://schemas.openxmlformats.org/drawingml/2006/main">
             <a:r>
-              <a:t>Discussion : écoute la question, réponds en une phrase, puis donne la preuve ou la limite utile.</a:t>
+              <a:t>Discussion : commence par la réponse courte, puis explique le composant et la preuve concernés.</a:t>
             </a:r>
           </a:p>
         </p:txBody>
@@ -1263,7 +1263,7 @@
           </a:p>
           <a:p xmlns:a="http://schemas.openxmlformats.org/drawingml/2006/main">
             <a:r>
-              <a:t>Le problème métier est qu'une recherche par mots-clés ne correspond pas toujours à la façon dont un utilisateur exprime son envie. Par exemple, une sortie en famille peut correspondre à une visite jouée par des comédiens, même si les mots utilisés diffèrent. Un modèle de langage seul peut produire une réponse convaincante sans connaître les événements du catalogue. Le RAG combine deux capacités. Il recherche d'abord des passages proches du sens de la question. Il ajoute ensuite ces passages au contexte du modèle. Enfin, Mistral formule une réponse en français. Les sources permettent de revenir aux événements d'origine. Le RAG réduit ainsi le risque d'invention, mais ne le supprime pas : il faut encore vérifier la pertinence des passages et la fidélité de la réponse.</a:t>
+              <a:t>Dans notre bibliothèque, les fiches OpenAgenda forment le catalogue. Chaque fiche décrit un événement, avec son titre, son lieu, ses dates et son lien. Le bibliothécaire représente la recherche avec FAISS : il retrouve des passages proches de la demande. Puis un rédacteur, le modèle Mistral, reçoit ces passages et formule la réponse. Les embeddings sont ce qui permet de comparer numériquement le sens des textes et de la question. Le RAG consiste à chercher d'abord, puis à rédiger avec les informations retrouvées. Je n'ai pas entraîné Mistral sur le catalogue : j'ai construit l'index et organisé ce passage d'informations. L'analogie a une limite : FAISS compare des vecteurs, il ne comprend pas toutes les contraintes comme un bibliothécaire humain.</a:t>
             </a:r>
           </a:p>
           <a:p xmlns:a="http://schemas.openxmlformats.org/drawingml/2006/main">
@@ -1293,7 +1293,7 @@
           </a:p>
           <a:p xmlns:a="http://schemas.openxmlformats.org/drawingml/2006/main">
             <a:r>
-              <a:t>Imagine un conseiller avec un catalogue devant lui. FAISS trouve les fiches utiles ; Mistral les lit et rédige. Retrieval = recherche. Augmented = on ajoute les fiches à la question. Generation = le modèle rédige. Le catalogue reste à l'extérieur du modèle.</a:t>
+              <a:t>Catalogue = corpus ; passages = chunks ; représentation du sens = embeddings ; bibliothécaire = recherche FAISS ; rédacteur = modèle de chat.</a:t>
             </a:r>
           </a:p>
           <a:p xmlns:a="http://schemas.openxmlformats.org/drawingml/2006/main">
@@ -1353,7 +1353,7 @@
           </a:p>
           <a:p xmlns:a="http://schemas.openxmlformats.org/drawingml/2006/main">
             <a:r>
-              <a:t>Cette approche dépend d'abord de la qualité du catalogue préparé.</a:t>
+              <a:t>Avant d’aider un visiteur, il faut constituer un catalogue fiable.</a:t>
             </a:r>
           </a:p>
         </p:txBody>
@@ -1438,7 +1438,7 @@
           </a:p>
           <a:p xmlns:a="http://schemas.openxmlformats.org/drawingml/2006/main">
             <a:r>
-              <a:t>Les données proviennent d'OpenAgenda à travers le jeu public exposé par Opendatasoft. Cette source est celle du lien donné dans la mission et ne demande pas de clé pour la collecte. Le script filtre Paris et la première date des événements, du 10 juillet 2025 au 10 juillet 2026. Il parcourt les résultats, nettoie les descriptions HTML, gère les champs absents et supprime les doublons par identifiant. Il produit un fichier Parquet structuré et un manifeste qui trace les paramètres et le volume. Je conserve les dates, le lieu et l'URL pour que la réponse soit vérifiable. Cette fenêtre était celle du POC construit en juillet. Pour une utilisation aujourd'hui, le corpus doit être actualisé : je ne présente pas ce catalogue figé comme un agenda à jour.</a:t>
+              <a:t>J'ai commencé par collecter les fiches du dataset public OpenAgenda indiqué par la mission, accessible via Opendatasoft. J'ai choisi Paris et une fenêtre du 10 juillet 2025 au 10 juillet 2026. La collecte parcourt les pages, retire les doublons par identifiant et nettoie les descriptions, notamment les balises HTML. Je garde les informations qui permettent de vérifier une réponse : titre, description, lieu, dates et URL. Les données sont exportées dans un fichier Parquet, un format structuré relisible par les scripts. Ce catalogue contient 7 586 événements. Comme une bibliothèque dont le catalogue n'a pas été mis à jour depuis juillet, il manque les nouvelles fiches d'octobre. Je reconnais cette limite : pour conseiller des sorties actuelles, il faut actualiser les données et vérifier les dates.</a:t>
             </a:r>
           </a:p>
           <a:p xmlns:a="http://schemas.openxmlformats.org/drawingml/2006/main">
@@ -1468,7 +1468,7 @@
           </a:p>
           <a:p xmlns:a="http://schemas.openxmlformats.org/drawingml/2006/main">
             <a:r>
-              <a:t>Une API de données donne des fiches d'événements. Le nettoyage rend leurs champs utilisables. Parquet est un format de tableau compact. Le manifeste est la fiche d'identité de la collecte : source, filtres, date et quantité. Le seed est la copie de référence livrée avec le projet.</a:t>
+              <a:t>Nettoyer le catalogue ne signifie pas inventer ce qui manque. Tu conserves les informations disponibles et les références. Le catalogue est un instantané de juillet.</a:t>
             </a:r>
           </a:p>
           <a:p xmlns:a="http://schemas.openxmlformats.org/drawingml/2006/main">
@@ -1528,7 +1528,7 @@
           </a:p>
           <a:p xmlns:a="http://schemas.openxmlformats.org/drawingml/2006/main">
             <a:r>
-              <a:t>Une fois les fiches préparées, il faut les rendre recherchables par leur sens.</a:t>
+              <a:t>Une fiche peut être longue : nous allons préparer des passages plus faciles à retrouver.</a:t>
             </a:r>
           </a:p>
         </p:txBody>
@@ -1613,7 +1613,7 @@
           </a:p>
           <a:p xmlns:a="http://schemas.openxmlformats.org/drawingml/2006/main">
             <a:r>
-              <a:t>Certaines fiches sont longues. Les indexer comme un seul bloc risquerait de diluer une information utile. J'utilise donc le découpage récursif de LangChain, configuré à 1 000 caractères avec un chevauchement maximal de 200 caractères. Le chevauchement limite la perte d'information aux frontières. Par exemple, une fiche CHIMERE contient 10 273 caractères et produit 15 passages, car le découpage tient aussi compte des séparateurs. Le modèle mistral-embed transforme chaque passage en un vecteur de 1 024 dimensions, autrement dit une liste de nombres représentant son sens. La construction se fait par lots de 50. Au total, FAISS contient 14 903 vecteurs pour les 7 586 événements. Chaque passage conserve l'identifiant de l'événement, ses dates, son lieu et son lien.</a:t>
+              <a:t>Dans un catalogue, certaines fiches sont courtes et d'autres très longues. Pour ne pas transmettre toute une longue description au rédacteur, je les découpe en passages, appelés chunks. Le réglage de départ est de 1 000 caractères, avec jusqu'à 200 caractères de chevauchement pour préserver les informations aux frontières. Le découpage cherche à respecter les séparateurs du texte. La fiche CHIMERE illustre ce point : elle produit 15 passages. Tout le catalogue produit 14 903 passages, et non 14 903 événements. Chaque passage est transformé par mistral-embed en un vecteur de 1 024 nombres. Ces nombres servent à comparer le sens ; ce ne sont pas des catégories lisibles par un humain. Je conserve aussi le lien vers la fiche, ses dates et son lieu.</a:t>
             </a:r>
           </a:p>
           <a:p xmlns:a="http://schemas.openxmlformats.org/drawingml/2006/main">
@@ -1643,7 +1643,7 @@
           </a:p>
           <a:p xmlns:a="http://schemas.openxmlformats.org/drawingml/2006/main">
             <a:r>
-              <a:t>Un chunk est un morceau de texte. Un embedding est une liste de nombres qui permet de comparer le sens des textes. FAISS est l'outil qui range ces vecteurs et retrouve les plus proches. Il ne rédige aucune phrase et ne remplace pas Mistral.</a:t>
+              <a:t>Le passage est le texte. Le vecteur est sa représentation numérique. Les métadonnées sont sa référence dans le catalogue. Ce sont trois choses différentes.</a:t>
             </a:r>
           </a:p>
           <a:p xmlns:a="http://schemas.openxmlformats.org/drawingml/2006/main">
@@ -1703,7 +1703,7 @@
           </a:p>
           <a:p xmlns:a="http://schemas.openxmlformats.org/drawingml/2006/main">
             <a:r>
-              <a:t>L'index est préparé. Voyons ce qui se passe lorsqu'un utilisateur pose une question.</a:t>
+              <a:t>Voyons comment le bibliothécaire utilise ces représentations pour une question.</a:t>
             </a:r>
           </a:p>
         </p:txBody>
@@ -1788,7 +1788,7 @@
           </a:p>
           <a:p xmlns:a="http://schemas.openxmlformats.org/drawingml/2006/main">
             <a:r>
-              <a:t>Au moment d'une question, on utilise le même modèle d'embedding que pour les documents. Cela rend leurs vecteurs comparables. FAISS sélectionne les quatre passages les plus proches : c'est le paramètre top-k. Le code assemble ensuite un contexte avec le texte et les métadonnées, puis le transmet avec la question à ministral-8b-2512. Pour la soutenance, ce modèle remplace mistral-small-latest, limité par Mistral aujourd'hui. Le prompt demande de répondre seulement à partir du contexte, de citer les informations disponibles et de ne pas inventer. La température est basse, à 0,1, pour limiter la variation ; la réponse est limitée à 700 tokens. Le JSON renvoie la réponse et les sources récupérées, regroupées par événement. Attention : quatre passages peuvent provenir du même événement. Et l'absence de seuil de pertinence signifie que le modèle doit encore décider si le contexte permet de répondre.</a:t>
+              <a:t>Quand le visiteur pose une question, mistral-embed la transforme avec le même modèle que les passages. Les vecteurs deviennent ainsi comparables. FAISS retrouve les quatre passages les plus proches : c'est le top-k fixé à quatre. Dans notre image, le bibliothécaire dépose quatre extraits sur le bureau du rédacteur. Le prompt est sa consigne : répondre en français à partir de ces extraits, citer les informations disponibles et dire qu'il ne sait pas si elles manquent. Mistral Small était le modèle initial. Aujourd'hui, il renvoyait une limite d'usage ; j'ai configuré la version ministral-8b-2512, puis vérifié la démo. L'embedding reste identique, donc le catalogue vectoriel n'a pas été reconstruit. Les scores historiques concernent toutefois Small. Le prompt aide le rédacteur, mais ne garantit pas une réponse sans erreur.</a:t>
             </a:r>
           </a:p>
           <a:p xmlns:a="http://schemas.openxmlformats.org/drawingml/2006/main">
@@ -1818,7 +1818,7 @@
           </a:p>
           <a:p xmlns:a="http://schemas.openxmlformats.org/drawingml/2006/main">
             <a:r>
-              <a:t>Les deux modèles ont deux métiers différents. mistral-embed transforme textes et questions en nombres. ministral-8b-2512 lit le contexte et produit des phrases. top-k signifie combien de passages on lui donne ; cela ne signifie pas quatre recommandations.</a:t>
+              <a:t>FAISS choisit les passages ; le modèle de chat rédige. Quatre passages ne signifient pas quatre événements. La température 0,1 et la limite de 700 tokens sont des réglages de départ, pas un optimum démontré.</a:t>
             </a:r>
           </a:p>
           <a:p xmlns:a="http://schemas.openxmlformats.org/drawingml/2006/main">
@@ -1878,7 +1878,7 @@
           </a:p>
           <a:p xmlns:a="http://schemas.openxmlformats.org/drawingml/2006/main">
             <a:r>
-              <a:t>Ces étapes sont séparées dans le code pour pouvoir les tester et les remplacer.</a:t>
+              <a:t>Cette bibliothèque fonctionne en deux temps : la préparation et le traitement d’une demande.</a:t>
             </a:r>
           </a:p>
         </p:txBody>
@@ -1963,7 +1963,7 @@
           </a:p>
           <a:p xmlns:a="http://schemas.openxmlformats.org/drawingml/2006/main">
             <a:r>
-              <a:t>L'architecture distingue la préparation des données du traitement des questions. La préparation collecte les fiches, les normalise, calcule leurs embeddings et sauvegarde l'index. Elle est faite avant l'utilisation du chatbot et appelle déjà Mistral pour les vecteurs. À chaque question, l'API appelle le service RAG, qui recharge l'index si nécessaire, recherche les passages et sollicite le modèle de chat. Le retriever et le client Mistral sont initialisés à la première question puis conservés en mémoire pour les suivantes. Le dossier scripts contient les commandes de lancement, tandis que src contient la logique métier. Cette séparation permet d'utiliser le même moteur depuis le terminal, l'API et l'évaluation. Elle évite de relancer la collecte ou l'indexation pour chaque demande.</a:t>
+              <a:t>Il faut distinguer les deux moments. Avant les questions, je prépare les rayons : collecte, nettoyage, découpage, calcul des embeddings et enregistrement de l'index FAISS. Chaque passage reste relié à sa fiche. Puis, à chaque demande, je vectorise uniquement la question, recherche les passages et appelle le rédacteur. Je ne recollecte pas tout OpenAgenda et je ne recalcule pas tous les vecteurs à chaque question. Le fichier FAISS livré contient 14 903 vecteurs ; tous les identifiants d'événements sont représentés. L'index est chargé à la première demande, puis réutilisé. Attention, les rayons sont locaux, mais mistral-embed et le rédacteur sont des services distants. Cette bibliothèque dépend donc encore d'internet.</a:t>
             </a:r>
           </a:p>
           <a:p xmlns:a="http://schemas.openxmlformats.org/drawingml/2006/main">
@@ -1993,7 +1993,7 @@
           </a:p>
           <a:p xmlns:a="http://schemas.openxmlformats.org/drawingml/2006/main">
             <a:r>
-              <a:t>La préparation construit une bibliothèque. L'usage consulte cette bibliothèque. Le service est le point central qui relie les briques. LangChain fournit les objets pour les documents, le découpage, la recherche et les messages ; il ne remplace pas le code du projet.</a:t>
+              <a:t>Construire l’index, c’est préparer les rayons. Interroger l’index, c’est chercher dedans. Docker contient le seed ; le volume conserve l’index de travail.</a:t>
             </a:r>
           </a:p>
           <a:p xmlns:a="http://schemas.openxmlformats.org/drawingml/2006/main">
@@ -2053,7 +2053,7 @@
           </a:p>
           <a:p xmlns:a="http://schemas.openxmlformats.org/drawingml/2006/main">
             <a:r>
-              <a:t>L'API donne aux équipes un contrat simple pour tester cette chaîne.</a:t>
+              <a:t>Pour que vos équipes puissent poser une question, il reste à ouvrir un guichet.</a:t>
             </a:r>
           </a:p>
         </p:txBody>
@@ -2138,7 +2138,7 @@
           </a:p>
           <a:p xmlns:a="http://schemas.openxmlformats.org/drawingml/2006/main">
             <a:r>
-              <a:t>FastAPI expose trois routes métier. Health indique que le serveur répond et montre sa configuration. Ask accepte une question et renvoie un JSON avec la réponse, les sources et le nombre de passages récupérés. Rebuild reconstruit l'index depuis le fichier Parquet ; il ne lance pas une nouvelle collecte. Swagger, sur docs, permet de lire et tester le contrat sans écrire de client. Docker embarque le code, les dépendances et le seed. Au premier démarrage, l'index et les données sont copiés dans un volume persistant. La clé Mistral est injectée par l'environnement et n'est pas versionnée. Le jeton d'administration de rebuild est optionnel et doit être configuré avant une exposition publique. Le POC reste dépendant d'internet pour vectoriser la question et générer la réponse.</a:t>
+              <a:t>FastAPI est le guichet de notre bibliothèque. Une application lui envoie une question en JSON et reçoit une réponse, des sources et le nombre de passages récupérés. La route ask fait ce travail. Health indique que le guichet répond et affiche sa configuration, mais ne vérifie pas à elle seule que le bibliothécaire et le rédacteur peuvent répondre. Rebuild reconstruit les rayons à partir du Parquet ; elle ne collecte pas de nouvelles fiches. Swagger documente ces routes. Docker rassemble le code, les dépendances et le catalogue de départ pour lancer le même service ailleurs. La clé Mistral reste côté serveur. Le jeton de reconstruction est optionnel dans le POC ; il faut sécuriser ce guichet avant de l'exposer publiquement.</a:t>
             </a:r>
           </a:p>
           <a:p xmlns:a="http://schemas.openxmlformats.org/drawingml/2006/main">
@@ -2168,7 +2168,7 @@
           </a:p>
           <a:p xmlns:a="http://schemas.openxmlformats.org/drawingml/2006/main">
             <a:r>
-              <a:t>Une API est une porte d'entrée pour d'autres logiciels. GET lit, POST envoie une action ou des données. JSON est le format des messages. Swagger est la page de documentation interactive. Docker fournit le même environnement ; le volume garde les fichiers modifiés lorsque le conteneur est recréé.</a:t>
+              <a:t>API = guichet accessible par un logiciel. JSON = format du message. Docker = environnement transportable ; il ne rend pas Mistral local.</a:t>
             </a:r>
           </a:p>
           <a:p xmlns:a="http://schemas.openxmlformats.org/drawingml/2006/main">
@@ -2228,7 +2228,7 @@
           </a:p>
           <a:p xmlns:a="http://schemas.openxmlformats.org/drawingml/2006/main">
             <a:r>
-              <a:t>Je vais maintenant montrer un cas présent dans le corpus et un cas hors périmètre.</a:t>
+              <a:t>Passons maintenant au guichet avec deux demandes concrètes.</a:t>
             </a:r>
           </a:p>
         </p:txBody>
@@ -2313,7 +2313,7 @@
           </a:p>
           <a:p xmlns:a="http://schemas.openxmlformats.org/drawingml/2006/main">
             <a:r>
-              <a:t>Je commence par montrer que l'API répond et que ses routes sont documentées. Pour le premier cas, je demande des informations sur Concert Fishers à Paris. Le résultat doit permettre de retrouver l'événement, son lieu, sa date et son URL. Il s'agit d'un exemple du corpus livré, pas d'une sortie à venir aujourd'hui. Je compare la réponse au premier événement source. Les autres sources sont les voisins récupérés et ne sont pas toutes nécessaires à cette réponse. Pour le second cas, je demande des expositions photo à Lyon. Le corpus contient Paris. Dans la répétition directe d'aujourd'hui, le modèle dit qu'il ne sait pas et n'invente pas d'exposition lyonnaise. FAISS renvoie quand même des passages : cela illustre la limite de la recherche sans seuil de pertinence.</a:t>
+              <a:t>Je montre d'abord les routes et la configuration du guichet. Dans la page de démonstration, je demande des informations sur Concert Fishers à Paris et je clique sur l'appel direct. La page transmet la question à l'API, qui recherche les passages et appelle le rédacteur. Je compare maintenant la réponse à la fiche : Concert Fishers, Le Gymnase Montparnasse, le 21 juin 2026 et l'URL OpenAgenda. Cet événement est passé ; il sert à vérifier la chaîne sur le catalogue livré. Pour la deuxième demande, je cherche des expositions photo à Lyon. Notre catalogue couvre Paris. Le modèle indique qu'il ne sait pas répondre à partir de ce corpus. Le bibliothécaire retrouve tout de même des passages voisins : ce ne sont pas des recommandations pour Lyon. Cette distinction explique pourquoi un filtre de ville serait utile.</a:t>
             </a:r>
           </a:p>
           <a:p xmlns:a="http://schemas.openxmlformats.org/drawingml/2006/main">
@@ -2343,7 +2343,7 @@
           </a:p>
           <a:p xmlns:a="http://schemas.openxmlformats.org/drawingml/2006/main">
             <a:r>
-              <a:t>Ta démo doit prouver trois choses : le contrat API existe ; la réponse utilise une vraie fiche ; le système sait reconnaître au moins un cas hors corpus. Le premier événement est ancien : annonce-le. Si Mistral est indisponible, montre les réponses enregistrées en le disant explicitement.</a:t>
+              <a:t>La page est une interface HTML ajoutée pour la soutenance. Elle appelle réellement le guichet FastAPI. Son bouton enregistré montre une répétition sauvegardée, explicitement séparée du direct.</a:t>
             </a:r>
           </a:p>
           <a:p xmlns:a="http://schemas.openxmlformats.org/drawingml/2006/main">
@@ -2403,7 +2403,7 @@
           </a:p>
           <a:p xmlns:a="http://schemas.openxmlformats.org/drawingml/2006/main">
             <a:r>
-              <a:t>La démonstration donne un exemple ; les tests et les métriques complètent cette preuve.</a:t>
+              <a:t>Deux demandes donnent des exemples. Comment vérifier plus largement la bibliothèque ?</a:t>
             </a:r>
           </a:p>
         </p:txBody>
@@ -2488,7 +2488,7 @@
           </a:p>
           <a:p xmlns:a="http://schemas.openxmlformats.org/drawingml/2006/main">
             <a:r>
-              <a:t>J'ai exécuté aujourd'hui la suite : les 76 tests passent. Ils vérifient notamment les filtres, la normalisation, la construction et le rechargement de l'index, la forme des réponses, la validation API et le calcul des métriques. Ces tests utilisent des doublures pour les services externes. Ils protègent les comportements du code, sans garantir que Mistral est accessible ni que toutes les réponses métier sont bonnes. Un deuxième niveau contient quatre questions annotées avec des réponses et des titres attendus. Les résultats enregistrés classent les quatre cas comme corrects selon les règles locales. Ces règles sont assez permissives : un titre peut être retrouvé dans les sources sans que la réponse soit parfaite. Je complète donc cette évaluation par RAGAS. L'automatisation en CI serait une prochaine étape ; elle n'est pas implémentée ici.</a:t>
+              <a:t>Pour contrôler la bibliothèque, je distingue la mécanique et la qualité des conseils. Les 76 tests locaux passent : ils vérifient notamment les filtres, le nettoyage, le découpage, l'indexation, le contrat API et les erreurs. Ils utilisent des doublures pour ne pas dépendre du fournisseur à chaque exécution. Les appels réels sont vérifiés séparément dans la démo. Le jeu fonctionnel contient quatre questions annotées, avec des titres attendus et un cas de refus. Sa règle est permissive : un titre présent dans les sources peut suffire à classer le cas comme correct, même si la réponse reste imparfaite. Quatre cas corrects ne signifient donc pas cent pour cent de fiabilité. Aucune chaîne CI/CD n'est livrée ; les scripts permettent déjà d'automatiser les vérifications.</a:t>
             </a:r>
           </a:p>
           <a:p xmlns:a="http://schemas.openxmlformats.org/drawingml/2006/main">
@@ -2518,7 +2518,7 @@
           </a:p>
           <a:p xmlns:a="http://schemas.openxmlformats.org/drawingml/2006/main">
             <a:r>
-              <a:t>Les tests de code vérifient les mécanismes. Le jeu annoté vérifie des exemples de questions. RAGAS examine la qualité du texte et du contexte. Ce sont trois niveaux de preuve différents. Une doublure simule un service externe pour tester sans internet et sans coût.</a:t>
+              <a:t>Un guichet qui répond et des rayons accessibles ne prouvent pas que le rédacteur donne toujours le bon conseil. Les tests du code et l’évaluation des réponses sont complémentaires.</a:t>
             </a:r>
           </a:p>
           <a:p xmlns:a="http://schemas.openxmlformats.org/drawingml/2006/main">
@@ -2578,7 +2578,7 @@
           </a:p>
           <a:p xmlns:a="http://schemas.openxmlformats.org/drawingml/2006/main">
             <a:r>
-              <a:t>RAGAS nous aide à distinguer une bonne recherche d'une réponse pleinement correcte.</a:t>
+              <a:t>RAGAS apporte une seconde lecture : examiner les extraits et le travail du rédacteur.</a:t>
             </a:r>
           </a:p>
         </p:txBody>
@@ -2646,7 +2646,7 @@
   </p:cSld>
   <p:clrMap bg1="lt1" tx1="dk1" bg2="lt2" tx2="dk2" accent1="accent1" accent2="accent2" accent3="accent3" accent4="accent4" accent5="accent5" accent6="accent6" hlink="hlink" folHlink="folHlink"/>
   <p:sldLayoutIdLst>
-    <p:sldLayoutId xmlns:r="http://schemas.openxmlformats.org/officeDocument/2006/relationships" id="2147483649" r:id="R658d5424f4ca4986"/>
+    <p:sldLayoutId xmlns:r="http://schemas.openxmlformats.org/officeDocument/2006/relationships" id="2147483649" r:id="Re81c86b78d954e6d"/>
   </p:sldLayoutIdLst>
   <p:txStyles>
     <p:titleStyle>
@@ -3432,7 +3432,7 @@
                 <a:ea typeface="Montserrat"/>
                 <a:cs typeface="Montserrat"/>
               </a:rPr>
-              <a:t>Un assistant culturel</a:t>
+              <a:t>Un catalogue culturel.</a:t>
             </a:r>
           </a:p>
           <a:p xmlns:a="http://schemas.openxmlformats.org/drawingml/2006/main">
@@ -3459,7 +3459,7 @@
                 <a:ea typeface="Montserrat"/>
                 <a:cs typeface="Montserrat"/>
               </a:rPr>
-              <a:t>fondé sur des</a:t>
+              <a:t>Une question.</a:t>
             </a:r>
           </a:p>
           <a:p xmlns:a="http://schemas.openxmlformats.org/drawingml/2006/main">
@@ -3486,7 +3486,7 @@
                 <a:ea typeface="Montserrat"/>
                 <a:cs typeface="Montserrat"/>
               </a:rPr>
-              <a:t>événements réels</a:t>
+              <a:t>Une réponse vérifiable.</a:t>
             </a:r>
           </a:p>
         </p:txBody>
@@ -4436,7 +4436,7 @@
                 <a:ea typeface="Montserrat"/>
                 <a:cs typeface="Montserrat"/>
               </a:rPr>
-              <a:t>Les scores RAGAS orientent les améliorations</a:t>
+              <a:t>Le lecteur contrôle les extraits et la rédaction</a:t>
             </a:r>
           </a:p>
         </p:txBody>
@@ -6379,7 +6379,7 @@
                 <a:ea typeface="Montserrat"/>
                 <a:cs typeface="Montserrat"/>
               </a:rPr>
-              <a:t>Les limites définissent le travail avant production</a:t>
+              <a:t>Un catalogue daté, une recherche imparfaite, un rédacteur externe</a:t>
             </a:r>
           </a:p>
         </p:txBody>
@@ -7618,7 +7618,7 @@
                 <a:ea typeface="Noto Sans"/>
                 <a:cs typeface="Noto Sans"/>
               </a:rPr>
-              <a:t>Corpus à actualiser ; refus à renforcer ; modèle de démo changé après une limite sur Small.</a:t>
+              <a:t>Catalogue à actualiser ; recherche à calibrer ; rédacteur à contrôler et modèle alternatif à réévaluer.</a:t>
             </a:r>
           </a:p>
         </p:txBody>
@@ -8010,7 +8010,7 @@
                 <a:ea typeface="Montserrat"/>
                 <a:cs typeface="Montserrat"/>
               </a:rPr>
-              <a:t>Un pilote mesuré</a:t>
+              <a:t>Une bibliothèque testable.</a:t>
             </a:r>
           </a:p>
           <a:p xmlns:a="http://schemas.openxmlformats.org/drawingml/2006/main">
@@ -8037,7 +8037,7 @@
                 <a:ea typeface="Montserrat"/>
                 <a:cs typeface="Montserrat"/>
               </a:rPr>
-              <a:t>est la prochaine étape</a:t>
+              <a:t>Un pilote à mesurer.</a:t>
             </a:r>
           </a:p>
         </p:txBody>
@@ -8484,7 +8484,7 @@
                 <a:ea typeface="Noto Sans"/>
                 <a:cs typeface="Noto Sans"/>
               </a:rPr>
-              <a:t>59 tests + RAGAS</a:t>
+              <a:t>76 tests + RAGAS</a:t>
             </a:r>
           </a:p>
         </p:txBody>
@@ -9033,7 +9033,7 @@
                 <a:ea typeface="Noto Sans"/>
                 <a:cs typeface="Noto Sans"/>
               </a:rPr>
-              <a:t>1. actualiser le corpus et filtrer</a:t>
+              <a:t>1. actualiser le catalogue et filtrer</a:t>
             </a:r>
           </a:p>
           <a:p xmlns:a="http://schemas.openxmlformats.org/drawingml/2006/main">
@@ -9060,7 +9060,7 @@
                 <a:ea typeface="Noto Sans"/>
                 <a:cs typeface="Noto Sans"/>
               </a:rPr>
-              <a:t>2. élargir le jeu annoté</a:t>
+              <a:t>2. contrôler les réponses sur plus de cas</a:t>
             </a:r>
           </a:p>
           <a:p xmlns:a="http://schemas.openxmlformats.org/drawingml/2006/main">
@@ -9087,7 +9087,7 @@
                 <a:ea typeface="Noto Sans"/>
                 <a:cs typeface="Noto Sans"/>
               </a:rPr>
-              <a:t>3. mesurer avant industrialisation</a:t>
+              <a:t>3. mesurer un pilote avant industrialisation</a:t>
             </a:r>
           </a:p>
         </p:txBody>
@@ -9449,7 +9449,7 @@
                 <a:ea typeface="Montserrat"/>
                 <a:cs typeface="Montserrat"/>
               </a:rPr>
-              <a:t>Le RAG relie la réponse au catalogue</a:t>
+              <a:t>Chercher dans le catalogue avant de répondre</a:t>
             </a:r>
           </a:p>
         </p:txBody>
@@ -11636,7 +11636,7 @@
                 <a:ea typeface="Montserrat"/>
                 <a:cs typeface="Montserrat"/>
               </a:rPr>
-              <a:t>Le corpus est un instantané explicite de Paris</a:t>
+              <a:t>Constituer et nettoyer le catalogue</a:t>
             </a:r>
           </a:p>
         </p:txBody>
@@ -13019,7 +13019,7 @@
                 <a:ea typeface="Noto Sans"/>
                 <a:cs typeface="Noto Sans"/>
               </a:rPr>
-              <a:t>Titre, description, date, lieu et URL conservés. Corpus figé : fraîcheur à réévaluer.</a:t>
+              <a:t>Des fiches nettoyées et des références conservées. Catalogue figé : mise à jour nécessaire.</a:t>
             </a:r>
           </a:p>
         </p:txBody>
@@ -13408,7 +13408,7 @@
                 <a:ea typeface="Montserrat"/>
                 <a:cs typeface="Montserrat"/>
               </a:rPr>
-              <a:t>Les descriptions deviennent des passages recherchables</a:t>
+              <a:t>Découper les fiches, puis comparer leur sens</a:t>
             </a:r>
           </a:p>
         </p:txBody>
@@ -15206,7 +15206,7 @@
                 <a:ea typeface="Noto Sans"/>
                 <a:cs typeface="Noto Sans"/>
               </a:rPr>
-              <a:t>CHIMERE : 15 passages. Tout le corpus : 14 903 vecteurs. Métadonnées conservées.</a:t>
+              <a:t>Une fiche CHIMERE : 15 passages. Tout le catalogue : 14 903 vecteurs.</a:t>
             </a:r>
           </a:p>
         </p:txBody>
@@ -15595,7 +15595,7 @@
                 <a:ea typeface="Montserrat"/>
                 <a:cs typeface="Montserrat"/>
               </a:rPr>
-              <a:t>Mistral reçoit la question et quatre passages</a:t>
+              <a:t>Le bibliothécaire cherche ; le rédacteur répond</a:t>
             </a:r>
           </a:p>
         </p:txBody>
@@ -15820,7 +15820,7 @@
                 <a:ea typeface="Montserrat"/>
                 <a:cs typeface="Montserrat"/>
               </a:rPr>
-              <a:t>Le prompt demande une réponse en français fondée sur le contexte, et un refus si les passages ne permettent pas de répondre. Il réduit le risque sans le supprimer.</a:t>
+              <a:t>Le bibliothécaire apporte quatre passages ; le rédacteur reçoit les consignes et les sources. Le prompt réduit le risque sans garantir une réponse parfaite.</a:t>
             </a:r>
           </a:p>
         </p:txBody>
@@ -16241,7 +16241,7 @@
           <p:nvPr/>
         </p:nvPicPr>
         <p:blipFill>
-          <a:blip xmlns:r="http://schemas.openxmlformats.org/officeDocument/2006/relationships" xmlns:a="http://schemas.openxmlformats.org/drawingml/2006/main" r:embed="R58bece4b608f4c4c"/>
+          <a:blip xmlns:r="http://schemas.openxmlformats.org/officeDocument/2006/relationships" xmlns:a="http://schemas.openxmlformats.org/drawingml/2006/main" r:embed="Re3e57c5d73bb493b"/>
           <a:stretch xmlns:a="http://schemas.openxmlformats.org/drawingml/2006/main"/>
         </p:blipFill>
         <p:spPr>
@@ -16316,7 +16316,7 @@
                 <a:latin typeface="Montserrat"/>
                 <a:ea typeface="Montserrat"/>
                 <a:cs typeface="Montserrat"/>
-                <a:hlinkClick xmlns:r="http://schemas.openxmlformats.org/officeDocument/2006/relationships" r:id="R0d68c91a4a2f4fbe"/>
+                <a:hlinkClick xmlns:r="http://schemas.openxmlformats.org/officeDocument/2006/relationships" r:id="Re930750818e24dd1"/>
               </a:rPr>
               <a:t>TEMPÉRATURE 0,1</a:t>
             </a:r>
@@ -16385,7 +16385,7 @@
                 <a:latin typeface="Montserrat"/>
                 <a:ea typeface="Montserrat"/>
                 <a:cs typeface="Montserrat"/>
-                <a:hlinkClick xmlns:r="http://schemas.openxmlformats.org/officeDocument/2006/relationships" r:id="Rcfdfabe040e647bb"/>
+                <a:hlinkClick xmlns:r="http://schemas.openxmlformats.org/officeDocument/2006/relationships" r:id="R5c7a4c9372bc411f"/>
               </a:rPr>
               <a:t>SOURCES DISTINCTES</a:t>
             </a:r>
@@ -16835,7 +16835,7 @@
                 <a:ea typeface="Montserrat"/>
                 <a:cs typeface="Montserrat"/>
               </a:rPr>
-              <a:t>La préparation de l’index précède les questions</a:t>
+              <a:t>Préparer les rayons une fois, chercher à chaque demande</a:t>
             </a:r>
           </a:p>
         </p:txBody>
@@ -18513,7 +18513,7 @@
                 <a:ea typeface="Noto Sans"/>
                 <a:cs typeface="Noto Sans"/>
               </a:rPr>
-              <a:t>Préparation : données → index. À chaque question : recherche → réponse. Mistral est distant.</a:t>
+              <a:t>Avant : préparer les rayons. À chaque demande : chercher puis rédiger. Mistral reste distant.</a:t>
             </a:r>
           </a:p>
         </p:txBody>
@@ -18902,7 +18902,7 @@
                 <a:ea typeface="Montserrat"/>
                 <a:cs typeface="Montserrat"/>
               </a:rPr>
-              <a:t>L’API rend le POC accessible aux équipes</a:t>
+              <a:t>Un guichet pour les équipes produit</a:t>
             </a:r>
           </a:p>
         </p:txBody>
@@ -19548,7 +19548,7 @@
           <p:nvPr/>
         </p:nvPicPr>
         <p:blipFill>
-          <a:blip xmlns:r="http://schemas.openxmlformats.org/officeDocument/2006/relationships" xmlns:a="http://schemas.openxmlformats.org/drawingml/2006/main" r:embed="R0b1b0e14e9104d13"/>
+          <a:blip xmlns:r="http://schemas.openxmlformats.org/officeDocument/2006/relationships" xmlns:a="http://schemas.openxmlformats.org/drawingml/2006/main" r:embed="R3b9757df841a455b"/>
           <a:srcRect xmlns:a="http://schemas.openxmlformats.org/drawingml/2006/main" l="5000" t="0" r="5000" b="0"/>
           <a:stretch xmlns:a="http://schemas.openxmlformats.org/drawingml/2006/main">
             <a:fillRect l="0" t="0" r="0" b="0"/>
@@ -19626,7 +19626,7 @@
                 <a:latin typeface="Montserrat"/>
                 <a:ea typeface="Montserrat"/>
                 <a:cs typeface="Montserrat"/>
-                <a:hlinkClick xmlns:r="http://schemas.openxmlformats.org/officeDocument/2006/relationships" r:id="Rf321966d5c544d76"/>
+                <a:hlinkClick xmlns:r="http://schemas.openxmlformats.org/officeDocument/2006/relationships" r:id="R5cf0a30796314bb0"/>
               </a:rPr>
               <a:t>DOCKER COMPOSE</a:t>
             </a:r>
@@ -19695,7 +19695,7 @@
                 <a:latin typeface="Montserrat"/>
                 <a:ea typeface="Montserrat"/>
                 <a:cs typeface="Montserrat"/>
-                <a:hlinkClick xmlns:r="http://schemas.openxmlformats.org/officeDocument/2006/relationships" r:id="Ra8253bb7978e4b6e"/>
+                <a:hlinkClick xmlns:r="http://schemas.openxmlformats.org/officeDocument/2006/relationships" r:id="Rfeb706730eea4db7"/>
               </a:rPr>
               <a:t>SWAGGER /docs</a:t>
             </a:r>
@@ -19756,7 +19756,7 @@
                 <a:ea typeface="Noto Sans"/>
                 <a:cs typeface="Noto Sans"/>
               </a:rPr>
-              <a:t>Retriever chargé à la première question, puis réutilisé. /health ne teste pas Mistral.</a:t>
+              <a:t>FastAPI est le guichet. /health montre sa configuration ; /ask exécute la chaîne complète.</a:t>
             </a:r>
           </a:p>
         </p:txBody>
@@ -20145,7 +20145,7 @@
                 <a:ea typeface="Montserrat"/>
                 <a:cs typeface="Montserrat"/>
               </a:rPr>
-              <a:t>La démonstration montre un résultat et une limite</a:t>
+              <a:t>Au guichet : une fiche trouvée, une demande hors catalogue</a:t>
             </a:r>
           </a:p>
         </p:txBody>
@@ -21220,7 +21220,7 @@
                 <a:latin typeface="Montserrat"/>
                 <a:ea typeface="Montserrat"/>
                 <a:cs typeface="Montserrat"/>
-                <a:hlinkClick xmlns:r="http://schemas.openxmlformats.org/officeDocument/2006/relationships" r:id="Rade46dc666c6449b"/>
+                <a:hlinkClick xmlns:r="http://schemas.openxmlformats.org/officeDocument/2006/relationships" r:id="R3a4064d7bc404002"/>
               </a:rPr>
               <a:t>API</a:t>
             </a:r>
@@ -21289,7 +21289,7 @@
                 <a:latin typeface="Montserrat"/>
                 <a:ea typeface="Montserrat"/>
                 <a:cs typeface="Montserrat"/>
-                <a:hlinkClick xmlns:r="http://schemas.openxmlformats.org/officeDocument/2006/relationships" r:id="R84840a9d63364149"/>
+                <a:hlinkClick xmlns:r="http://schemas.openxmlformats.org/officeDocument/2006/relationships" r:id="R794867ef118f4cf9"/>
               </a:rPr>
               <a:t>SOURCES</a:t>
             </a:r>
@@ -21358,7 +21358,7 @@
                 <a:latin typeface="Montserrat"/>
                 <a:ea typeface="Montserrat"/>
                 <a:cs typeface="Montserrat"/>
-                <a:hlinkClick xmlns:r="http://schemas.openxmlformats.org/officeDocument/2006/relationships" r:id="R898837321585492a"/>
+                <a:hlinkClick xmlns:r="http://schemas.openxmlformats.org/officeDocument/2006/relationships" r:id="Rdc098d5f9821481a"/>
               </a:rPr>
               <a:t>PRUDENCE</a:t>
             </a:r>
@@ -21427,7 +21427,7 @@
                 <a:latin typeface="Montserrat"/>
                 <a:ea typeface="Montserrat"/>
                 <a:cs typeface="Montserrat"/>
-                <a:hlinkClick xmlns:r="http://schemas.openxmlformats.org/officeDocument/2006/relationships" r:id="R1657cbd2ebce444f"/>
+                <a:hlinkClick xmlns:r="http://schemas.openxmlformats.org/officeDocument/2006/relationships" r:id="R629276bdb7c94025"/>
               </a:rPr>
               <a:t>DOCKER</a:t>
             </a:r>
@@ -21588,7 +21588,7 @@
                 <a:ea typeface="Noto Sans"/>
                 <a:cs typeface="Noto Sans"/>
               </a:rPr>
-              <a:t>Secours : réponses du jour explicitement enregistrées. Ne pas les présenter comme du live.</a:t>
+              <a:t>Le guichet reçoit deux demandes : une fiche trouvée, puis un refus hors catalogue. Secours enregistré explicite.</a:t>
             </a:r>
           </a:p>
         </p:txBody>
@@ -21828,7 +21828,7 @@
                 <a:ea typeface="Montserrat"/>
                 <a:cs typeface="Montserrat"/>
               </a:rPr>
-              <a:t>Les tests du code et la qualité se complètent</a:t>
+              <a:t>Tester le mécanisme et examiner les réponses</a:t>
             </a:r>
           </a:p>
         </p:txBody>
@@ -22979,7 +22979,7 @@
                 <a:ea typeface="Montserrat"/>
                 <a:cs typeface="Montserrat"/>
               </a:rPr>
-              <a:t>59</a:t>
+              <a:t>76</a:t>
             </a:r>
           </a:p>
         </p:txBody>
@@ -23259,7 +23259,7 @@
                 <a:ea typeface="Noto Sans"/>
                 <a:cs typeface="Noto Sans"/>
               </a:rPr>
-              <a:t>76 tests locaux ; 4 cas fonctionnels aux règles permissives ; CI/CD proposée, non implémentée.</a:t>
+              <a:t>76 tests vérifient les rayons et le guichet ; quatre questions annotées examinent les réponses. Pas de CI/CD.</a:t>
             </a:r>
           </a:p>
         </p:txBody>

</xml_diff>

<commit_message>
docs: présenter depuis les slides et la démo uniquement
</commit_message>
<xml_diff>
--- a/outputs/openagenda-rag-soutenance.pptx
+++ b/outputs/openagenda-rag-soutenance.pptx
@@ -2,24 +2,24 @@
 <file path=ppt/presentation.xml><?xml version="1.0" encoding="utf-8"?>
 <p:presentation xmlns:p="http://schemas.openxmlformats.org/presentationml/2006/main">
   <p:sldMasterIdLst>
-    <p:sldMasterId xmlns:r="http://schemas.openxmlformats.org/officeDocument/2006/relationships" id="2147483648" r:id="Rc4ca9f147d284d3e"/>
+    <p:sldMasterId xmlns:r="http://schemas.openxmlformats.org/officeDocument/2006/relationships" id="2147483648" r:id="R15d06b6de8b54cea"/>
   </p:sldMasterIdLst>
   <p:notesMasterIdLst>
-    <p:notesMasterId xmlns:r="http://schemas.openxmlformats.org/officeDocument/2006/relationships" r:id="R640021b1d5804199"/>
+    <p:notesMasterId xmlns:r="http://schemas.openxmlformats.org/officeDocument/2006/relationships" r:id="R0721d70878a340d1"/>
   </p:notesMasterIdLst>
   <p:sldIdLst>
-    <p:sldId xmlns:r="http://schemas.openxmlformats.org/officeDocument/2006/relationships" id="256" r:id="R5677905291ee4aa2"/>
-    <p:sldId xmlns:r="http://schemas.openxmlformats.org/officeDocument/2006/relationships" id="257" r:id="R8d039abab63e462c"/>
-    <p:sldId xmlns:r="http://schemas.openxmlformats.org/officeDocument/2006/relationships" id="258" r:id="R4edff52d71024b79"/>
-    <p:sldId xmlns:r="http://schemas.openxmlformats.org/officeDocument/2006/relationships" id="259" r:id="R7fe9351b2b894f60"/>
-    <p:sldId xmlns:r="http://schemas.openxmlformats.org/officeDocument/2006/relationships" id="260" r:id="R7b6285a699d4494d"/>
-    <p:sldId xmlns:r="http://schemas.openxmlformats.org/officeDocument/2006/relationships" id="261" r:id="R8ed9209ba0db47d4"/>
-    <p:sldId xmlns:r="http://schemas.openxmlformats.org/officeDocument/2006/relationships" id="262" r:id="R568fb63f979d4a81"/>
-    <p:sldId xmlns:r="http://schemas.openxmlformats.org/officeDocument/2006/relationships" id="263" r:id="Rb441118189574bef"/>
-    <p:sldId xmlns:r="http://schemas.openxmlformats.org/officeDocument/2006/relationships" id="264" r:id="R008e9bc478ac4d1e"/>
-    <p:sldId xmlns:r="http://schemas.openxmlformats.org/officeDocument/2006/relationships" id="265" r:id="Rc0d455ccc59c468c"/>
-    <p:sldId xmlns:r="http://schemas.openxmlformats.org/officeDocument/2006/relationships" id="266" r:id="Ra1d695ccb8f048ff"/>
-    <p:sldId xmlns:r="http://schemas.openxmlformats.org/officeDocument/2006/relationships" id="267" r:id="R50b5c12ea071479b"/>
+    <p:sldId xmlns:r="http://schemas.openxmlformats.org/officeDocument/2006/relationships" id="256" r:id="Rf6ef1ff01c5a47fb"/>
+    <p:sldId xmlns:r="http://schemas.openxmlformats.org/officeDocument/2006/relationships" id="257" r:id="R48233b751c5747d9"/>
+    <p:sldId xmlns:r="http://schemas.openxmlformats.org/officeDocument/2006/relationships" id="258" r:id="R1ff1b3d5aa654bea"/>
+    <p:sldId xmlns:r="http://schemas.openxmlformats.org/officeDocument/2006/relationships" id="259" r:id="R32974fc357414e3a"/>
+    <p:sldId xmlns:r="http://schemas.openxmlformats.org/officeDocument/2006/relationships" id="260" r:id="R940fb439b5b84d9e"/>
+    <p:sldId xmlns:r="http://schemas.openxmlformats.org/officeDocument/2006/relationships" id="261" r:id="R10fdc0a9fffe4bf8"/>
+    <p:sldId xmlns:r="http://schemas.openxmlformats.org/officeDocument/2006/relationships" id="262" r:id="R047fd4b028db413c"/>
+    <p:sldId xmlns:r="http://schemas.openxmlformats.org/officeDocument/2006/relationships" id="263" r:id="R79b790e1b1ca4e18"/>
+    <p:sldId xmlns:r="http://schemas.openxmlformats.org/officeDocument/2006/relationships" id="264" r:id="Rf32bb63e20e041a6"/>
+    <p:sldId xmlns:r="http://schemas.openxmlformats.org/officeDocument/2006/relationships" id="265" r:id="R37e9e3c781d54304"/>
+    <p:sldId xmlns:r="http://schemas.openxmlformats.org/officeDocument/2006/relationships" id="266" r:id="R1c21708102a8414e"/>
+    <p:sldId xmlns:r="http://schemas.openxmlformats.org/officeDocument/2006/relationships" id="267" r:id="R716ec21748794453"/>
   </p:sldIdLst>
   <p:sldSz cx="12192000" cy="6858000"/>
   <p:notesSz cx="6858000" cy="9144000"/>
@@ -753,7 +753,7 @@
           </a:p>
           <a:p xmlns:a="http://schemas.openxmlformats.org/drawingml/2006/main">
             <a:r>
-              <a:t>Lis les quatre scores avec leur sens, puis donne la limite du petit échantillon. En discussion, ouvre les exemples RAGAS du rapport.</a:t>
+              <a:t>Reste sur les quatre scores : explique leur sens, l'exemple de correction faible et les limites du petit échantillon.</a:t>
             </a:r>
           </a:p>
           <a:p xmlns:a="http://schemas.openxmlformats.org/drawingml/2006/main">
@@ -1088,7 +1088,7 @@
           </a:p>
           <a:p xmlns:a="http://schemas.openxmlformats.org/drawingml/2006/main">
             <a:r>
-              <a:t>Pour conclure, le POC livre notre bibliothèque : un catalogue réel, des passages indexés, une recherche par proximité de sens, un rédacteur guidé par les sources et un guichet API accessible avec Docker. Je propose d'abord d'actualiser le catalogue et d'ajouter les contraintes de ville et de date. Ensuite, d'élargir les références humaines et de comparer les réglages ainsi que les modèles. Enfin, un pilote doit mesurer l'utilité des réponses, les refus corrects, les clics vers les sources, la latence et le coût. Je vous montre brièvement le rapport et le dépôt : scripts permet de relancer les étapes, src contient le moteur et le guichet, tests les contrôles, et seed-data le catalogue de référence et son index. La solution est examinable et testable ; sa qualité à plus grande échelle reste à mesurer. Je suis prêt à répondre à vos questions.</a:t>
+              <a:t>Pour conclure, reprenons le trajet du visiteur dans notre bibliothèque. Il pose une question ; le guichet la reçoit ; sa représentation numérique permet au bibliothécaire de retrouver les passages proches ; le rédacteur les utilise pour formuler une réponse, accompagnée des fiches à vérifier. Le POC réalise ce parcours avec un catalogue réel, une recherche locale et des modèles existants. La démonstration a montré ce qui fonctionne, mais aussi pourquoi une source retrouvée n'est pas toujours adaptée à la demande. Pour aller plus loin, je propose trois priorités. D'abord, actualiser le catalogue et appliquer les contraintes de ville et de date. Ensuite, élargir les références humaines pour comparer les réglages et les modèles sur davantage de situations, y compris les demandes sans réponse. Enfin, mesurer un pilote avec les équipes : utilité des réponses, refus corrects, clics vers les sources, latence et coût. Les tests vérifient la mécanique ; l'évaluation et les utilisateurs doivent vérifier son utilité. La bibliothèque est testable, et sa qualité à grande échelle reste à mesurer. Je suis prêt à répondre à vos questions.</a:t>
             </a:r>
           </a:p>
           <a:p xmlns:a="http://schemas.openxmlformats.org/drawingml/2006/main">
@@ -1103,7 +1103,7 @@
           </a:p>
           <a:p xmlns:a="http://schemas.openxmlformats.org/drawingml/2006/main">
             <a:r>
-              <a:t>30 s de conclusion ; 20 s rapport (architecture, évaluation, limites) ; 25 s dépôt (scripts/, src/, tests/, seed-data/). Retourne ensuite au deck. Tous les liens sont dans le guide.</a:t>
+              <a:t>Reste sur la conclusion pendant 75 s : rappelle le parcours de la bibliothèque, relie les trois améliorations aux limites, puis ouvre la discussion. Aucun changement vers GitHub, le code ou le rapport n'est prévu.</a:t>
             </a:r>
           </a:p>
           <a:p xmlns:a="http://schemas.openxmlformats.org/drawingml/2006/main">
@@ -1148,7 +1148,7 @@
           </a:p>
           <a:p xmlns:a="http://schemas.openxmlformats.org/drawingml/2006/main">
             <a:r>
-              <a:t>Ne consacre pas plusieurs minutes à parcourir le dépôt. La présentation doit rester entre 10 et 20 minutes, cible 15.</a:t>
+              <a:t>Garde la conclusion sur le support. Ne promets ni une qualité parfaite ni un service prêt pour la production. Le rapport et le dépôt sont disponibles si le jury les demande ; leur visite n'est pas intégrée à ton récit.</a:t>
             </a:r>
           </a:p>
           <a:p xmlns:a="http://schemas.openxmlformats.org/drawingml/2006/main">
@@ -1453,7 +1453,7 @@
           </a:p>
           <a:p xmlns:a="http://schemas.openxmlformats.org/drawingml/2006/main">
             <a:r>
-              <a:t>Explique la fenêtre telle qu'elle est. Si on te demande le fichier, ouvre le manifeste de collecte, pas le JSON brut entier.</a:t>
+              <a:t>Reste sur la diapositive : montre Paris, la période du catalogue et les trois opérations de nettoyage.</a:t>
             </a:r>
           </a:p>
           <a:p xmlns:a="http://schemas.openxmlformats.org/drawingml/2006/main">
@@ -1803,7 +1803,7 @@
           </a:p>
           <a:p xmlns:a="http://schemas.openxmlformats.org/drawingml/2006/main">
             <a:r>
-              <a:t>Pointe la séparation embedding/chat et le texte du prompt. Si demandé, ouvre SYSTEM_PROMPT dans rag.py.</a:t>
+              <a:t>Pointe la séparation embedding/chat et explique les consignes du rédacteur sur le support.</a:t>
             </a:r>
           </a:p>
           <a:p xmlns:a="http://schemas.openxmlformats.org/drawingml/2006/main">
@@ -1978,7 +1978,7 @@
           </a:p>
           <a:p xmlns:a="http://schemas.openxmlformats.org/drawingml/2006/main">
             <a:r>
-              <a:t>Si Jérémy demande le code, montre service.py puis rag.py. Évite de naviguer entre toutes les fonctions.</a:t>
+              <a:t>Pointe les deux moments sur le support : préparer les rayons une fois ; rechercher et répondre à chaque demande.</a:t>
             </a:r>
           </a:p>
           <a:p xmlns:a="http://schemas.openxmlformats.org/drawingml/2006/main">
@@ -2153,7 +2153,7 @@
           </a:p>
           <a:p xmlns:a="http://schemas.openxmlformats.org/drawingml/2006/main">
             <a:r>
-              <a:t>Pendant la démo, ouvre Swagger et montre les routes ; garde /rebuild fermé. Tu peux cliquer le lien Démo de la slide suivante.</a:t>
+              <a:t>Reste sur le schéma du guichet API. Explique les routes sans ouvrir Swagger ; la démonstration se fait dans la page dédiée à la slide suivante.</a:t>
             </a:r>
           </a:p>
           <a:p xmlns:a="http://schemas.openxmlformats.org/drawingml/2006/main">
@@ -2313,7 +2313,7 @@
           </a:p>
           <a:p xmlns:a="http://schemas.openxmlformats.org/drawingml/2006/main">
             <a:r>
-              <a:t>Je montre d'abord les routes et la configuration du guichet. Dans la page de démonstration, je demande des informations sur Concert Fishers à Paris et je clique sur l'appel direct. La page transmet la question à l'API, qui recherche les passages et appelle le rédacteur. Je compare maintenant la réponse à la fiche : Concert Fishers, Le Gymnase Montparnasse, le 21 juin 2026 et l'URL OpenAgenda. Cet événement est passé ; il sert à vérifier la chaîne sur le catalogue livré. Pour la deuxième demande, je cherche des expositions photo à Lyon. Notre catalogue couvre Paris. Le modèle indique qu'il ne sait pas répondre à partir de ce corpus. Le bibliothécaire retrouve tout de même des passages voisins : ce ne sont pas des recommandations pour Lyon. Cette distinction explique pourquoi un filtre de ville serait utile.</a:t>
+              <a:t>Je reste dans la page de démonstration et je vérifie d'abord l'état du guichet avec le bouton health. Ce contrôle vérifie la configuration du serveur ; l'appel suivant montrera si toute la chaîne répond. Dans la page de démonstration, je demande des informations sur Concert Fishers à Paris et je clique sur l'appel direct. La page transmet la question à l'API, qui recherche les passages et appelle le rédacteur. Je compare maintenant la réponse à la fiche : Concert Fishers, Le Gymnase Montparnasse, le 21 juin 2026 et l'URL OpenAgenda. Cet événement est passé ; il sert à vérifier la chaîne sur le catalogue livré. Pour la deuxième demande, je cherche des expositions photo à Lyon. Notre catalogue couvre Paris. Le modèle indique qu'il ne sait pas répondre à partir de ce corpus. Le bibliothécaire retrouve tout de même des passages voisins : ce ne sont pas des recommandations pour Lyon. Cette distinction explique pourquoi un filtre de ville serait utile.</a:t>
             </a:r>
           </a:p>
           <a:p xmlns:a="http://schemas.openxmlformats.org/drawingml/2006/main">
@@ -2328,7 +2328,7 @@
           </a:p>
           <a:p xmlns:a="http://schemas.openxmlformats.org/drawingml/2006/main">
             <a:r>
-              <a:t>140 s au total : 20 s health/Swagger ; 50 s cas nominal ; 40 s Lyon ; 30 s explication et retour au deck. Une tentative live maximum en cas de quota, puis enregistrement. Mode secours disponible hors réseau.</a:t>
+              <a:t>140 s au total : 20 s bouton health dans la page de démo ; 50 s cas nominal ; 40 s Lyon ; 30 s explication et retour au diaporama. Une tentative live maximum en cas de quota, puis enregistrement annoncé.</a:t>
             </a:r>
           </a:p>
           <a:p xmlns:a="http://schemas.openxmlformats.org/drawingml/2006/main">
@@ -2503,7 +2503,7 @@
           </a:p>
           <a:p xmlns:a="http://schemas.openxmlformats.org/drawingml/2006/main">
             <a:r>
-              <a:t>Annonce le résultat des tests, puis explique ce qu'ils couvrent. Montre le petit jeu CSV si demandé.</a:t>
+              <a:t>Reste sur la diapositive : annonce les 76 tests et explique la différence avec les quatre questions annotées.</a:t>
             </a:r>
           </a:p>
           <a:p xmlns:a="http://schemas.openxmlformats.org/drawingml/2006/main">
@@ -2646,7 +2646,7 @@
   </p:cSld>
   <p:clrMap bg1="lt1" tx1="dk1" bg2="lt2" tx2="dk2" accent1="accent1" accent2="accent2" accent3="accent3" accent4="accent4" accent5="accent5" accent6="accent6" hlink="hlink" folHlink="folHlink"/>
   <p:sldLayoutIdLst>
-    <p:sldLayoutId xmlns:r="http://schemas.openxmlformats.org/officeDocument/2006/relationships" id="2147483649" r:id="Re81c86b78d954e6d"/>
+    <p:sldLayoutId xmlns:r="http://schemas.openxmlformats.org/officeDocument/2006/relationships" id="2147483649" r:id="R589089a4fdf4437c"/>
   </p:sldLayoutIdLst>
   <p:txStyles>
     <p:titleStyle>
@@ -9209,7 +9209,7 @@
                 <a:ea typeface="Noto Sans"/>
                 <a:cs typeface="Noto Sans"/>
               </a:rPr>
-              <a:t>Rapport, dépôt, scripts et résultats : preuves consultables pour la discussion technique</a:t>
+              <a:t>Catalogue réel, recherche de passages, réponses sourcées : un parcours testable</a:t>
             </a:r>
           </a:p>
         </p:txBody>
@@ -16241,7 +16241,7 @@
           <p:nvPr/>
         </p:nvPicPr>
         <p:blipFill>
-          <a:blip xmlns:r="http://schemas.openxmlformats.org/officeDocument/2006/relationships" xmlns:a="http://schemas.openxmlformats.org/drawingml/2006/main" r:embed="Re3e57c5d73bb493b"/>
+          <a:blip xmlns:r="http://schemas.openxmlformats.org/officeDocument/2006/relationships" xmlns:a="http://schemas.openxmlformats.org/drawingml/2006/main" r:embed="Rf86fc8a094d540b5"/>
           <a:stretch xmlns:a="http://schemas.openxmlformats.org/drawingml/2006/main"/>
         </p:blipFill>
         <p:spPr>
@@ -16316,7 +16316,7 @@
                 <a:latin typeface="Montserrat"/>
                 <a:ea typeface="Montserrat"/>
                 <a:cs typeface="Montserrat"/>
-                <a:hlinkClick xmlns:r="http://schemas.openxmlformats.org/officeDocument/2006/relationships" r:id="Re930750818e24dd1"/>
+                <a:hlinkClick xmlns:r="http://schemas.openxmlformats.org/officeDocument/2006/relationships" r:id="Rb56ee87caaee4880"/>
               </a:rPr>
               <a:t>TEMPÉRATURE 0,1</a:t>
             </a:r>
@@ -16385,7 +16385,7 @@
                 <a:latin typeface="Montserrat"/>
                 <a:ea typeface="Montserrat"/>
                 <a:cs typeface="Montserrat"/>
-                <a:hlinkClick xmlns:r="http://schemas.openxmlformats.org/officeDocument/2006/relationships" r:id="R5c7a4c9372bc411f"/>
+                <a:hlinkClick xmlns:r="http://schemas.openxmlformats.org/officeDocument/2006/relationships" r:id="R9a99f7efdc18408e"/>
               </a:rPr>
               <a:t>SOURCES DISTINCTES</a:t>
             </a:r>
@@ -19548,7 +19548,7 @@
           <p:nvPr/>
         </p:nvPicPr>
         <p:blipFill>
-          <a:blip xmlns:r="http://schemas.openxmlformats.org/officeDocument/2006/relationships" xmlns:a="http://schemas.openxmlformats.org/drawingml/2006/main" r:embed="R3b9757df841a455b"/>
+          <a:blip xmlns:r="http://schemas.openxmlformats.org/officeDocument/2006/relationships" xmlns:a="http://schemas.openxmlformats.org/drawingml/2006/main" r:embed="R0693933633b7436a"/>
           <a:srcRect xmlns:a="http://schemas.openxmlformats.org/drawingml/2006/main" l="5000" t="0" r="5000" b="0"/>
           <a:stretch xmlns:a="http://schemas.openxmlformats.org/drawingml/2006/main">
             <a:fillRect l="0" t="0" r="0" b="0"/>
@@ -19626,7 +19626,7 @@
                 <a:latin typeface="Montserrat"/>
                 <a:ea typeface="Montserrat"/>
                 <a:cs typeface="Montserrat"/>
-                <a:hlinkClick xmlns:r="http://schemas.openxmlformats.org/officeDocument/2006/relationships" r:id="R5cf0a30796314bb0"/>
+                <a:hlinkClick xmlns:r="http://schemas.openxmlformats.org/officeDocument/2006/relationships" r:id="Rc69bdf81a5164a9e"/>
               </a:rPr>
               <a:t>DOCKER COMPOSE</a:t>
             </a:r>
@@ -19695,7 +19695,7 @@
                 <a:latin typeface="Montserrat"/>
                 <a:ea typeface="Montserrat"/>
                 <a:cs typeface="Montserrat"/>
-                <a:hlinkClick xmlns:r="http://schemas.openxmlformats.org/officeDocument/2006/relationships" r:id="Rfeb706730eea4db7"/>
+                <a:hlinkClick xmlns:r="http://schemas.openxmlformats.org/officeDocument/2006/relationships" r:id="Rf30ebd089d904418"/>
               </a:rPr>
               <a:t>SWAGGER /docs</a:t>
             </a:r>
@@ -21220,7 +21220,7 @@
                 <a:latin typeface="Montserrat"/>
                 <a:ea typeface="Montserrat"/>
                 <a:cs typeface="Montserrat"/>
-                <a:hlinkClick xmlns:r="http://schemas.openxmlformats.org/officeDocument/2006/relationships" r:id="R3a4064d7bc404002"/>
+                <a:hlinkClick xmlns:r="http://schemas.openxmlformats.org/officeDocument/2006/relationships" r:id="Rc6b641eeb1124829"/>
               </a:rPr>
               <a:t>API</a:t>
             </a:r>
@@ -21289,7 +21289,7 @@
                 <a:latin typeface="Montserrat"/>
                 <a:ea typeface="Montserrat"/>
                 <a:cs typeface="Montserrat"/>
-                <a:hlinkClick xmlns:r="http://schemas.openxmlformats.org/officeDocument/2006/relationships" r:id="R794867ef118f4cf9"/>
+                <a:hlinkClick xmlns:r="http://schemas.openxmlformats.org/officeDocument/2006/relationships" r:id="R97be7d0f9a264735"/>
               </a:rPr>
               <a:t>SOURCES</a:t>
             </a:r>
@@ -21358,7 +21358,7 @@
                 <a:latin typeface="Montserrat"/>
                 <a:ea typeface="Montserrat"/>
                 <a:cs typeface="Montserrat"/>
-                <a:hlinkClick xmlns:r="http://schemas.openxmlformats.org/officeDocument/2006/relationships" r:id="Rdc098d5f9821481a"/>
+                <a:hlinkClick xmlns:r="http://schemas.openxmlformats.org/officeDocument/2006/relationships" r:id="R8b983d23e2244e94"/>
               </a:rPr>
               <a:t>PRUDENCE</a:t>
             </a:r>
@@ -21427,7 +21427,7 @@
                 <a:latin typeface="Montserrat"/>
                 <a:ea typeface="Montserrat"/>
                 <a:cs typeface="Montserrat"/>
-                <a:hlinkClick xmlns:r="http://schemas.openxmlformats.org/officeDocument/2006/relationships" r:id="R629276bdb7c94025"/>
+                <a:hlinkClick xmlns:r="http://schemas.openxmlformats.org/officeDocument/2006/relationships" r:id="R55d27ccfb6fd4c08"/>
               </a:rPr>
               <a:t>DOCKER</a:t>
             </a:r>

</xml_diff>